<commit_message>
Aplica cambios de prioridad con base en la investigación de comercio exterior
- 80/20 OEM: sale RMC de México (ropa interior, sin serigrafía visible) y entra
  Industrias Manufactureras MYR (Irapuato; adidas y Puma)
- Grupo Martex y MYR pasan a prioridad A
- Latinoamérica: bajas de Hanes Ink Honduras, Palm y Everfit (cerradas o en
  liquidación); Southern Apparel, Gildan RD y CMT del Sur bajan a B
- 8 cuentas foco en Latinoamérica: Techno Screen, ACSA Colors, Cygnus, grupo
  Willbes (TCPL, Willbes Haitian, Willbes Dominicana), Topy Top y Nettalco
- Excel de prospectos: hoja Comercio exterior y columnas Cuenta foco / Notas
- Estudio de mercado: cifras de Latinoamérica calculadas desde los datos
- Propuesta, presentaciones, mapas y plan de marketing regenerados

Co-Authored-By: Claude Opus 5.5 <noreply@anthropic.com>
Claude-Session: https://claude.ai/code/session_012axCVDM5kAgj1VFnxhpsuM
</commit_message>
<xml_diff>
--- a/propuesta-clt/CLT_Market_Study_Mexico_Latam_EN.pptx
+++ b/propuesta-clt/CLT_Market_Study_Mexico_Latam_EN.pptx
@@ -143,20 +143,20 @@
   <p:extLst>
     <p:ext uri="{521415D9-36F7-43E2-AB2F-B90AF26B5E84}">
       <p14:sectionLst xmlns:p14="http://schemas.microsoft.com/office/powerpoint/2010/main">
-        <p14:section name="Opening" id="{ae30ad48-12ee-635f-590e-9609f41f8f63}">
+        <p14:section name="Opening" id="{50353cc7-c5f9-1bd2-fbba-676110092727}">
           <p14:sldIdLst>
             <p14:sldId id="256"/>
             <p14:sldId id="257"/>
             <p14:sldId id="258"/>
           </p14:sldIdLst>
         </p14:section>
-        <p14:section name="Scope and methodology" id="{a315a14f-b16b-92cd-6697-efa6e561cd9c}">
+        <p14:section name="Scope and methodology" id="{7b1f1745-bdeb-cdcd-8995-0af426c0fbc9}">
           <p14:sldIdLst>
             <p14:sldId id="259"/>
             <p14:sldId id="260"/>
           </p14:sldIdLst>
         </p14:section>
-        <p14:section name="The manufacturer: CLT" id="{f28f8bf6-89ce-3268-3bc3-725dd875f33a}">
+        <p14:section name="The manufacturer: CLT" id="{c25c5a83-3467-3d38-073e-341e8b3d0952}">
           <p14:sldIdLst>
             <p14:sldId id="261"/>
             <p14:sldId id="262"/>
@@ -168,7 +168,7 @@
             <p14:sldId id="268"/>
           </p14:sldIdLst>
         </p14:section>
-        <p14:section name="Mexican market" id="{b90e644d-e0be-6c97-b43e-d8ea01f1191b}">
+        <p14:section name="Mexican market" id="{c9b58469-ce55-d30b-e07f-c08589d189dd}">
           <p14:sldIdLst>
             <p14:sldId id="269"/>
             <p14:sldId id="270"/>
@@ -178,14 +178,14 @@
             <p14:sldId id="274"/>
           </p14:sldIdLst>
         </p14:section>
-        <p14:section name="Priority accounts" id="{45c5db27-a40c-df50-0d81-153f8568fdf7}">
+        <p14:section name="Priority accounts" id="{57d9810e-2d02-c46c-dfbb-722c3a3ac851}">
           <p14:sldIdLst>
             <p14:sldId id="275"/>
             <p14:sldId id="276"/>
             <p14:sldId id="277"/>
           </p14:sldIdLst>
         </p14:section>
-        <p14:section name="Competition" id="{5e7cd35e-f232-9439-1535-119c3a0dc6a1}">
+        <p14:section name="Competition" id="{e60c350f-1b8a-c39f-1b39-245a486b8921}">
           <p14:sldIdLst>
             <p14:sldId id="278"/>
             <p14:sldId id="279"/>
@@ -194,13 +194,13 @@
             <p14:sldId id="282"/>
           </p14:sldIdLst>
         </p14:section>
-        <p14:section name="Trade" id="{836cece3-d3aa-b982-135f-aadd8dec21d6}">
+        <p14:section name="Trade" id="{043118cc-3c08-c8ee-c2a7-ef516cde0401}">
           <p14:sldIdLst>
             <p14:sldId id="283"/>
             <p14:sldId id="284"/>
           </p14:sldIdLst>
         </p14:section>
-        <p14:section name="Latin America and the U.S." id="{6217fa59-2478-8d49-3abe-4b20e79976c1}">
+        <p14:section name="Latin America and the U.S." id="{aa063a21-bf0d-7a94-c3fd-f7a20c9202bb}">
           <p14:sldIdLst>
             <p14:sldId id="285"/>
             <p14:sldId id="286"/>
@@ -208,7 +208,7 @@
             <p14:sldId id="288"/>
           </p14:sldIdLst>
         </p14:section>
-        <p14:section name="Conclusions" id="{42cf74d8-d6af-a094-7822-1d24dd91e553}">
+        <p14:section name="Conclusions" id="{88cfa3b3-9226-c1a5-3773-5c759c024183}">
           <p14:sldIdLst>
             <p14:sldId id="289"/>
             <p14:sldId id="290"/>
@@ -1446,13 +1446,13 @@
                 <c:formatCode>General</c:formatCode>
                 <c:ptCount val="3"/>
                 <c:pt idx="0">
-                  <c:v>13</c:v>
+                  <c:v>11</c:v>
                 </c:pt>
                 <c:pt idx="1">
                   <c:v>6</c:v>
                 </c:pt>
                 <c:pt idx="2">
-                  <c:v>8</c:v>
+                  <c:v>7</c:v>
                 </c:pt>
               </c:numCache>
             </c:numRef>
@@ -1529,13 +1529,13 @@
                 <c:formatCode>General</c:formatCode>
                 <c:ptCount val="3"/>
                 <c:pt idx="0">
-                  <c:v>23</c:v>
+                  <c:v>24</c:v>
                 </c:pt>
                 <c:pt idx="1">
                   <c:v>16</c:v>
                 </c:pt>
                 <c:pt idx="2">
-                  <c:v>16</c:v>
+                  <c:v>17</c:v>
                 </c:pt>
               </c:numCache>
             </c:numRef>
@@ -1615,10 +1615,10 @@
                   <c:v>9</c:v>
                 </c:pt>
                 <c:pt idx="1">
-                  <c:v>12</c:v>
+                  <c:v>11</c:v>
                 </c:pt>
                 <c:pt idx="2">
-                  <c:v>19</c:v>
+                  <c:v>18</c:v>
                 </c:pt>
               </c:numCache>
             </c:numRef>
@@ -11462,7 +11462,7 @@
                   <a:schemeClr val="accent1"/>
                 </a:solidFill>
               </a:rPr>
-              <a:t>16</a:t>
+              <a:t>17</a:t>
             </a:r>
             <a:endParaRPr lang="en-US" sz="3000" dirty="0"/>
           </a:p>
@@ -11534,7 +11534,7 @@
                   <a:schemeClr val="accent2"/>
                 </a:solidFill>
               </a:rPr>
-              <a:t>35</a:t>
+              <a:t>33</a:t>
             </a:r>
             <a:endParaRPr lang="en-US" sz="3000" dirty="0"/>
           </a:p>
@@ -12050,7 +12050,7 @@
                   <a:srgbClr val="B38600"/>
                 </a:solidFill>
               </a:rPr>
-              <a:t>122</a:t>
+              <a:t>119</a:t>
             </a:r>
             <a:endParaRPr lang="en-US" sz="3000" dirty="0"/>
           </a:p>
@@ -16090,7 +16090,7 @@
                             <a:srgbClr val="1B1F3B"/>
                           </a:solidFill>
                         </a:rPr>
-                        <a:t>RMC de México</a:t>
+                        <a:t>Industrias Manufactureras MYR</a:t>
                       </a:r>
                       <a:endParaRPr lang="en-US" sz="900" dirty="0"/>
                     </a:p>
@@ -16151,7 +16151,7 @@
                             <a:srgbClr val="1B1F3B"/>
                           </a:solidFill>
                         </a:rPr>
-                        <a:t>Linares, N.L.</a:t>
+                        <a:t>Irapuato, Gto.</a:t>
                       </a:r>
                       <a:endParaRPr lang="en-US" sz="900" dirty="0"/>
                     </a:p>
@@ -16212,7 +16212,7 @@
                             <a:srgbClr val="1B1F3B"/>
                           </a:solidFill>
                         </a:rPr>
-                        <a:t>Under Armour, Nordstrom</a:t>
+                        <a:t>adidas, Puma</a:t>
                       </a:r>
                       <a:endParaRPr lang="en-US" sz="900" dirty="0"/>
                     </a:p>
@@ -24923,7 +24923,7 @@
                   <a:schemeClr val="tx1"/>
                 </a:solidFill>
               </a:rPr>
-              <a:t>Latin America: 122 prospects in 16 countries</a:t>
+              <a:t>Latin America: 119 prospects in 16 countries</a:t>
             </a:r>
             <a:endParaRPr lang="en-US" sz="2600" dirty="0"/>
           </a:p>
@@ -24975,7 +24975,7 @@
                   <a:schemeClr val="accent1"/>
                 </a:solidFill>
               </a:rPr>
-              <a:t>27</a:t>
+              <a:t>24</a:t>
             </a:r>
             <a:endParaRPr lang="en-US" sz="3000" dirty="0"/>
           </a:p>
@@ -25047,7 +25047,7 @@
                   <a:schemeClr val="accent2"/>
                 </a:solidFill>
               </a:rPr>
-              <a:t>45</a:t>
+              <a:t>44</a:t>
             </a:r>
             <a:endParaRPr lang="en-US" sz="3000" dirty="0"/>
           </a:p>
@@ -25119,7 +25119,7 @@
                   <a:schemeClr val="accent1"/>
                 </a:solidFill>
               </a:rPr>
-              <a:t>19 + 19</a:t>
+              <a:t>19 + 14</a:t>
             </a:r>
             <a:endParaRPr lang="en-US" sz="3000" dirty="0"/>
           </a:p>
@@ -25155,7 +25155,7 @@
                   <a:schemeClr val="tx2"/>
                 </a:solidFill>
               </a:rPr>
-              <a:t>Peru and Dominican Republic</a:t>
+              <a:t>Peru and Colombia</a:t>
             </a:r>
             <a:endParaRPr lang="en-US" sz="1200" dirty="0"/>
           </a:p>
@@ -25499,7 +25499,7 @@
                             <a:srgbClr val="1B1F3B"/>
                           </a:solidFill>
                         </a:rPr>
-                        <a:t>Gildan Activewear</a:t>
+                        <a:t>TCPL The Caribbean Print Limitada S.R.L.</a:t>
                       </a:r>
                       <a:endParaRPr lang="en-US" sz="900" dirty="0"/>
                     </a:p>
@@ -25560,7 +25560,7 @@
                             <a:srgbClr val="1B1F3B"/>
                           </a:solidFill>
                         </a:rPr>
-                        <a:t>Honduras</a:t>
+                        <a:t>República Dominicana</a:t>
                       </a:r>
                       <a:endParaRPr lang="en-US" sz="900" dirty="0"/>
                     </a:p>
@@ -25621,7 +25621,7 @@
                             <a:srgbClr val="1B1F3B"/>
                           </a:solidFill>
                         </a:rPr>
-                        <a:t>OEM / full-package contractor</a:t>
+                        <a:t>Contract printer</a:t>
                       </a:r>
                       <a:endParaRPr lang="en-US" sz="900" dirty="0"/>
                     </a:p>
@@ -25684,7 +25684,7 @@
                             <a:srgbClr val="1B1F3B"/>
                           </a:solidFill>
                         </a:rPr>
-                        <a:t>Hanes Ink Honduras</a:t>
+                        <a:t>The Willbes Dominicana Inc.</a:t>
                       </a:r>
                       <a:endParaRPr lang="en-US" sz="900" dirty="0"/>
                     </a:p>
@@ -25745,7 +25745,7 @@
                             <a:srgbClr val="1B1F3B"/>
                           </a:solidFill>
                         </a:rPr>
-                        <a:t>Honduras</a:t>
+                        <a:t>República Dominicana</a:t>
                       </a:r>
                       <a:endParaRPr lang="en-US" sz="900" dirty="0"/>
                     </a:p>
@@ -25869,7 +25869,7 @@
                             <a:srgbClr val="1B1F3B"/>
                           </a:solidFill>
                         </a:rPr>
-                        <a:t>Southern Apparel Contractors</a:t>
+                        <a:t>The Willbes Haitian</a:t>
                       </a:r>
                       <a:endParaRPr lang="en-US" sz="900" dirty="0"/>
                     </a:p>
@@ -25930,377 +25930,7 @@
                             <a:srgbClr val="1B1F3B"/>
                           </a:solidFill>
                         </a:rPr>
-                        <a:t>Honduras</a:t>
-                      </a:r>
-                      <a:endParaRPr lang="en-US" sz="900" dirty="0"/>
-                    </a:p>
-                  </a:txBody>
-                  <a:tcPr marL="45720" marR="45720" marT="45720" marB="45720" anchor="ctr">
-                    <a:lnL w="6350" cap="flat" cmpd="sng" algn="ctr">
-                      <a:solidFill>
-                        <a:srgbClr val="C9D1DC"/>
-                      </a:solidFill>
-                      <a:prstDash val="solid"/>
-                      <a:round/>
-                      <a:headEnd type="none" w="med" len="med"/>
-                      <a:tailEnd type="none" w="med" len="med"/>
-                    </a:lnL>
-                    <a:lnR w="6350" cap="flat" cmpd="sng" algn="ctr">
-                      <a:solidFill>
-                        <a:srgbClr val="C9D1DC"/>
-                      </a:solidFill>
-                      <a:prstDash val="solid"/>
-                      <a:round/>
-                      <a:headEnd type="none" w="med" len="med"/>
-                      <a:tailEnd type="none" w="med" len="med"/>
-                    </a:lnR>
-                    <a:lnT w="6350" cap="flat" cmpd="sng" algn="ctr">
-                      <a:solidFill>
-                        <a:srgbClr val="C9D1DC"/>
-                      </a:solidFill>
-                      <a:prstDash val="solid"/>
-                      <a:round/>
-                      <a:headEnd type="none" w="med" len="med"/>
-                      <a:tailEnd type="none" w="med" len="med"/>
-                    </a:lnT>
-                    <a:lnB w="6350" cap="flat" cmpd="sng" algn="ctr">
-                      <a:solidFill>
-                        <a:srgbClr val="C9D1DC"/>
-                      </a:solidFill>
-                      <a:prstDash val="solid"/>
-                      <a:round/>
-                      <a:headEnd type="none" w="med" len="med"/>
-                      <a:tailEnd type="none" w="med" len="med"/>
-                    </a:lnB>
-                    <a:solidFill>
-                      <a:srgbClr val="EEF2F7"/>
-                    </a:solidFill>
-                  </a:tcPr>
-                </a:tc>
-                <a:tc>
-                  <a:txBody>
-                    <a:bodyPr/>
-                    <a:lstStyle/>
-                    <a:p>
-                      <a:pPr indent="0" marL="0">
-                        <a:buNone/>
-                      </a:pPr>
-                      <a:r>
-                        <a:rPr lang="en-US" sz="900" dirty="0">
-                          <a:solidFill>
-                            <a:srgbClr val="1B1F3B"/>
-                          </a:solidFill>
-                        </a:rPr>
-                        <a:t>OEM / full-package contractor</a:t>
-                      </a:r>
-                      <a:endParaRPr lang="en-US" sz="900" dirty="0"/>
-                    </a:p>
-                  </a:txBody>
-                  <a:tcPr marL="45720" marR="45720" marT="45720" marB="45720" anchor="ctr">
-                    <a:lnL w="6350" cap="flat" cmpd="sng" algn="ctr">
-                      <a:solidFill>
-                        <a:srgbClr val="C9D1DC"/>
-                      </a:solidFill>
-                      <a:prstDash val="solid"/>
-                      <a:round/>
-                      <a:headEnd type="none" w="med" len="med"/>
-                      <a:tailEnd type="none" w="med" len="med"/>
-                    </a:lnL>
-                    <a:lnR w="6350" cap="flat" cmpd="sng" algn="ctr">
-                      <a:solidFill>
-                        <a:srgbClr val="C9D1DC"/>
-                      </a:solidFill>
-                      <a:prstDash val="solid"/>
-                      <a:round/>
-                      <a:headEnd type="none" w="med" len="med"/>
-                      <a:tailEnd type="none" w="med" len="med"/>
-                    </a:lnR>
-                    <a:lnT w="6350" cap="flat" cmpd="sng" algn="ctr">
-                      <a:solidFill>
-                        <a:srgbClr val="C9D1DC"/>
-                      </a:solidFill>
-                      <a:prstDash val="solid"/>
-                      <a:round/>
-                      <a:headEnd type="none" w="med" len="med"/>
-                      <a:tailEnd type="none" w="med" len="med"/>
-                    </a:lnT>
-                    <a:lnB w="6350" cap="flat" cmpd="sng" algn="ctr">
-                      <a:solidFill>
-                        <a:srgbClr val="C9D1DC"/>
-                      </a:solidFill>
-                      <a:prstDash val="solid"/>
-                      <a:round/>
-                      <a:headEnd type="none" w="med" len="med"/>
-                      <a:tailEnd type="none" w="med" len="med"/>
-                    </a:lnB>
-                    <a:solidFill>
-                      <a:srgbClr val="EEF2F7"/>
-                    </a:solidFill>
-                  </a:tcPr>
-                </a:tc>
-              </a:tr>
-              <a:tr h="265176">
-                <a:tc>
-                  <a:txBody>
-                    <a:bodyPr/>
-                    <a:lstStyle/>
-                    <a:p>
-                      <a:pPr indent="0" marL="0">
-                        <a:buNone/>
-                      </a:pPr>
-                      <a:r>
-                        <a:rPr lang="en-US" sz="900" b="1" dirty="0">
-                          <a:solidFill>
-                            <a:srgbClr val="1B1F3B"/>
-                          </a:solidFill>
-                        </a:rPr>
-                        <a:t>Pinehurst Manufacturing</a:t>
-                      </a:r>
-                      <a:endParaRPr lang="en-US" sz="900" dirty="0"/>
-                    </a:p>
-                  </a:txBody>
-                  <a:tcPr marL="45720" marR="45720" marT="45720" marB="45720" anchor="ctr">
-                    <a:lnL w="6350" cap="flat" cmpd="sng" algn="ctr">
-                      <a:solidFill>
-                        <a:srgbClr val="C9D1DC"/>
-                      </a:solidFill>
-                      <a:prstDash val="solid"/>
-                      <a:round/>
-                      <a:headEnd type="none" w="med" len="med"/>
-                      <a:tailEnd type="none" w="med" len="med"/>
-                    </a:lnL>
-                    <a:lnR w="6350" cap="flat" cmpd="sng" algn="ctr">
-                      <a:solidFill>
-                        <a:srgbClr val="C9D1DC"/>
-                      </a:solidFill>
-                      <a:prstDash val="solid"/>
-                      <a:round/>
-                      <a:headEnd type="none" w="med" len="med"/>
-                      <a:tailEnd type="none" w="med" len="med"/>
-                    </a:lnR>
-                    <a:lnT w="6350" cap="flat" cmpd="sng" algn="ctr">
-                      <a:solidFill>
-                        <a:srgbClr val="C9D1DC"/>
-                      </a:solidFill>
-                      <a:prstDash val="solid"/>
-                      <a:round/>
-                      <a:headEnd type="none" w="med" len="med"/>
-                      <a:tailEnd type="none" w="med" len="med"/>
-                    </a:lnT>
-                    <a:lnB w="6350" cap="flat" cmpd="sng" algn="ctr">
-                      <a:solidFill>
-                        <a:srgbClr val="C9D1DC"/>
-                      </a:solidFill>
-                      <a:prstDash val="solid"/>
-                      <a:round/>
-                      <a:headEnd type="none" w="med" len="med"/>
-                      <a:tailEnd type="none" w="med" len="med"/>
-                    </a:lnB>
-                    <a:solidFill>
-                      <a:srgbClr val="FFFFFF"/>
-                    </a:solidFill>
-                  </a:tcPr>
-                </a:tc>
-                <a:tc>
-                  <a:txBody>
-                    <a:bodyPr/>
-                    <a:lstStyle/>
-                    <a:p>
-                      <a:pPr indent="0" marL="0">
-                        <a:buNone/>
-                      </a:pPr>
-                      <a:r>
-                        <a:rPr lang="en-US" sz="900" dirty="0">
-                          <a:solidFill>
-                            <a:srgbClr val="1B1F3B"/>
-                          </a:solidFill>
-                        </a:rPr>
-                        <a:t>Honduras</a:t>
-                      </a:r>
-                      <a:endParaRPr lang="en-US" sz="900" dirty="0"/>
-                    </a:p>
-                  </a:txBody>
-                  <a:tcPr marL="45720" marR="45720" marT="45720" marB="45720" anchor="ctr">
-                    <a:lnL w="6350" cap="flat" cmpd="sng" algn="ctr">
-                      <a:solidFill>
-                        <a:srgbClr val="C9D1DC"/>
-                      </a:solidFill>
-                      <a:prstDash val="solid"/>
-                      <a:round/>
-                      <a:headEnd type="none" w="med" len="med"/>
-                      <a:tailEnd type="none" w="med" len="med"/>
-                    </a:lnL>
-                    <a:lnR w="6350" cap="flat" cmpd="sng" algn="ctr">
-                      <a:solidFill>
-                        <a:srgbClr val="C9D1DC"/>
-                      </a:solidFill>
-                      <a:prstDash val="solid"/>
-                      <a:round/>
-                      <a:headEnd type="none" w="med" len="med"/>
-                      <a:tailEnd type="none" w="med" len="med"/>
-                    </a:lnR>
-                    <a:lnT w="6350" cap="flat" cmpd="sng" algn="ctr">
-                      <a:solidFill>
-                        <a:srgbClr val="C9D1DC"/>
-                      </a:solidFill>
-                      <a:prstDash val="solid"/>
-                      <a:round/>
-                      <a:headEnd type="none" w="med" len="med"/>
-                      <a:tailEnd type="none" w="med" len="med"/>
-                    </a:lnT>
-                    <a:lnB w="6350" cap="flat" cmpd="sng" algn="ctr">
-                      <a:solidFill>
-                        <a:srgbClr val="C9D1DC"/>
-                      </a:solidFill>
-                      <a:prstDash val="solid"/>
-                      <a:round/>
-                      <a:headEnd type="none" w="med" len="med"/>
-                      <a:tailEnd type="none" w="med" len="med"/>
-                    </a:lnB>
-                    <a:solidFill>
-                      <a:srgbClr val="FFFFFF"/>
-                    </a:solidFill>
-                  </a:tcPr>
-                </a:tc>
-                <a:tc>
-                  <a:txBody>
-                    <a:bodyPr/>
-                    <a:lstStyle/>
-                    <a:p>
-                      <a:pPr indent="0" marL="0">
-                        <a:buNone/>
-                      </a:pPr>
-                      <a:r>
-                        <a:rPr lang="en-US" sz="900" dirty="0">
-                          <a:solidFill>
-                            <a:srgbClr val="1B1F3B"/>
-                          </a:solidFill>
-                        </a:rPr>
-                        <a:t>Sportswear / uniform maker</a:t>
-                      </a:r>
-                      <a:endParaRPr lang="en-US" sz="900" dirty="0"/>
-                    </a:p>
-                  </a:txBody>
-                  <a:tcPr marL="45720" marR="45720" marT="45720" marB="45720" anchor="ctr">
-                    <a:lnL w="6350" cap="flat" cmpd="sng" algn="ctr">
-                      <a:solidFill>
-                        <a:srgbClr val="C9D1DC"/>
-                      </a:solidFill>
-                      <a:prstDash val="solid"/>
-                      <a:round/>
-                      <a:headEnd type="none" w="med" len="med"/>
-                      <a:tailEnd type="none" w="med" len="med"/>
-                    </a:lnL>
-                    <a:lnR w="6350" cap="flat" cmpd="sng" algn="ctr">
-                      <a:solidFill>
-                        <a:srgbClr val="C9D1DC"/>
-                      </a:solidFill>
-                      <a:prstDash val="solid"/>
-                      <a:round/>
-                      <a:headEnd type="none" w="med" len="med"/>
-                      <a:tailEnd type="none" w="med" len="med"/>
-                    </a:lnR>
-                    <a:lnT w="6350" cap="flat" cmpd="sng" algn="ctr">
-                      <a:solidFill>
-                        <a:srgbClr val="C9D1DC"/>
-                      </a:solidFill>
-                      <a:prstDash val="solid"/>
-                      <a:round/>
-                      <a:headEnd type="none" w="med" len="med"/>
-                      <a:tailEnd type="none" w="med" len="med"/>
-                    </a:lnT>
-                    <a:lnB w="6350" cap="flat" cmpd="sng" algn="ctr">
-                      <a:solidFill>
-                        <a:srgbClr val="C9D1DC"/>
-                      </a:solidFill>
-                      <a:prstDash val="solid"/>
-                      <a:round/>
-                      <a:headEnd type="none" w="med" len="med"/>
-                      <a:tailEnd type="none" w="med" len="med"/>
-                    </a:lnB>
-                    <a:solidFill>
-                      <a:srgbClr val="FFFFFF"/>
-                    </a:solidFill>
-                  </a:tcPr>
-                </a:tc>
-              </a:tr>
-              <a:tr h="265176">
-                <a:tc>
-                  <a:txBody>
-                    <a:bodyPr/>
-                    <a:lstStyle/>
-                    <a:p>
-                      <a:pPr indent="0" marL="0">
-                        <a:buNone/>
-                      </a:pPr>
-                      <a:r>
-                        <a:rPr lang="en-US" sz="900" b="1" dirty="0">
-                          <a:solidFill>
-                            <a:srgbClr val="1B1F3B"/>
-                          </a:solidFill>
-                        </a:rPr>
-                        <a:t>DecoTex International</a:t>
-                      </a:r>
-                      <a:endParaRPr lang="en-US" sz="900" dirty="0"/>
-                    </a:p>
-                  </a:txBody>
-                  <a:tcPr marL="45720" marR="45720" marT="45720" marB="45720" anchor="ctr">
-                    <a:lnL w="6350" cap="flat" cmpd="sng" algn="ctr">
-                      <a:solidFill>
-                        <a:srgbClr val="C9D1DC"/>
-                      </a:solidFill>
-                      <a:prstDash val="solid"/>
-                      <a:round/>
-                      <a:headEnd type="none" w="med" len="med"/>
-                      <a:tailEnd type="none" w="med" len="med"/>
-                    </a:lnL>
-                    <a:lnR w="6350" cap="flat" cmpd="sng" algn="ctr">
-                      <a:solidFill>
-                        <a:srgbClr val="C9D1DC"/>
-                      </a:solidFill>
-                      <a:prstDash val="solid"/>
-                      <a:round/>
-                      <a:headEnd type="none" w="med" len="med"/>
-                      <a:tailEnd type="none" w="med" len="med"/>
-                    </a:lnR>
-                    <a:lnT w="6350" cap="flat" cmpd="sng" algn="ctr">
-                      <a:solidFill>
-                        <a:srgbClr val="C9D1DC"/>
-                      </a:solidFill>
-                      <a:prstDash val="solid"/>
-                      <a:round/>
-                      <a:headEnd type="none" w="med" len="med"/>
-                      <a:tailEnd type="none" w="med" len="med"/>
-                    </a:lnT>
-                    <a:lnB w="6350" cap="flat" cmpd="sng" algn="ctr">
-                      <a:solidFill>
-                        <a:srgbClr val="C9D1DC"/>
-                      </a:solidFill>
-                      <a:prstDash val="solid"/>
-                      <a:round/>
-                      <a:headEnd type="none" w="med" len="med"/>
-                      <a:tailEnd type="none" w="med" len="med"/>
-                    </a:lnB>
-                    <a:solidFill>
-                      <a:srgbClr val="EEF2F7"/>
-                    </a:solidFill>
-                  </a:tcPr>
-                </a:tc>
-                <a:tc>
-                  <a:txBody>
-                    <a:bodyPr/>
-                    <a:lstStyle/>
-                    <a:p>
-                      <a:pPr indent="0" marL="0">
-                        <a:buNone/>
-                      </a:pPr>
-                      <a:r>
-                        <a:rPr lang="en-US" sz="900" dirty="0">
-                          <a:solidFill>
-                            <a:srgbClr val="1B1F3B"/>
-                          </a:solidFill>
-                        </a:rPr>
-                        <a:t>El Salvador</a:t>
+                        <a:t>Haití</a:t>
                       </a:r>
                       <a:endParaRPr lang="en-US" sz="900" dirty="0"/>
                     </a:p>
@@ -26794,7 +26424,7 @@
                             <a:srgbClr val="1B1F3B"/>
                           </a:solidFill>
                         </a:rPr>
-                        <a:t>Apple Tree El Salvador</a:t>
+                        <a:t>ACSA Colors Printing</a:t>
                       </a:r>
                       <a:endParaRPr lang="en-US" sz="900" dirty="0"/>
                     </a:p>
@@ -26855,7 +26485,377 @@
                             <a:srgbClr val="1B1F3B"/>
                           </a:solidFill>
                         </a:rPr>
-                        <a:t>El Salvador</a:t>
+                        <a:t>Guatemala</a:t>
+                      </a:r>
+                      <a:endParaRPr lang="en-US" sz="900" dirty="0"/>
+                    </a:p>
+                  </a:txBody>
+                  <a:tcPr marL="45720" marR="45720" marT="45720" marB="45720" anchor="ctr">
+                    <a:lnL w="6350" cap="flat" cmpd="sng" algn="ctr">
+                      <a:solidFill>
+                        <a:srgbClr val="C9D1DC"/>
+                      </a:solidFill>
+                      <a:prstDash val="solid"/>
+                      <a:round/>
+                      <a:headEnd type="none" w="med" len="med"/>
+                      <a:tailEnd type="none" w="med" len="med"/>
+                    </a:lnL>
+                    <a:lnR w="6350" cap="flat" cmpd="sng" algn="ctr">
+                      <a:solidFill>
+                        <a:srgbClr val="C9D1DC"/>
+                      </a:solidFill>
+                      <a:prstDash val="solid"/>
+                      <a:round/>
+                      <a:headEnd type="none" w="med" len="med"/>
+                      <a:tailEnd type="none" w="med" len="med"/>
+                    </a:lnR>
+                    <a:lnT w="6350" cap="flat" cmpd="sng" algn="ctr">
+                      <a:solidFill>
+                        <a:srgbClr val="C9D1DC"/>
+                      </a:solidFill>
+                      <a:prstDash val="solid"/>
+                      <a:round/>
+                      <a:headEnd type="none" w="med" len="med"/>
+                      <a:tailEnd type="none" w="med" len="med"/>
+                    </a:lnT>
+                    <a:lnB w="6350" cap="flat" cmpd="sng" algn="ctr">
+                      <a:solidFill>
+                        <a:srgbClr val="C9D1DC"/>
+                      </a:solidFill>
+                      <a:prstDash val="solid"/>
+                      <a:round/>
+                      <a:headEnd type="none" w="med" len="med"/>
+                      <a:tailEnd type="none" w="med" len="med"/>
+                    </a:lnB>
+                    <a:solidFill>
+                      <a:srgbClr val="FFFFFF"/>
+                    </a:solidFill>
+                  </a:tcPr>
+                </a:tc>
+                <a:tc>
+                  <a:txBody>
+                    <a:bodyPr/>
+                    <a:lstStyle/>
+                    <a:p>
+                      <a:pPr indent="0" marL="0">
+                        <a:buNone/>
+                      </a:pPr>
+                      <a:r>
+                        <a:rPr lang="en-US" sz="900" dirty="0">
+                          <a:solidFill>
+                            <a:srgbClr val="1B1F3B"/>
+                          </a:solidFill>
+                        </a:rPr>
+                        <a:t>Contract printer</a:t>
+                      </a:r>
+                      <a:endParaRPr lang="en-US" sz="900" dirty="0"/>
+                    </a:p>
+                  </a:txBody>
+                  <a:tcPr marL="45720" marR="45720" marT="45720" marB="45720" anchor="ctr">
+                    <a:lnL w="6350" cap="flat" cmpd="sng" algn="ctr">
+                      <a:solidFill>
+                        <a:srgbClr val="C9D1DC"/>
+                      </a:solidFill>
+                      <a:prstDash val="solid"/>
+                      <a:round/>
+                      <a:headEnd type="none" w="med" len="med"/>
+                      <a:tailEnd type="none" w="med" len="med"/>
+                    </a:lnL>
+                    <a:lnR w="6350" cap="flat" cmpd="sng" algn="ctr">
+                      <a:solidFill>
+                        <a:srgbClr val="C9D1DC"/>
+                      </a:solidFill>
+                      <a:prstDash val="solid"/>
+                      <a:round/>
+                      <a:headEnd type="none" w="med" len="med"/>
+                      <a:tailEnd type="none" w="med" len="med"/>
+                    </a:lnR>
+                    <a:lnT w="6350" cap="flat" cmpd="sng" algn="ctr">
+                      <a:solidFill>
+                        <a:srgbClr val="C9D1DC"/>
+                      </a:solidFill>
+                      <a:prstDash val="solid"/>
+                      <a:round/>
+                      <a:headEnd type="none" w="med" len="med"/>
+                      <a:tailEnd type="none" w="med" len="med"/>
+                    </a:lnT>
+                    <a:lnB w="6350" cap="flat" cmpd="sng" algn="ctr">
+                      <a:solidFill>
+                        <a:srgbClr val="C9D1DC"/>
+                      </a:solidFill>
+                      <a:prstDash val="solid"/>
+                      <a:round/>
+                      <a:headEnd type="none" w="med" len="med"/>
+                      <a:tailEnd type="none" w="med" len="med"/>
+                    </a:lnB>
+                    <a:solidFill>
+                      <a:srgbClr val="FFFFFF"/>
+                    </a:solidFill>
+                  </a:tcPr>
+                </a:tc>
+              </a:tr>
+              <a:tr h="265176">
+                <a:tc>
+                  <a:txBody>
+                    <a:bodyPr/>
+                    <a:lstStyle/>
+                    <a:p>
+                      <a:pPr indent="0" marL="0">
+                        <a:buNone/>
+                      </a:pPr>
+                      <a:r>
+                        <a:rPr lang="en-US" sz="900" b="1" dirty="0">
+                          <a:solidFill>
+                            <a:srgbClr val="1B1F3B"/>
+                          </a:solidFill>
+                        </a:rPr>
+                        <a:t>Topy Top</a:t>
+                      </a:r>
+                      <a:endParaRPr lang="en-US" sz="900" dirty="0"/>
+                    </a:p>
+                  </a:txBody>
+                  <a:tcPr marL="45720" marR="45720" marT="45720" marB="45720" anchor="ctr">
+                    <a:lnL w="6350" cap="flat" cmpd="sng" algn="ctr">
+                      <a:solidFill>
+                        <a:srgbClr val="C9D1DC"/>
+                      </a:solidFill>
+                      <a:prstDash val="solid"/>
+                      <a:round/>
+                      <a:headEnd type="none" w="med" len="med"/>
+                      <a:tailEnd type="none" w="med" len="med"/>
+                    </a:lnL>
+                    <a:lnR w="6350" cap="flat" cmpd="sng" algn="ctr">
+                      <a:solidFill>
+                        <a:srgbClr val="C9D1DC"/>
+                      </a:solidFill>
+                      <a:prstDash val="solid"/>
+                      <a:round/>
+                      <a:headEnd type="none" w="med" len="med"/>
+                      <a:tailEnd type="none" w="med" len="med"/>
+                    </a:lnR>
+                    <a:lnT w="6350" cap="flat" cmpd="sng" algn="ctr">
+                      <a:solidFill>
+                        <a:srgbClr val="C9D1DC"/>
+                      </a:solidFill>
+                      <a:prstDash val="solid"/>
+                      <a:round/>
+                      <a:headEnd type="none" w="med" len="med"/>
+                      <a:tailEnd type="none" w="med" len="med"/>
+                    </a:lnT>
+                    <a:lnB w="6350" cap="flat" cmpd="sng" algn="ctr">
+                      <a:solidFill>
+                        <a:srgbClr val="C9D1DC"/>
+                      </a:solidFill>
+                      <a:prstDash val="solid"/>
+                      <a:round/>
+                      <a:headEnd type="none" w="med" len="med"/>
+                      <a:tailEnd type="none" w="med" len="med"/>
+                    </a:lnB>
+                    <a:solidFill>
+                      <a:srgbClr val="EEF2F7"/>
+                    </a:solidFill>
+                  </a:tcPr>
+                </a:tc>
+                <a:tc>
+                  <a:txBody>
+                    <a:bodyPr/>
+                    <a:lstStyle/>
+                    <a:p>
+                      <a:pPr indent="0" marL="0">
+                        <a:buNone/>
+                      </a:pPr>
+                      <a:r>
+                        <a:rPr lang="en-US" sz="900" dirty="0">
+                          <a:solidFill>
+                            <a:srgbClr val="1B1F3B"/>
+                          </a:solidFill>
+                        </a:rPr>
+                        <a:t>Perú</a:t>
+                      </a:r>
+                      <a:endParaRPr lang="en-US" sz="900" dirty="0"/>
+                    </a:p>
+                  </a:txBody>
+                  <a:tcPr marL="45720" marR="45720" marT="45720" marB="45720" anchor="ctr">
+                    <a:lnL w="6350" cap="flat" cmpd="sng" algn="ctr">
+                      <a:solidFill>
+                        <a:srgbClr val="C9D1DC"/>
+                      </a:solidFill>
+                      <a:prstDash val="solid"/>
+                      <a:round/>
+                      <a:headEnd type="none" w="med" len="med"/>
+                      <a:tailEnd type="none" w="med" len="med"/>
+                    </a:lnL>
+                    <a:lnR w="6350" cap="flat" cmpd="sng" algn="ctr">
+                      <a:solidFill>
+                        <a:srgbClr val="C9D1DC"/>
+                      </a:solidFill>
+                      <a:prstDash val="solid"/>
+                      <a:round/>
+                      <a:headEnd type="none" w="med" len="med"/>
+                      <a:tailEnd type="none" w="med" len="med"/>
+                    </a:lnR>
+                    <a:lnT w="6350" cap="flat" cmpd="sng" algn="ctr">
+                      <a:solidFill>
+                        <a:srgbClr val="C9D1DC"/>
+                      </a:solidFill>
+                      <a:prstDash val="solid"/>
+                      <a:round/>
+                      <a:headEnd type="none" w="med" len="med"/>
+                      <a:tailEnd type="none" w="med" len="med"/>
+                    </a:lnT>
+                    <a:lnB w="6350" cap="flat" cmpd="sng" algn="ctr">
+                      <a:solidFill>
+                        <a:srgbClr val="C9D1DC"/>
+                      </a:solidFill>
+                      <a:prstDash val="solid"/>
+                      <a:round/>
+                      <a:headEnd type="none" w="med" len="med"/>
+                      <a:tailEnd type="none" w="med" len="med"/>
+                    </a:lnB>
+                    <a:solidFill>
+                      <a:srgbClr val="EEF2F7"/>
+                    </a:solidFill>
+                  </a:tcPr>
+                </a:tc>
+                <a:tc>
+                  <a:txBody>
+                    <a:bodyPr/>
+                    <a:lstStyle/>
+                    <a:p>
+                      <a:pPr indent="0" marL="0">
+                        <a:buNone/>
+                      </a:pPr>
+                      <a:r>
+                        <a:rPr lang="en-US" sz="900" dirty="0">
+                          <a:solidFill>
+                            <a:srgbClr val="1B1F3B"/>
+                          </a:solidFill>
+                        </a:rPr>
+                        <a:t>OEM / full-package contractor</a:t>
+                      </a:r>
+                      <a:endParaRPr lang="en-US" sz="900" dirty="0"/>
+                    </a:p>
+                  </a:txBody>
+                  <a:tcPr marL="45720" marR="45720" marT="45720" marB="45720" anchor="ctr">
+                    <a:lnL w="6350" cap="flat" cmpd="sng" algn="ctr">
+                      <a:solidFill>
+                        <a:srgbClr val="C9D1DC"/>
+                      </a:solidFill>
+                      <a:prstDash val="solid"/>
+                      <a:round/>
+                      <a:headEnd type="none" w="med" len="med"/>
+                      <a:tailEnd type="none" w="med" len="med"/>
+                    </a:lnL>
+                    <a:lnR w="6350" cap="flat" cmpd="sng" algn="ctr">
+                      <a:solidFill>
+                        <a:srgbClr val="C9D1DC"/>
+                      </a:solidFill>
+                      <a:prstDash val="solid"/>
+                      <a:round/>
+                      <a:headEnd type="none" w="med" len="med"/>
+                      <a:tailEnd type="none" w="med" len="med"/>
+                    </a:lnR>
+                    <a:lnT w="6350" cap="flat" cmpd="sng" algn="ctr">
+                      <a:solidFill>
+                        <a:srgbClr val="C9D1DC"/>
+                      </a:solidFill>
+                      <a:prstDash val="solid"/>
+                      <a:round/>
+                      <a:headEnd type="none" w="med" len="med"/>
+                      <a:tailEnd type="none" w="med" len="med"/>
+                    </a:lnT>
+                    <a:lnB w="6350" cap="flat" cmpd="sng" algn="ctr">
+                      <a:solidFill>
+                        <a:srgbClr val="C9D1DC"/>
+                      </a:solidFill>
+                      <a:prstDash val="solid"/>
+                      <a:round/>
+                      <a:headEnd type="none" w="med" len="med"/>
+                      <a:tailEnd type="none" w="med" len="med"/>
+                    </a:lnB>
+                    <a:solidFill>
+                      <a:srgbClr val="EEF2F7"/>
+                    </a:solidFill>
+                  </a:tcPr>
+                </a:tc>
+              </a:tr>
+              <a:tr h="265176">
+                <a:tc>
+                  <a:txBody>
+                    <a:bodyPr/>
+                    <a:lstStyle/>
+                    <a:p>
+                      <a:pPr indent="0" marL="0">
+                        <a:buNone/>
+                      </a:pPr>
+                      <a:r>
+                        <a:rPr lang="en-US" sz="900" b="1" dirty="0">
+                          <a:solidFill>
+                            <a:srgbClr val="1B1F3B"/>
+                          </a:solidFill>
+                        </a:rPr>
+                        <a:t>Industrias Nettalco</a:t>
+                      </a:r>
+                      <a:endParaRPr lang="en-US" sz="900" dirty="0"/>
+                    </a:p>
+                  </a:txBody>
+                  <a:tcPr marL="45720" marR="45720" marT="45720" marB="45720" anchor="ctr">
+                    <a:lnL w="6350" cap="flat" cmpd="sng" algn="ctr">
+                      <a:solidFill>
+                        <a:srgbClr val="C9D1DC"/>
+                      </a:solidFill>
+                      <a:prstDash val="solid"/>
+                      <a:round/>
+                      <a:headEnd type="none" w="med" len="med"/>
+                      <a:tailEnd type="none" w="med" len="med"/>
+                    </a:lnL>
+                    <a:lnR w="6350" cap="flat" cmpd="sng" algn="ctr">
+                      <a:solidFill>
+                        <a:srgbClr val="C9D1DC"/>
+                      </a:solidFill>
+                      <a:prstDash val="solid"/>
+                      <a:round/>
+                      <a:headEnd type="none" w="med" len="med"/>
+                      <a:tailEnd type="none" w="med" len="med"/>
+                    </a:lnR>
+                    <a:lnT w="6350" cap="flat" cmpd="sng" algn="ctr">
+                      <a:solidFill>
+                        <a:srgbClr val="C9D1DC"/>
+                      </a:solidFill>
+                      <a:prstDash val="solid"/>
+                      <a:round/>
+                      <a:headEnd type="none" w="med" len="med"/>
+                      <a:tailEnd type="none" w="med" len="med"/>
+                    </a:lnT>
+                    <a:lnB w="6350" cap="flat" cmpd="sng" algn="ctr">
+                      <a:solidFill>
+                        <a:srgbClr val="C9D1DC"/>
+                      </a:solidFill>
+                      <a:prstDash val="solid"/>
+                      <a:round/>
+                      <a:headEnd type="none" w="med" len="med"/>
+                      <a:tailEnd type="none" w="med" len="med"/>
+                    </a:lnB>
+                    <a:solidFill>
+                      <a:srgbClr val="FFFFFF"/>
+                    </a:solidFill>
+                  </a:tcPr>
+                </a:tc>
+                <a:tc>
+                  <a:txBody>
+                    <a:bodyPr/>
+                    <a:lstStyle/>
+                    <a:p>
+                      <a:pPr indent="0" marL="0">
+                        <a:buNone/>
+                      </a:pPr>
+                      <a:r>
+                        <a:rPr lang="en-US" sz="900" dirty="0">
+                          <a:solidFill>
+                            <a:srgbClr val="1B1F3B"/>
+                          </a:solidFill>
+                        </a:rPr>
+                        <a:t>Perú</a:t>
                       </a:r>
                       <a:endParaRPr lang="en-US" sz="900" dirty="0"/>
                     </a:p>
@@ -26979,7 +26979,7 @@
                             <a:srgbClr val="1B1F3B"/>
                           </a:solidFill>
                         </a:rPr>
-                        <a:t>OA</a:t>
+                        <a:t>Serigrafía Moderna</a:t>
                       </a:r>
                       <a:endParaRPr lang="en-US" sz="900" dirty="0"/>
                     </a:p>
@@ -27040,7 +27040,7 @@
                             <a:srgbClr val="1B1F3B"/>
                           </a:solidFill>
                         </a:rPr>
-                        <a:t>El Salvador</a:t>
+                        <a:t>República Dominicana</a:t>
                       </a:r>
                       <a:endParaRPr lang="en-US" sz="900" dirty="0"/>
                     </a:p>
@@ -27101,7 +27101,7 @@
                             <a:srgbClr val="1B1F3B"/>
                           </a:solidFill>
                         </a:rPr>
-                        <a:t>OEM / full-package contractor</a:t>
+                        <a:t>Contract printer</a:t>
                       </a:r>
                       <a:endParaRPr lang="en-US" sz="900" dirty="0"/>
                     </a:p>
@@ -27164,7 +27164,7 @@
                             <a:srgbClr val="1B1F3B"/>
                           </a:solidFill>
                         </a:rPr>
-                        <a:t>Intradeco</a:t>
+                        <a:t>Uniwell Apparel</a:t>
                       </a:r>
                       <a:endParaRPr lang="en-US" sz="900" dirty="0"/>
                     </a:p>
@@ -27225,7 +27225,7 @@
                             <a:srgbClr val="1B1F3B"/>
                           </a:solidFill>
                         </a:rPr>
-                        <a:t>El Salvador</a:t>
+                        <a:t>Haití</a:t>
                       </a:r>
                       <a:endParaRPr lang="en-US" sz="900" dirty="0"/>
                     </a:p>
@@ -27349,7 +27349,7 @@
                             <a:srgbClr val="1B1F3B"/>
                           </a:solidFill>
                         </a:rPr>
-                        <a:t>ACSA Colors Printing</a:t>
+                        <a:t>Sun Island Jamaica Ltd.</a:t>
                       </a:r>
                       <a:endParaRPr lang="en-US" sz="900" dirty="0"/>
                     </a:p>
@@ -27410,7 +27410,7 @@
                             <a:srgbClr val="1B1F3B"/>
                           </a:solidFill>
                         </a:rPr>
-                        <a:t>Guatemala</a:t>
+                        <a:t>Jamaica</a:t>
                       </a:r>
                       <a:endParaRPr lang="en-US" sz="900" dirty="0"/>
                     </a:p>
@@ -27454,191 +27454,6 @@
                     </a:lnB>
                     <a:solidFill>
                       <a:srgbClr val="EEF2F7"/>
-                    </a:solidFill>
-                  </a:tcPr>
-                </a:tc>
-                <a:tc>
-                  <a:txBody>
-                    <a:bodyPr/>
-                    <a:lstStyle/>
-                    <a:p>
-                      <a:pPr indent="0" marL="0">
-                        <a:buNone/>
-                      </a:pPr>
-                      <a:r>
-                        <a:rPr lang="en-US" sz="900" dirty="0">
-                          <a:solidFill>
-                            <a:srgbClr val="1B1F3B"/>
-                          </a:solidFill>
-                        </a:rPr>
-                        <a:t>Contract printer</a:t>
-                      </a:r>
-                      <a:endParaRPr lang="en-US" sz="900" dirty="0"/>
-                    </a:p>
-                  </a:txBody>
-                  <a:tcPr marL="45720" marR="45720" marT="45720" marB="45720" anchor="ctr">
-                    <a:lnL w="6350" cap="flat" cmpd="sng" algn="ctr">
-                      <a:solidFill>
-                        <a:srgbClr val="C9D1DC"/>
-                      </a:solidFill>
-                      <a:prstDash val="solid"/>
-                      <a:round/>
-                      <a:headEnd type="none" w="med" len="med"/>
-                      <a:tailEnd type="none" w="med" len="med"/>
-                    </a:lnL>
-                    <a:lnR w="6350" cap="flat" cmpd="sng" algn="ctr">
-                      <a:solidFill>
-                        <a:srgbClr val="C9D1DC"/>
-                      </a:solidFill>
-                      <a:prstDash val="solid"/>
-                      <a:round/>
-                      <a:headEnd type="none" w="med" len="med"/>
-                      <a:tailEnd type="none" w="med" len="med"/>
-                    </a:lnR>
-                    <a:lnT w="6350" cap="flat" cmpd="sng" algn="ctr">
-                      <a:solidFill>
-                        <a:srgbClr val="C9D1DC"/>
-                      </a:solidFill>
-                      <a:prstDash val="solid"/>
-                      <a:round/>
-                      <a:headEnd type="none" w="med" len="med"/>
-                      <a:tailEnd type="none" w="med" len="med"/>
-                    </a:lnT>
-                    <a:lnB w="6350" cap="flat" cmpd="sng" algn="ctr">
-                      <a:solidFill>
-                        <a:srgbClr val="C9D1DC"/>
-                      </a:solidFill>
-                      <a:prstDash val="solid"/>
-                      <a:round/>
-                      <a:headEnd type="none" w="med" len="med"/>
-                      <a:tailEnd type="none" w="med" len="med"/>
-                    </a:lnB>
-                    <a:solidFill>
-                      <a:srgbClr val="EEF2F7"/>
-                    </a:solidFill>
-                  </a:tcPr>
-                </a:tc>
-              </a:tr>
-              <a:tr h="265176">
-                <a:tc>
-                  <a:txBody>
-                    <a:bodyPr/>
-                    <a:lstStyle/>
-                    <a:p>
-                      <a:pPr indent="0" marL="0">
-                        <a:buNone/>
-                      </a:pPr>
-                      <a:r>
-                        <a:rPr lang="en-US" sz="900" b="1" dirty="0">
-                          <a:solidFill>
-                            <a:srgbClr val="1B1F3B"/>
-                          </a:solidFill>
-                        </a:rPr>
-                        <a:t>Romatextil</a:t>
-                      </a:r>
-                      <a:endParaRPr lang="en-US" sz="900" dirty="0"/>
-                    </a:p>
-                  </a:txBody>
-                  <a:tcPr marL="45720" marR="45720" marT="45720" marB="45720" anchor="ctr">
-                    <a:lnL w="6350" cap="flat" cmpd="sng" algn="ctr">
-                      <a:solidFill>
-                        <a:srgbClr val="C9D1DC"/>
-                      </a:solidFill>
-                      <a:prstDash val="solid"/>
-                      <a:round/>
-                      <a:headEnd type="none" w="med" len="med"/>
-                      <a:tailEnd type="none" w="med" len="med"/>
-                    </a:lnL>
-                    <a:lnR w="6350" cap="flat" cmpd="sng" algn="ctr">
-                      <a:solidFill>
-                        <a:srgbClr val="C9D1DC"/>
-                      </a:solidFill>
-                      <a:prstDash val="solid"/>
-                      <a:round/>
-                      <a:headEnd type="none" w="med" len="med"/>
-                      <a:tailEnd type="none" w="med" len="med"/>
-                    </a:lnR>
-                    <a:lnT w="6350" cap="flat" cmpd="sng" algn="ctr">
-                      <a:solidFill>
-                        <a:srgbClr val="C9D1DC"/>
-                      </a:solidFill>
-                      <a:prstDash val="solid"/>
-                      <a:round/>
-                      <a:headEnd type="none" w="med" len="med"/>
-                      <a:tailEnd type="none" w="med" len="med"/>
-                    </a:lnT>
-                    <a:lnB w="6350" cap="flat" cmpd="sng" algn="ctr">
-                      <a:solidFill>
-                        <a:srgbClr val="C9D1DC"/>
-                      </a:solidFill>
-                      <a:prstDash val="solid"/>
-                      <a:round/>
-                      <a:headEnd type="none" w="med" len="med"/>
-                      <a:tailEnd type="none" w="med" len="med"/>
-                    </a:lnB>
-                    <a:solidFill>
-                      <a:srgbClr val="FFFFFF"/>
-                    </a:solidFill>
-                  </a:tcPr>
-                </a:tc>
-                <a:tc>
-                  <a:txBody>
-                    <a:bodyPr/>
-                    <a:lstStyle/>
-                    <a:p>
-                      <a:pPr indent="0" marL="0">
-                        <a:buNone/>
-                      </a:pPr>
-                      <a:r>
-                        <a:rPr lang="en-US" sz="900" dirty="0">
-                          <a:solidFill>
-                            <a:srgbClr val="1B1F3B"/>
-                          </a:solidFill>
-                        </a:rPr>
-                        <a:t>Guatemala</a:t>
-                      </a:r>
-                      <a:endParaRPr lang="en-US" sz="900" dirty="0"/>
-                    </a:p>
-                  </a:txBody>
-                  <a:tcPr marL="45720" marR="45720" marT="45720" marB="45720" anchor="ctr">
-                    <a:lnL w="6350" cap="flat" cmpd="sng" algn="ctr">
-                      <a:solidFill>
-                        <a:srgbClr val="C9D1DC"/>
-                      </a:solidFill>
-                      <a:prstDash val="solid"/>
-                      <a:round/>
-                      <a:headEnd type="none" w="med" len="med"/>
-                      <a:tailEnd type="none" w="med" len="med"/>
-                    </a:lnL>
-                    <a:lnR w="6350" cap="flat" cmpd="sng" algn="ctr">
-                      <a:solidFill>
-                        <a:srgbClr val="C9D1DC"/>
-                      </a:solidFill>
-                      <a:prstDash val="solid"/>
-                      <a:round/>
-                      <a:headEnd type="none" w="med" len="med"/>
-                      <a:tailEnd type="none" w="med" len="med"/>
-                    </a:lnR>
-                    <a:lnT w="6350" cap="flat" cmpd="sng" algn="ctr">
-                      <a:solidFill>
-                        <a:srgbClr val="C9D1DC"/>
-                      </a:solidFill>
-                      <a:prstDash val="solid"/>
-                      <a:round/>
-                      <a:headEnd type="none" w="med" len="med"/>
-                      <a:tailEnd type="none" w="med" len="med"/>
-                    </a:lnT>
-                    <a:lnB w="6350" cap="flat" cmpd="sng" algn="ctr">
-                      <a:solidFill>
-                        <a:srgbClr val="C9D1DC"/>
-                      </a:solidFill>
-                      <a:prstDash val="solid"/>
-                      <a:round/>
-                      <a:headEnd type="none" w="med" len="med"/>
-                      <a:tailEnd type="none" w="med" len="med"/>
-                    </a:lnB>
-                    <a:solidFill>
-                      <a:srgbClr val="FFFFFF"/>
                     </a:solidFill>
                   </a:tcPr>
                 </a:tc>
@@ -27699,6 +27514,191 @@
                       <a:tailEnd type="none" w="med" len="med"/>
                     </a:lnB>
                     <a:solidFill>
+                      <a:srgbClr val="EEF2F7"/>
+                    </a:solidFill>
+                  </a:tcPr>
+                </a:tc>
+              </a:tr>
+              <a:tr h="265176">
+                <a:tc>
+                  <a:txBody>
+                    <a:bodyPr/>
+                    <a:lstStyle/>
+                    <a:p>
+                      <a:pPr indent="0" marL="0">
+                        <a:buNone/>
+                      </a:pPr>
+                      <a:r>
+                        <a:rPr lang="en-US" sz="900" b="1" dirty="0">
+                          <a:solidFill>
+                            <a:srgbClr val="1B1F3B"/>
+                          </a:solidFill>
+                        </a:rPr>
+                        <a:t>Gildan Activewear</a:t>
+                      </a:r>
+                      <a:endParaRPr lang="en-US" sz="900" dirty="0"/>
+                    </a:p>
+                  </a:txBody>
+                  <a:tcPr marL="45720" marR="45720" marT="45720" marB="45720" anchor="ctr">
+                    <a:lnL w="6350" cap="flat" cmpd="sng" algn="ctr">
+                      <a:solidFill>
+                        <a:srgbClr val="C9D1DC"/>
+                      </a:solidFill>
+                      <a:prstDash val="solid"/>
+                      <a:round/>
+                      <a:headEnd type="none" w="med" len="med"/>
+                      <a:tailEnd type="none" w="med" len="med"/>
+                    </a:lnL>
+                    <a:lnR w="6350" cap="flat" cmpd="sng" algn="ctr">
+                      <a:solidFill>
+                        <a:srgbClr val="C9D1DC"/>
+                      </a:solidFill>
+                      <a:prstDash val="solid"/>
+                      <a:round/>
+                      <a:headEnd type="none" w="med" len="med"/>
+                      <a:tailEnd type="none" w="med" len="med"/>
+                    </a:lnR>
+                    <a:lnT w="6350" cap="flat" cmpd="sng" algn="ctr">
+                      <a:solidFill>
+                        <a:srgbClr val="C9D1DC"/>
+                      </a:solidFill>
+                      <a:prstDash val="solid"/>
+                      <a:round/>
+                      <a:headEnd type="none" w="med" len="med"/>
+                      <a:tailEnd type="none" w="med" len="med"/>
+                    </a:lnT>
+                    <a:lnB w="6350" cap="flat" cmpd="sng" algn="ctr">
+                      <a:solidFill>
+                        <a:srgbClr val="C9D1DC"/>
+                      </a:solidFill>
+                      <a:prstDash val="solid"/>
+                      <a:round/>
+                      <a:headEnd type="none" w="med" len="med"/>
+                      <a:tailEnd type="none" w="med" len="med"/>
+                    </a:lnB>
+                    <a:solidFill>
+                      <a:srgbClr val="FFFFFF"/>
+                    </a:solidFill>
+                  </a:tcPr>
+                </a:tc>
+                <a:tc>
+                  <a:txBody>
+                    <a:bodyPr/>
+                    <a:lstStyle/>
+                    <a:p>
+                      <a:pPr indent="0" marL="0">
+                        <a:buNone/>
+                      </a:pPr>
+                      <a:r>
+                        <a:rPr lang="en-US" sz="900" dirty="0">
+                          <a:solidFill>
+                            <a:srgbClr val="1B1F3B"/>
+                          </a:solidFill>
+                        </a:rPr>
+                        <a:t>Honduras</a:t>
+                      </a:r>
+                      <a:endParaRPr lang="en-US" sz="900" dirty="0"/>
+                    </a:p>
+                  </a:txBody>
+                  <a:tcPr marL="45720" marR="45720" marT="45720" marB="45720" anchor="ctr">
+                    <a:lnL w="6350" cap="flat" cmpd="sng" algn="ctr">
+                      <a:solidFill>
+                        <a:srgbClr val="C9D1DC"/>
+                      </a:solidFill>
+                      <a:prstDash val="solid"/>
+                      <a:round/>
+                      <a:headEnd type="none" w="med" len="med"/>
+                      <a:tailEnd type="none" w="med" len="med"/>
+                    </a:lnL>
+                    <a:lnR w="6350" cap="flat" cmpd="sng" algn="ctr">
+                      <a:solidFill>
+                        <a:srgbClr val="C9D1DC"/>
+                      </a:solidFill>
+                      <a:prstDash val="solid"/>
+                      <a:round/>
+                      <a:headEnd type="none" w="med" len="med"/>
+                      <a:tailEnd type="none" w="med" len="med"/>
+                    </a:lnR>
+                    <a:lnT w="6350" cap="flat" cmpd="sng" algn="ctr">
+                      <a:solidFill>
+                        <a:srgbClr val="C9D1DC"/>
+                      </a:solidFill>
+                      <a:prstDash val="solid"/>
+                      <a:round/>
+                      <a:headEnd type="none" w="med" len="med"/>
+                      <a:tailEnd type="none" w="med" len="med"/>
+                    </a:lnT>
+                    <a:lnB w="6350" cap="flat" cmpd="sng" algn="ctr">
+                      <a:solidFill>
+                        <a:srgbClr val="C9D1DC"/>
+                      </a:solidFill>
+                      <a:prstDash val="solid"/>
+                      <a:round/>
+                      <a:headEnd type="none" w="med" len="med"/>
+                      <a:tailEnd type="none" w="med" len="med"/>
+                    </a:lnB>
+                    <a:solidFill>
+                      <a:srgbClr val="FFFFFF"/>
+                    </a:solidFill>
+                  </a:tcPr>
+                </a:tc>
+                <a:tc>
+                  <a:txBody>
+                    <a:bodyPr/>
+                    <a:lstStyle/>
+                    <a:p>
+                      <a:pPr indent="0" marL="0">
+                        <a:buNone/>
+                      </a:pPr>
+                      <a:r>
+                        <a:rPr lang="en-US" sz="900" dirty="0">
+                          <a:solidFill>
+                            <a:srgbClr val="1B1F3B"/>
+                          </a:solidFill>
+                        </a:rPr>
+                        <a:t>OEM / full-package contractor</a:t>
+                      </a:r>
+                      <a:endParaRPr lang="en-US" sz="900" dirty="0"/>
+                    </a:p>
+                  </a:txBody>
+                  <a:tcPr marL="45720" marR="45720" marT="45720" marB="45720" anchor="ctr">
+                    <a:lnL w="6350" cap="flat" cmpd="sng" algn="ctr">
+                      <a:solidFill>
+                        <a:srgbClr val="C9D1DC"/>
+                      </a:solidFill>
+                      <a:prstDash val="solid"/>
+                      <a:round/>
+                      <a:headEnd type="none" w="med" len="med"/>
+                      <a:tailEnd type="none" w="med" len="med"/>
+                    </a:lnL>
+                    <a:lnR w="6350" cap="flat" cmpd="sng" algn="ctr">
+                      <a:solidFill>
+                        <a:srgbClr val="C9D1DC"/>
+                      </a:solidFill>
+                      <a:prstDash val="solid"/>
+                      <a:round/>
+                      <a:headEnd type="none" w="med" len="med"/>
+                      <a:tailEnd type="none" w="med" len="med"/>
+                    </a:lnR>
+                    <a:lnT w="6350" cap="flat" cmpd="sng" algn="ctr">
+                      <a:solidFill>
+                        <a:srgbClr val="C9D1DC"/>
+                      </a:solidFill>
+                      <a:prstDash val="solid"/>
+                      <a:round/>
+                      <a:headEnd type="none" w="med" len="med"/>
+                      <a:tailEnd type="none" w="med" len="med"/>
+                    </a:lnT>
+                    <a:lnB w="6350" cap="flat" cmpd="sng" algn="ctr">
+                      <a:solidFill>
+                        <a:srgbClr val="C9D1DC"/>
+                      </a:solidFill>
+                      <a:prstDash val="solid"/>
+                      <a:round/>
+                      <a:headEnd type="none" w="med" len="med"/>
+                      <a:tailEnd type="none" w="med" len="med"/>
+                    </a:lnB>
+                    <a:solidFill>
                       <a:srgbClr val="FFFFFF"/>
                     </a:solidFill>
                   </a:tcPr>
@@ -27738,7 +27738,7 @@
                   <a:schemeClr val="accent5"/>
                 </a:solidFill>
               </a:rPr>
-              <a:t>Caribbean: Gildan DR, The Caribbean Print, Serigrafía Moderna, Willbes Haitian, Uniwell, Sun Island Jamaica.</a:t>
+              <a:t>Focus accounts first (volume printing or M&amp;R / hybrid equipment); the rest of priority A is in the workbook.</a:t>
             </a:r>
             <a:endParaRPr lang="en-US" sz="1000" dirty="0"/>
           </a:p>

</xml_diff>

<commit_message>
Agrega 34 prospectos de Brasil y regenera Excel, estudio, mapas y plan de marketing
Co-Authored-By: Claude Opus 5.5 <noreply@anthropic.com>
Claude-Session: https://claude.ai/code/session_012axCVDM5kAgj1VFnxhpsuM
</commit_message>
<xml_diff>
--- a/propuesta-clt/CLT_Market_Study_Mexico_Latam_EN.pptx
+++ b/propuesta-clt/CLT_Market_Study_Mexico_Latam_EN.pptx
@@ -143,20 +143,20 @@
   <p:extLst>
     <p:ext uri="{521415D9-36F7-43E2-AB2F-B90AF26B5E84}">
       <p14:sectionLst xmlns:p14="http://schemas.microsoft.com/office/powerpoint/2010/main">
-        <p14:section name="Opening" id="{50353cc7-c5f9-1bd2-fbba-676110092727}">
+        <p14:section name="Opening" id="{d5bb2592-f380-7357-cad7-ddd68e4d7ecd}">
           <p14:sldIdLst>
             <p14:sldId id="256"/>
             <p14:sldId id="257"/>
             <p14:sldId id="258"/>
           </p14:sldIdLst>
         </p14:section>
-        <p14:section name="Scope and methodology" id="{7b1f1745-bdeb-cdcd-8995-0af426c0fbc9}">
+        <p14:section name="Scope and methodology" id="{1611a80b-0d95-ed4f-bebd-666f87894a7d}">
           <p14:sldIdLst>
             <p14:sldId id="259"/>
             <p14:sldId id="260"/>
           </p14:sldIdLst>
         </p14:section>
-        <p14:section name="The manufacturer: CLT" id="{c25c5a83-3467-3d38-073e-341e8b3d0952}">
+        <p14:section name="The manufacturer: CLT" id="{198b412e-3a3e-8468-2d4a-a53d1df1ccaf}">
           <p14:sldIdLst>
             <p14:sldId id="261"/>
             <p14:sldId id="262"/>
@@ -168,7 +168,7 @@
             <p14:sldId id="268"/>
           </p14:sldIdLst>
         </p14:section>
-        <p14:section name="Mexican market" id="{c9b58469-ce55-d30b-e07f-c08589d189dd}">
+        <p14:section name="Mexican market" id="{d0870826-894d-9775-6427-9a2c2c16dbea}">
           <p14:sldIdLst>
             <p14:sldId id="269"/>
             <p14:sldId id="270"/>
@@ -178,14 +178,14 @@
             <p14:sldId id="274"/>
           </p14:sldIdLst>
         </p14:section>
-        <p14:section name="Priority accounts" id="{57d9810e-2d02-c46c-dfbb-722c3a3ac851}">
+        <p14:section name="Priority accounts" id="{5a2bfdaa-a3c3-c152-2dbe-e59c3faee96d}">
           <p14:sldIdLst>
             <p14:sldId id="275"/>
             <p14:sldId id="276"/>
             <p14:sldId id="277"/>
           </p14:sldIdLst>
         </p14:section>
-        <p14:section name="Competition" id="{e60c350f-1b8a-c39f-1b39-245a486b8921}">
+        <p14:section name="Competition" id="{f87928c0-dd4a-b182-e99b-a7c191d77c15}">
           <p14:sldIdLst>
             <p14:sldId id="278"/>
             <p14:sldId id="279"/>
@@ -194,13 +194,13 @@
             <p14:sldId id="282"/>
           </p14:sldIdLst>
         </p14:section>
-        <p14:section name="Trade" id="{043118cc-3c08-c8ee-c2a7-ef516cde0401}">
+        <p14:section name="Trade" id="{b56de99a-30e3-e510-4f89-b77d7708a8c1}">
           <p14:sldIdLst>
             <p14:sldId id="283"/>
             <p14:sldId id="284"/>
           </p14:sldIdLst>
         </p14:section>
-        <p14:section name="Latin America and the U.S." id="{aa063a21-bf0d-7a94-c3fd-f7a20c9202bb}">
+        <p14:section name="Latin America and the U.S." id="{25839813-cf15-4e66-82cf-51fd98e209c8}">
           <p14:sldIdLst>
             <p14:sldId id="285"/>
             <p14:sldId id="286"/>
@@ -208,7 +208,7 @@
             <p14:sldId id="288"/>
           </p14:sldIdLst>
         </p14:section>
-        <p14:section name="Conclusions" id="{88cfa3b3-9226-c1a5-3773-5c759c024183}">
+        <p14:section name="Conclusions" id="{767ba8e3-0d45-1b1c-f618-441d00483fb9}">
           <p14:sldIdLst>
             <p14:sldId id="289"/>
             <p14:sldId id="290"/>
@@ -1452,7 +1452,7 @@
                   <c:v>6</c:v>
                 </c:pt>
                 <c:pt idx="2">
-                  <c:v>7</c:v>
+                  <c:v>25</c:v>
                 </c:pt>
               </c:numCache>
             </c:numRef>
@@ -1535,7 +1535,7 @@
                   <c:v>16</c:v>
                 </c:pt>
                 <c:pt idx="2">
-                  <c:v>17</c:v>
+                  <c:v>40</c:v>
                 </c:pt>
               </c:numCache>
             </c:numRef>
@@ -1618,7 +1618,7 @@
                   <c:v>11</c:v>
                 </c:pt>
                 <c:pt idx="2">
-                  <c:v>18</c:v>
+                  <c:v>38</c:v>
                 </c:pt>
               </c:numCache>
             </c:numRef>
@@ -12050,7 +12050,7 @@
                   <a:srgbClr val="B38600"/>
                 </a:solidFill>
               </a:rPr>
-              <a:t>119</a:t>
+              <a:t>180</a:t>
             </a:r>
             <a:endParaRPr lang="en-US" sz="3000" dirty="0"/>
           </a:p>
@@ -24923,7 +24923,7 @@
                   <a:schemeClr val="tx1"/>
                 </a:solidFill>
               </a:rPr>
-              <a:t>Latin America: 119 prospects in 16 countries</a:t>
+              <a:t>Latin America: 180 prospects in 16 countries</a:t>
             </a:r>
             <a:endParaRPr lang="en-US" sz="2600" dirty="0"/>
           </a:p>
@@ -24975,7 +24975,7 @@
                   <a:schemeClr val="accent1"/>
                 </a:solidFill>
               </a:rPr>
-              <a:t>24</a:t>
+              <a:t>42</a:t>
             </a:r>
             <a:endParaRPr lang="en-US" sz="3000" dirty="0"/>
           </a:p>
@@ -25119,7 +25119,7 @@
                   <a:schemeClr val="accent1"/>
                 </a:solidFill>
               </a:rPr>
-              <a:t>19 + 14</a:t>
+              <a:t>41 + 35</a:t>
             </a:r>
             <a:endParaRPr lang="en-US" sz="3000" dirty="0"/>
           </a:p>
@@ -25155,7 +25155,7 @@
                   <a:schemeClr val="tx2"/>
                 </a:solidFill>
               </a:rPr>
-              <a:t>Peru and Colombia</a:t>
+              <a:t>Colombia and Brazil</a:t>
             </a:r>
             <a:endParaRPr lang="en-US" sz="1200" dirty="0"/>
           </a:p>
@@ -26979,7 +26979,7 @@
                             <a:srgbClr val="1B1F3B"/>
                           </a:solidFill>
                         </a:rPr>
-                        <a:t>Serigrafía Moderna</a:t>
+                        <a:t>Grupo Malwee</a:t>
                       </a:r>
                       <a:endParaRPr lang="en-US" sz="900" dirty="0"/>
                     </a:p>
@@ -27040,7 +27040,7 @@
                             <a:srgbClr val="1B1F3B"/>
                           </a:solidFill>
                         </a:rPr>
-                        <a:t>República Dominicana</a:t>
+                        <a:t>Brasil</a:t>
                       </a:r>
                       <a:endParaRPr lang="en-US" sz="900" dirty="0"/>
                     </a:p>
@@ -27101,7 +27101,7 @@
                             <a:srgbClr val="1B1F3B"/>
                           </a:solidFill>
                         </a:rPr>
-                        <a:t>Contract printer</a:t>
+                        <a:t>Marca de moda</a:t>
                       </a:r>
                       <a:endParaRPr lang="en-US" sz="900" dirty="0"/>
                     </a:p>
@@ -27164,7 +27164,7 @@
                             <a:srgbClr val="1B1F3B"/>
                           </a:solidFill>
                         </a:rPr>
-                        <a:t>Uniwell Apparel</a:t>
+                        <a:t>Lunelli</a:t>
                       </a:r>
                       <a:endParaRPr lang="en-US" sz="900" dirty="0"/>
                     </a:p>
@@ -27225,7 +27225,7 @@
                             <a:srgbClr val="1B1F3B"/>
                           </a:solidFill>
                         </a:rPr>
-                        <a:t>Haití</a:t>
+                        <a:t>Brasil</a:t>
                       </a:r>
                       <a:endParaRPr lang="en-US" sz="900" dirty="0"/>
                     </a:p>
@@ -27286,7 +27286,7 @@
                             <a:srgbClr val="1B1F3B"/>
                           </a:solidFill>
                         </a:rPr>
-                        <a:t>OEM / full-package contractor</a:t>
+                        <a:t>Marca de moda</a:t>
                       </a:r>
                       <a:endParaRPr lang="en-US" sz="900" dirty="0"/>
                     </a:p>
@@ -27349,7 +27349,7 @@
                             <a:srgbClr val="1B1F3B"/>
                           </a:solidFill>
                         </a:rPr>
-                        <a:t>Sun Island Jamaica Ltd.</a:t>
+                        <a:t>Grupo Kyly</a:t>
                       </a:r>
                       <a:endParaRPr lang="en-US" sz="900" dirty="0"/>
                     </a:p>
@@ -27410,7 +27410,7 @@
                             <a:srgbClr val="1B1F3B"/>
                           </a:solidFill>
                         </a:rPr>
-                        <a:t>Jamaica</a:t>
+                        <a:t>Brasil</a:t>
                       </a:r>
                       <a:endParaRPr lang="en-US" sz="900" dirty="0"/>
                     </a:p>
@@ -27471,7 +27471,7 @@
                             <a:srgbClr val="1B1F3B"/>
                           </a:solidFill>
                         </a:rPr>
-                        <a:t>Sportswear / uniform maker</a:t>
+                        <a:t>Marca de moda</a:t>
                       </a:r>
                       <a:endParaRPr lang="en-US" sz="900" dirty="0"/>
                     </a:p>
@@ -27534,7 +27534,7 @@
                             <a:srgbClr val="1B1F3B"/>
                           </a:solidFill>
                         </a:rPr>
-                        <a:t>Gildan Activewear</a:t>
+                        <a:t>Brandili Têxtil</a:t>
                       </a:r>
                       <a:endParaRPr lang="en-US" sz="900" dirty="0"/>
                     </a:p>
@@ -27595,7 +27595,7 @@
                             <a:srgbClr val="1B1F3B"/>
                           </a:solidFill>
                         </a:rPr>
-                        <a:t>Honduras</a:t>
+                        <a:t>Brasil</a:t>
                       </a:r>
                       <a:endParaRPr lang="en-US" sz="900" dirty="0"/>
                     </a:p>
@@ -27656,7 +27656,7 @@
                             <a:srgbClr val="1B1F3B"/>
                           </a:solidFill>
                         </a:rPr>
-                        <a:t>OEM / full-package contractor</a:t>
+                        <a:t>Marca de moda</a:t>
                       </a:r>
                       <a:endParaRPr lang="en-US" sz="900" dirty="0"/>
                     </a:p>

</xml_diff>

<commit_message>
Agrega mapas LATAM al estudio de mercado (ES/EN) y hoja Mapas al plan de marketing
Co-Authored-By: Claude Opus 5.5 <noreply@anthropic.com>
Claude-Session: https://claude.ai/code/session_012axCVDM5kAgj1VFnxhpsuM
</commit_message>
<xml_diff>
--- a/propuesta-clt/CLT_Market_Study_Mexico_Latam_EN.pptx
+++ b/propuesta-clt/CLT_Market_Study_Mexico_Latam_EN.pptx
@@ -42,9 +42,11 @@
     <p:sldId id="290" r:id="rId36"/>
     <p:sldId id="291" r:id="rId37"/>
     <p:sldId id="292" r:id="rId38"/>
+    <p:sldId id="293" r:id="rId39"/>
+    <p:sldId id="294" r:id="rId40"/>
   </p:sldIdLst>
   <p:notesMasterIdLst>
-    <p:notesMasterId r:id="rId39"/>
+    <p:notesMasterId r:id="rId41"/>
   </p:notesMasterIdLst>
   <p:sldSz cx="9144000" cy="5143500"/>
   <p:notesSz cx="5143500" cy="9144000"/>
@@ -143,20 +145,20 @@
   <p:extLst>
     <p:ext uri="{521415D9-36F7-43E2-AB2F-B90AF26B5E84}">
       <p14:sectionLst xmlns:p14="http://schemas.microsoft.com/office/powerpoint/2010/main">
-        <p14:section name="Opening" id="{d5bb2592-f380-7357-cad7-ddd68e4d7ecd}">
+        <p14:section name="Opening" id="{d491546d-b0fa-babb-47ef-a81b1d32190d}">
           <p14:sldIdLst>
             <p14:sldId id="256"/>
             <p14:sldId id="257"/>
             <p14:sldId id="258"/>
           </p14:sldIdLst>
         </p14:section>
-        <p14:section name="Scope and methodology" id="{1611a80b-0d95-ed4f-bebd-666f87894a7d}">
+        <p14:section name="Scope and methodology" id="{1aeac795-6aaa-1a36-0f61-81bcca3744dd}">
           <p14:sldIdLst>
             <p14:sldId id="259"/>
             <p14:sldId id="260"/>
           </p14:sldIdLst>
         </p14:section>
-        <p14:section name="The manufacturer: CLT" id="{198b412e-3a3e-8468-2d4a-a53d1df1ccaf}">
+        <p14:section name="The manufacturer: CLT" id="{2f725a22-de04-c718-efcd-02103b0c3e1b}">
           <p14:sldIdLst>
             <p14:sldId id="261"/>
             <p14:sldId id="262"/>
@@ -168,7 +170,7 @@
             <p14:sldId id="268"/>
           </p14:sldIdLst>
         </p14:section>
-        <p14:section name="Mexican market" id="{d0870826-894d-9775-6427-9a2c2c16dbea}">
+        <p14:section name="Mexican market" id="{a590c268-d971-b815-cb77-aa4507ff8c7c}">
           <p14:sldIdLst>
             <p14:sldId id="269"/>
             <p14:sldId id="270"/>
@@ -178,14 +180,14 @@
             <p14:sldId id="274"/>
           </p14:sldIdLst>
         </p14:section>
-        <p14:section name="Priority accounts" id="{5a2bfdaa-a3c3-c152-2dbe-e59c3faee96d}">
+        <p14:section name="Priority accounts" id="{d8ea4643-2865-00be-c411-e423f78623b2}">
           <p14:sldIdLst>
             <p14:sldId id="275"/>
             <p14:sldId id="276"/>
             <p14:sldId id="277"/>
           </p14:sldIdLst>
         </p14:section>
-        <p14:section name="Competition" id="{f87928c0-dd4a-b182-e99b-a7c191d77c15}">
+        <p14:section name="Competition" id="{eb9d7040-1373-fb08-15f7-9129769f8cd7}">
           <p14:sldIdLst>
             <p14:sldId id="278"/>
             <p14:sldId id="279"/>
@@ -194,26 +196,28 @@
             <p14:sldId id="282"/>
           </p14:sldIdLst>
         </p14:section>
-        <p14:section name="Trade" id="{b56de99a-30e3-e510-4f89-b77d7708a8c1}">
+        <p14:section name="Trade" id="{1ddbb390-05ff-dd3b-9e77-76a2be24c2ae}">
           <p14:sldIdLst>
             <p14:sldId id="283"/>
             <p14:sldId id="284"/>
           </p14:sldIdLst>
         </p14:section>
-        <p14:section name="Latin America and the U.S." id="{25839813-cf15-4e66-82cf-51fd98e209c8}">
+        <p14:section name="Latin America and the U.S." id="{0f54ed07-18ad-7089-23eb-ee40c8147dd0}">
           <p14:sldIdLst>
             <p14:sldId id="285"/>
             <p14:sldId id="286"/>
             <p14:sldId id="287"/>
             <p14:sldId id="288"/>
+            <p14:sldId id="289"/>
+            <p14:sldId id="290"/>
           </p14:sldIdLst>
         </p14:section>
-        <p14:section name="Conclusions" id="{767ba8e3-0d45-1b1c-f618-441d00483fb9}">
+        <p14:section name="Conclusions" id="{c14d7c04-a31f-8866-c1bf-a32f98382a1f}">
           <p14:sldIdLst>
-            <p14:sldId id="289"/>
-            <p14:sldId id="290"/>
             <p14:sldId id="291"/>
             <p14:sldId id="292"/>
+            <p14:sldId id="293"/>
+            <p14:sldId id="294"/>
           </p14:sldIdLst>
         </p14:section>
       </p14:sectionLst>
@@ -4863,6 +4867,182 @@
 </p:notes>
 </file>
 
+<file path=ppt/notesSlides/notesSlide38.xml><?xml version="1.0" encoding="utf-8"?>
+<p:notes xmlns:a="http://schemas.openxmlformats.org/drawingml/2006/main" xmlns:r="http://schemas.openxmlformats.org/officeDocument/2006/relationships" xmlns:p="http://schemas.openxmlformats.org/presentationml/2006/main">
+  <p:cSld>
+    <p:spTree>
+      <p:nvGrpSpPr>
+        <p:cNvPr id="1" name=""/>
+        <p:cNvGrpSpPr/>
+        <p:nvPr/>
+      </p:nvGrpSpPr>
+      <p:grpSpPr>
+        <a:xfrm>
+          <a:off x="0" y="0"/>
+          <a:ext cx="0" cy="0"/>
+          <a:chOff x="0" y="0"/>
+          <a:chExt cx="0" cy="0"/>
+        </a:xfrm>
+      </p:grpSpPr>
+      <p:sp>
+        <p:nvSpPr>
+          <p:cNvPr id="2" name="Slide Image Placeholder 1"/>
+          <p:cNvSpPr>
+            <a:spLocks noGrp="1" noRot="1" noChangeAspect="1"/>
+          </p:cNvSpPr>
+          <p:nvPr>
+            <p:ph type="sldImg"/>
+          </p:nvPr>
+        </p:nvSpPr>
+        <p:spPr/>
+      </p:sp>
+      <p:sp>
+        <p:nvSpPr>
+          <p:cNvPr id="3" name="Notes Placeholder 2"/>
+          <p:cNvSpPr>
+            <a:spLocks noGrp="1"/>
+          </p:cNvSpPr>
+          <p:nvPr>
+            <p:ph type="body" idx="1"/>
+          </p:nvPr>
+        </p:nvSpPr>
+        <p:spPr/>
+        <p:txBody>
+          <a:bodyPr/>
+          <a:lstStyle/>
+          <a:p>
+            <a:r>
+              <a:rPr lang="en-US" dirty="0"/>
+              <a:t/>
+            </a:r>
+            <a:endParaRPr lang="en-US" dirty="0"/>
+          </a:p>
+        </p:txBody>
+      </p:sp>
+      <p:sp>
+        <p:nvSpPr>
+          <p:cNvPr id="4" name="Slide Number Placeholder 3"/>
+          <p:cNvSpPr>
+            <a:spLocks noGrp="1"/>
+          </p:cNvSpPr>
+          <p:nvPr>
+            <p:ph type="sldNum" sz="quarter" idx="10"/>
+          </p:nvPr>
+        </p:nvSpPr>
+        <p:spPr/>
+        <p:txBody>
+          <a:bodyPr/>
+          <a:lstStyle/>
+          <a:p>
+            <a:fld id="{F7021451-1387-4CA6-816F-3879F97B5CBC}" type="slidenum">
+              <a:rPr lang="en-US"/>
+              <a:t>38</a:t>
+            </a:fld>
+            <a:endParaRPr lang="en-US"/>
+          </a:p>
+        </p:txBody>
+      </p:sp>
+    </p:spTree>
+    <p:extLst>
+      <p:ext uri="{BB962C8B-B14F-4D97-AF65-F5344CB8AC3E}">
+        <p14:creationId xmlns:p14="http://schemas.microsoft.com/office/powerpoint/2010/main" val="1024086991"/>
+      </p:ext>
+    </p:extLst>
+  </p:cSld>
+  <p:clrMapOvr>
+    <a:masterClrMapping/>
+  </p:clrMapOvr>
+</p:notes>
+</file>
+
+<file path=ppt/notesSlides/notesSlide39.xml><?xml version="1.0" encoding="utf-8"?>
+<p:notes xmlns:a="http://schemas.openxmlformats.org/drawingml/2006/main" xmlns:r="http://schemas.openxmlformats.org/officeDocument/2006/relationships" xmlns:p="http://schemas.openxmlformats.org/presentationml/2006/main">
+  <p:cSld>
+    <p:spTree>
+      <p:nvGrpSpPr>
+        <p:cNvPr id="1" name=""/>
+        <p:cNvGrpSpPr/>
+        <p:nvPr/>
+      </p:nvGrpSpPr>
+      <p:grpSpPr>
+        <a:xfrm>
+          <a:off x="0" y="0"/>
+          <a:ext cx="0" cy="0"/>
+          <a:chOff x="0" y="0"/>
+          <a:chExt cx="0" cy="0"/>
+        </a:xfrm>
+      </p:grpSpPr>
+      <p:sp>
+        <p:nvSpPr>
+          <p:cNvPr id="2" name="Slide Image Placeholder 1"/>
+          <p:cNvSpPr>
+            <a:spLocks noGrp="1" noRot="1" noChangeAspect="1"/>
+          </p:cNvSpPr>
+          <p:nvPr>
+            <p:ph type="sldImg"/>
+          </p:nvPr>
+        </p:nvSpPr>
+        <p:spPr/>
+      </p:sp>
+      <p:sp>
+        <p:nvSpPr>
+          <p:cNvPr id="3" name="Notes Placeholder 2"/>
+          <p:cNvSpPr>
+            <a:spLocks noGrp="1"/>
+          </p:cNvSpPr>
+          <p:nvPr>
+            <p:ph type="body" idx="1"/>
+          </p:nvPr>
+        </p:nvSpPr>
+        <p:spPr/>
+        <p:txBody>
+          <a:bodyPr/>
+          <a:lstStyle/>
+          <a:p>
+            <a:r>
+              <a:rPr lang="en-US" dirty="0"/>
+              <a:t/>
+            </a:r>
+            <a:endParaRPr lang="en-US" dirty="0"/>
+          </a:p>
+        </p:txBody>
+      </p:sp>
+      <p:sp>
+        <p:nvSpPr>
+          <p:cNvPr id="4" name="Slide Number Placeholder 3"/>
+          <p:cNvSpPr>
+            <a:spLocks noGrp="1"/>
+          </p:cNvSpPr>
+          <p:nvPr>
+            <p:ph type="sldNum" sz="quarter" idx="10"/>
+          </p:nvPr>
+        </p:nvSpPr>
+        <p:spPr/>
+        <p:txBody>
+          <a:bodyPr/>
+          <a:lstStyle/>
+          <a:p>
+            <a:fld id="{F7021451-1387-4CA6-816F-3879F97B5CBC}" type="slidenum">
+              <a:rPr lang="en-US"/>
+              <a:t>39</a:t>
+            </a:fld>
+            <a:endParaRPr lang="en-US"/>
+          </a:p>
+        </p:txBody>
+      </p:sp>
+    </p:spTree>
+    <p:extLst>
+      <p:ext uri="{BB962C8B-B14F-4D97-AF65-F5344CB8AC3E}">
+        <p14:creationId xmlns:p14="http://schemas.microsoft.com/office/powerpoint/2010/main" val="1024086991"/>
+      </p:ext>
+    </p:extLst>
+  </p:cSld>
+  <p:clrMapOvr>
+    <a:masterClrMapping/>
+  </p:clrMapOvr>
+</p:notes>
+</file>
+
 <file path=ppt/notesSlides/notesSlide4.xml><?xml version="1.0" encoding="utf-8"?>
 <p:notes xmlns:a="http://schemas.openxmlformats.org/drawingml/2006/main" xmlns:r="http://schemas.openxmlformats.org/officeDocument/2006/relationships" xmlns:p="http://schemas.openxmlformats.org/presentationml/2006/main">
   <p:cSld>
@@ -27849,110 +28029,46 @@
                   <a:schemeClr val="tx1"/>
                 </a:solidFill>
               </a:rPr>
-              <a:t>Expansion path</a:t>
+              <a:t>LATAM map: OEM prospects (export contract manufacturing)</a:t>
             </a:r>
             <a:endParaRPr lang="en-US" sz="2600" dirty="0"/>
           </a:p>
         </p:txBody>
       </p:sp>
-      <p:sp>
-        <p:nvSpPr>
-          <p:cNvPr id="3" name="Shape 1"/>
-          <p:cNvSpPr/>
-          <p:nvPr/>
-        </p:nvSpPr>
-        <p:spPr>
-          <a:xfrm>
-            <a:off x="457200" y="1097280"/>
-            <a:ext cx="2606040" cy="2377440"/>
-          </a:xfrm>
-          <a:prstGeom prst="roundRect">
-            <a:avLst>
-              <a:gd name="adj" fmla="val 3077"/>
-            </a:avLst>
-          </a:prstGeom>
-          <a:solidFill>
-            <a:srgbClr val="EEF2F7"/>
-          </a:solidFill>
-          <a:ln w="12700">
-            <a:solidFill>
-              <a:srgbClr val="EEF2F7"/>
-            </a:solidFill>
-            <a:prstDash val="solid"/>
-          </a:ln>
-        </p:spPr>
-      </p:sp>
-      <p:sp>
-        <p:nvSpPr>
-          <p:cNvPr id="4" name="Shape 2"/>
-          <p:cNvSpPr/>
-          <p:nvPr/>
-        </p:nvSpPr>
-        <p:spPr>
-          <a:xfrm>
-            <a:off x="640080" y="1261872"/>
-            <a:ext cx="384048" cy="384048"/>
-          </a:xfrm>
-          <a:prstGeom prst="ellipse">
-            <a:avLst/>
-          </a:prstGeom>
-          <a:solidFill>
-            <a:srgbClr val="0089C2"/>
-          </a:solidFill>
-          <a:ln w="12700">
-            <a:solidFill>
-              <a:srgbClr val="0089C2"/>
-            </a:solidFill>
-            <a:prstDash val="solid"/>
-          </a:ln>
-        </p:spPr>
-      </p:sp>
-      <p:sp>
-        <p:nvSpPr>
-          <p:cNvPr id="5" name="Text 3"/>
+      <p:pic>
+        <p:nvPicPr>
+          <p:cNvPr id="3" name="Image 0" descr="LATAM map: OEM prospects (export contract manufacturing)">    </p:cNvPr>
+          <p:cNvPicPr>
+            <a:picLocks noChangeAspect="1"/>
+          </p:cNvPicPr>
+          <p:nvPr/>
+        </p:nvPicPr>
+        <p:blipFill>
+          <a:blip r:embed="rId1"/>
+          <a:stretch>
+            <a:fillRect/>
+          </a:stretch>
+        </p:blipFill>
+        <p:spPr>
+          <a:xfrm>
+            <a:off x="1252728" y="914400"/>
+            <a:ext cx="6638544" cy="3429000"/>
+          </a:xfrm>
+          <a:prstGeom prst="rect">
+            <a:avLst/>
+          </a:prstGeom>
+        </p:spPr>
+      </p:pic>
+      <p:sp>
+        <p:nvSpPr>
+          <p:cNvPr id="4" name="Text 1"/>
           <p:cNvSpPr txBox="1"/>
           <p:nvPr/>
         </p:nvSpPr>
         <p:spPr>
           <a:xfrm>
-            <a:off x="640080" y="1261872"/>
-            <a:ext cx="384048" cy="384048"/>
-          </a:xfrm>
-          <a:prstGeom prst="rect">
-            <a:avLst/>
-          </a:prstGeom>
-          <a:noFill/>
-          <a:ln/>
-        </p:spPr>
-        <p:txBody>
-          <a:bodyPr wrap="square" lIns="0" tIns="0" rIns="0" bIns="0" rtlCol="0" anchor="ctr"/>
-          <a:lstStyle/>
-          <a:p>
-            <a:pPr algn="ctr" indent="0" marL="0">
-              <a:buNone/>
-            </a:pPr>
-            <a:r>
-              <a:rPr lang="en-US" sz="1300" b="1" dirty="0">
-                <a:solidFill>
-                  <a:srgbClr val="FFFFFF"/>
-                </a:solidFill>
-              </a:rPr>
-              <a:t>1</a:t>
-            </a:r>
-            <a:endParaRPr lang="en-US" sz="1300" dirty="0"/>
-          </a:p>
-        </p:txBody>
-      </p:sp>
-      <p:sp>
-        <p:nvSpPr>
-          <p:cNvPr id="6" name="Text 4"/>
-          <p:cNvSpPr txBox="1"/>
-          <p:nvPr/>
-        </p:nvSpPr>
-        <p:spPr>
-          <a:xfrm>
-            <a:off x="1143000" y="1261872"/>
-            <a:ext cx="1828800" cy="384048"/>
+            <a:off x="457200" y="4480560"/>
+            <a:ext cx="8229600" cy="274320"/>
           </a:xfrm>
           <a:prstGeom prst="rect">
             <a:avLst/>
@@ -27968,541 +28084,14 @@
               <a:buNone/>
             </a:pPr>
             <a:r>
-              <a:rPr lang="en-US" sz="1300" b="1" dirty="0">
+              <a:rPr lang="en-US" sz="1000" i="1" dirty="0">
                 <a:solidFill>
-                  <a:schemeClr val="accent1"/>
+                  <a:schemeClr val="accent5"/>
                 </a:solidFill>
               </a:rPr>
-              <a:t>Wave 1 · years 2–3</a:t>
+              <a:t>Gold star: 80/20 account in Mexico or priority A elsewhere in LATAM. Numbered account list in mapas/ and in the prospects workbook.</a:t>
             </a:r>
-            <a:endParaRPr lang="en-US" sz="1300" dirty="0"/>
-          </a:p>
-        </p:txBody>
-      </p:sp>
-      <p:sp>
-        <p:nvSpPr>
-          <p:cNvPr id="7" name="Text 5"/>
-          <p:cNvSpPr txBox="1"/>
-          <p:nvPr/>
-        </p:nvSpPr>
-        <p:spPr>
-          <a:xfrm>
-            <a:off x="640080" y="1783080"/>
-            <a:ext cx="2286000" cy="548640"/>
-          </a:xfrm>
-          <a:prstGeom prst="rect">
-            <a:avLst/>
-          </a:prstGeom>
-          <a:noFill/>
-          <a:ln/>
-        </p:spPr>
-        <p:txBody>
-          <a:bodyPr wrap="square" lIns="0" tIns="0" rIns="0" bIns="0" rtlCol="0" anchor="t"/>
-          <a:lstStyle/>
-          <a:p>
-            <a:pPr indent="0" marL="0">
-              <a:buNone/>
-            </a:pPr>
-            <a:r>
-              <a:rPr lang="en-US" sz="1500" b="1" dirty="0">
-                <a:solidFill>
-                  <a:schemeClr val="tx1"/>
-                </a:solidFill>
-              </a:rPr>
-              <a:t>El Salvador, Honduras, Guatemala</a:t>
-            </a:r>
-            <a:endParaRPr lang="en-US" sz="1500" dirty="0"/>
-          </a:p>
-        </p:txBody>
-      </p:sp>
-      <p:sp>
-        <p:nvSpPr>
-          <p:cNvPr id="8" name="Text 6"/>
-          <p:cNvSpPr txBox="1"/>
-          <p:nvPr/>
-        </p:nvSpPr>
-        <p:spPr>
-          <a:xfrm>
-            <a:off x="640080" y="2377440"/>
-            <a:ext cx="2286000" cy="1005840"/>
-          </a:xfrm>
-          <a:prstGeom prst="rect">
-            <a:avLst/>
-          </a:prstGeom>
-          <a:noFill/>
-          <a:ln/>
-        </p:spPr>
-        <p:txBody>
-          <a:bodyPr wrap="square" lIns="0" tIns="0" rIns="0" bIns="0" rtlCol="0" anchor="t"/>
-          <a:lstStyle/>
-          <a:p>
-            <a:pPr indent="0" marL="0">
-              <a:buNone/>
-            </a:pPr>
-            <a:r>
-              <a:rPr lang="en-US" sz="1200" dirty="0">
-                <a:solidFill>
-                  <a:schemeClr val="tx2"/>
-                </a:solidFill>
-              </a:rPr>
-              <a:t>Contractors printing for Hanes, Gildan, Tegra; sold from Mexico</a:t>
-            </a:r>
-            <a:endParaRPr lang="en-US" sz="1200" dirty="0"/>
-          </a:p>
-        </p:txBody>
-      </p:sp>
-      <p:sp>
-        <p:nvSpPr>
-          <p:cNvPr id="9" name="Shape 7"/>
-          <p:cNvSpPr/>
-          <p:nvPr/>
-        </p:nvSpPr>
-        <p:spPr>
-          <a:xfrm>
-            <a:off x="3246120" y="1097280"/>
-            <a:ext cx="2606040" cy="2377440"/>
-          </a:xfrm>
-          <a:prstGeom prst="roundRect">
-            <a:avLst>
-              <a:gd name="adj" fmla="val 3077"/>
-            </a:avLst>
-          </a:prstGeom>
-          <a:solidFill>
-            <a:srgbClr val="EEF2F7"/>
-          </a:solidFill>
-          <a:ln w="12700">
-            <a:solidFill>
-              <a:srgbClr val="EEF2F7"/>
-            </a:solidFill>
-            <a:prstDash val="solid"/>
-          </a:ln>
-        </p:spPr>
-      </p:sp>
-      <p:sp>
-        <p:nvSpPr>
-          <p:cNvPr id="10" name="Shape 8"/>
-          <p:cNvSpPr/>
-          <p:nvPr/>
-        </p:nvSpPr>
-        <p:spPr>
-          <a:xfrm>
-            <a:off x="3429000" y="1261872"/>
-            <a:ext cx="384048" cy="384048"/>
-          </a:xfrm>
-          <a:prstGeom prst="ellipse">
-            <a:avLst/>
-          </a:prstGeom>
-          <a:solidFill>
-            <a:srgbClr val="C2185B"/>
-          </a:solidFill>
-          <a:ln w="12700">
-            <a:solidFill>
-              <a:srgbClr val="C2185B"/>
-            </a:solidFill>
-            <a:prstDash val="solid"/>
-          </a:ln>
-        </p:spPr>
-      </p:sp>
-      <p:sp>
-        <p:nvSpPr>
-          <p:cNvPr id="11" name="Text 9"/>
-          <p:cNvSpPr txBox="1"/>
-          <p:nvPr/>
-        </p:nvSpPr>
-        <p:spPr>
-          <a:xfrm>
-            <a:off x="3429000" y="1261872"/>
-            <a:ext cx="384048" cy="384048"/>
-          </a:xfrm>
-          <a:prstGeom prst="rect">
-            <a:avLst/>
-          </a:prstGeom>
-          <a:noFill/>
-          <a:ln/>
-        </p:spPr>
-        <p:txBody>
-          <a:bodyPr wrap="square" lIns="0" tIns="0" rIns="0" bIns="0" rtlCol="0" anchor="ctr"/>
-          <a:lstStyle/>
-          <a:p>
-            <a:pPr algn="ctr" indent="0" marL="0">
-              <a:buNone/>
-            </a:pPr>
-            <a:r>
-              <a:rPr lang="en-US" sz="1300" b="1" dirty="0">
-                <a:solidFill>
-                  <a:srgbClr val="FFFFFF"/>
-                </a:solidFill>
-              </a:rPr>
-              <a:t>2</a:t>
-            </a:r>
-            <a:endParaRPr lang="en-US" sz="1300" dirty="0"/>
-          </a:p>
-        </p:txBody>
-      </p:sp>
-      <p:sp>
-        <p:nvSpPr>
-          <p:cNvPr id="12" name="Text 10"/>
-          <p:cNvSpPr txBox="1"/>
-          <p:nvPr/>
-        </p:nvSpPr>
-        <p:spPr>
-          <a:xfrm>
-            <a:off x="3931920" y="1261872"/>
-            <a:ext cx="1828800" cy="384048"/>
-          </a:xfrm>
-          <a:prstGeom prst="rect">
-            <a:avLst/>
-          </a:prstGeom>
-          <a:noFill/>
-          <a:ln/>
-        </p:spPr>
-        <p:txBody>
-          <a:bodyPr wrap="square" lIns="0" tIns="0" rIns="0" bIns="0" rtlCol="0" anchor="ctr"/>
-          <a:lstStyle/>
-          <a:p>
-            <a:pPr indent="0" marL="0">
-              <a:buNone/>
-            </a:pPr>
-            <a:r>
-              <a:rPr lang="en-US" sz="1300" b="1" dirty="0">
-                <a:solidFill>
-                  <a:schemeClr val="accent1"/>
-                </a:solidFill>
-              </a:rPr>
-              <a:t>Wave 2 · year 3</a:t>
-            </a:r>
-            <a:endParaRPr lang="en-US" sz="1300" dirty="0"/>
-          </a:p>
-        </p:txBody>
-      </p:sp>
-      <p:sp>
-        <p:nvSpPr>
-          <p:cNvPr id="13" name="Text 11"/>
-          <p:cNvSpPr txBox="1"/>
-          <p:nvPr/>
-        </p:nvSpPr>
-        <p:spPr>
-          <a:xfrm>
-            <a:off x="3429000" y="1783080"/>
-            <a:ext cx="2286000" cy="548640"/>
-          </a:xfrm>
-          <a:prstGeom prst="rect">
-            <a:avLst/>
-          </a:prstGeom>
-          <a:noFill/>
-          <a:ln/>
-        </p:spPr>
-        <p:txBody>
-          <a:bodyPr wrap="square" lIns="0" tIns="0" rIns="0" bIns="0" rtlCol="0" anchor="t"/>
-          <a:lstStyle/>
-          <a:p>
-            <a:pPr indent="0" marL="0">
-              <a:buNone/>
-            </a:pPr>
-            <a:r>
-              <a:rPr lang="en-US" sz="1500" b="1" dirty="0">
-                <a:solidFill>
-                  <a:schemeClr val="tx1"/>
-                </a:solidFill>
-              </a:rPr>
-              <a:t>Peru and Colombia</a:t>
-            </a:r>
-            <a:endParaRPr lang="en-US" sz="1500" dirty="0"/>
-          </a:p>
-        </p:txBody>
-      </p:sp>
-      <p:sp>
-        <p:nvSpPr>
-          <p:cNvPr id="14" name="Text 12"/>
-          <p:cNvSpPr txBox="1"/>
-          <p:nvPr/>
-        </p:nvSpPr>
-        <p:spPr>
-          <a:xfrm>
-            <a:off x="3429000" y="2377440"/>
-            <a:ext cx="2286000" cy="1005840"/>
-          </a:xfrm>
-          <a:prstGeom prst="rect">
-            <a:avLst/>
-          </a:prstGeom>
-          <a:noFill/>
-          <a:ln/>
-        </p:spPr>
-        <p:txBody>
-          <a:bodyPr wrap="square" lIns="0" tIns="0" rIns="0" bIns="0" rtlCol="0" anchor="t"/>
-          <a:lstStyle/>
-          <a:p>
-            <a:pPr indent="0" marL="0">
-              <a:buNone/>
-            </a:pPr>
-            <a:r>
-              <a:rPr lang="en-US" sz="1200" dirty="0">
-                <a:solidFill>
-                  <a:schemeClr val="tx2"/>
-                </a:solidFill>
-              </a:rPr>
-              <a:t>Export cotton and knitwear; local agent with TID support</a:t>
-            </a:r>
-            <a:endParaRPr lang="en-US" sz="1200" dirty="0"/>
-          </a:p>
-        </p:txBody>
-      </p:sp>
-      <p:sp>
-        <p:nvSpPr>
-          <p:cNvPr id="15" name="Shape 13"/>
-          <p:cNvSpPr/>
-          <p:nvPr/>
-        </p:nvSpPr>
-        <p:spPr>
-          <a:xfrm>
-            <a:off x="6035040" y="1097280"/>
-            <a:ext cx="2606040" cy="2377440"/>
-          </a:xfrm>
-          <a:prstGeom prst="roundRect">
-            <a:avLst>
-              <a:gd name="adj" fmla="val 3077"/>
-            </a:avLst>
-          </a:prstGeom>
-          <a:solidFill>
-            <a:srgbClr val="EEF2F7"/>
-          </a:solidFill>
-          <a:ln w="12700">
-            <a:solidFill>
-              <a:srgbClr val="EEF2F7"/>
-            </a:solidFill>
-            <a:prstDash val="solid"/>
-          </a:ln>
-        </p:spPr>
-      </p:sp>
-      <p:sp>
-        <p:nvSpPr>
-          <p:cNvPr id="16" name="Shape 14"/>
-          <p:cNvSpPr/>
-          <p:nvPr/>
-        </p:nvSpPr>
-        <p:spPr>
-          <a:xfrm>
-            <a:off x="6217920" y="1261872"/>
-            <a:ext cx="384048" cy="384048"/>
-          </a:xfrm>
-          <a:prstGeom prst="ellipse">
-            <a:avLst/>
-          </a:prstGeom>
-          <a:solidFill>
-            <a:srgbClr val="F2B705"/>
-          </a:solidFill>
-          <a:ln w="12700">
-            <a:solidFill>
-              <a:srgbClr val="F2B705"/>
-            </a:solidFill>
-            <a:prstDash val="solid"/>
-          </a:ln>
-        </p:spPr>
-      </p:sp>
-      <p:sp>
-        <p:nvSpPr>
-          <p:cNvPr id="17" name="Text 15"/>
-          <p:cNvSpPr txBox="1"/>
-          <p:nvPr/>
-        </p:nvSpPr>
-        <p:spPr>
-          <a:xfrm>
-            <a:off x="6217920" y="1261872"/>
-            <a:ext cx="384048" cy="384048"/>
-          </a:xfrm>
-          <a:prstGeom prst="rect">
-            <a:avLst/>
-          </a:prstGeom>
-          <a:noFill/>
-          <a:ln/>
-        </p:spPr>
-        <p:txBody>
-          <a:bodyPr wrap="square" lIns="0" tIns="0" rIns="0" bIns="0" rtlCol="0" anchor="ctr"/>
-          <a:lstStyle/>
-          <a:p>
-            <a:pPr algn="ctr" indent="0" marL="0">
-              <a:buNone/>
-            </a:pPr>
-            <a:r>
-              <a:rPr lang="en-US" sz="1300" b="1" dirty="0">
-                <a:solidFill>
-                  <a:srgbClr val="1B1F3B"/>
-                </a:solidFill>
-              </a:rPr>
-              <a:t>3</a:t>
-            </a:r>
-            <a:endParaRPr lang="en-US" sz="1300" dirty="0"/>
-          </a:p>
-        </p:txBody>
-      </p:sp>
-      <p:sp>
-        <p:nvSpPr>
-          <p:cNvPr id="18" name="Text 16"/>
-          <p:cNvSpPr txBox="1"/>
-          <p:nvPr/>
-        </p:nvSpPr>
-        <p:spPr>
-          <a:xfrm>
-            <a:off x="6720840" y="1261872"/>
-            <a:ext cx="1828800" cy="384048"/>
-          </a:xfrm>
-          <a:prstGeom prst="rect">
-            <a:avLst/>
-          </a:prstGeom>
-          <a:noFill/>
-          <a:ln/>
-        </p:spPr>
-        <p:txBody>
-          <a:bodyPr wrap="square" lIns="0" tIns="0" rIns="0" bIns="0" rtlCol="0" anchor="ctr"/>
-          <a:lstStyle/>
-          <a:p>
-            <a:pPr indent="0" marL="0">
-              <a:buNone/>
-            </a:pPr>
-            <a:r>
-              <a:rPr lang="en-US" sz="1300" b="1" dirty="0">
-                <a:solidFill>
-                  <a:schemeClr val="accent1"/>
-                </a:solidFill>
-              </a:rPr>
-              <a:t>Wave 3 · years 3–4</a:t>
-            </a:r>
-            <a:endParaRPr lang="en-US" sz="1300" dirty="0"/>
-          </a:p>
-        </p:txBody>
-      </p:sp>
-      <p:sp>
-        <p:nvSpPr>
-          <p:cNvPr id="19" name="Text 17"/>
-          <p:cNvSpPr txBox="1"/>
-          <p:nvPr/>
-        </p:nvSpPr>
-        <p:spPr>
-          <a:xfrm>
-            <a:off x="6217920" y="1783080"/>
-            <a:ext cx="2286000" cy="548640"/>
-          </a:xfrm>
-          <a:prstGeom prst="rect">
-            <a:avLst/>
-          </a:prstGeom>
-          <a:noFill/>
-          <a:ln/>
-        </p:spPr>
-        <p:txBody>
-          <a:bodyPr wrap="square" lIns="0" tIns="0" rIns="0" bIns="0" rtlCol="0" anchor="t"/>
-          <a:lstStyle/>
-          <a:p>
-            <a:pPr indent="0" marL="0">
-              <a:buNone/>
-            </a:pPr>
-            <a:r>
-              <a:rPr lang="en-US" sz="1500" b="1" dirty="0">
-                <a:solidFill>
-                  <a:schemeClr val="tx1"/>
-                </a:solidFill>
-              </a:rPr>
-              <a:t>Dominican Rep., Haiti and others</a:t>
-            </a:r>
-            <a:endParaRPr lang="en-US" sz="1500" dirty="0"/>
-          </a:p>
-        </p:txBody>
-      </p:sp>
-      <p:sp>
-        <p:nvSpPr>
-          <p:cNvPr id="20" name="Text 18"/>
-          <p:cNvSpPr txBox="1"/>
-          <p:nvPr/>
-        </p:nvSpPr>
-        <p:spPr>
-          <a:xfrm>
-            <a:off x="6217920" y="2377440"/>
-            <a:ext cx="2286000" cy="1005840"/>
-          </a:xfrm>
-          <a:prstGeom prst="rect">
-            <a:avLst/>
-          </a:prstGeom>
-          <a:noFill/>
-          <a:ln/>
-        </p:spPr>
-        <p:txBody>
-          <a:bodyPr wrap="square" lIns="0" tIns="0" rIns="0" bIns="0" rtlCol="0" anchor="t"/>
-          <a:lstStyle/>
-          <a:p>
-            <a:pPr indent="0" marL="0">
-              <a:buNone/>
-            </a:pPr>
-            <a:r>
-              <a:rPr lang="en-US" sz="1200" dirty="0">
-                <a:solidFill>
-                  <a:schemeClr val="tx2"/>
-                </a:solidFill>
-              </a:rPr>
-              <a:t>Free zones with screen printing (Gildan, Hansae)</a:t>
-            </a:r>
-            <a:endParaRPr lang="en-US" sz="1200" dirty="0"/>
-          </a:p>
-        </p:txBody>
-      </p:sp>
-      <p:sp>
-        <p:nvSpPr>
-          <p:cNvPr id="21" name="Shape 19"/>
-          <p:cNvSpPr/>
-          <p:nvPr/>
-        </p:nvSpPr>
-        <p:spPr>
-          <a:xfrm>
-            <a:off x="457200" y="3657600"/>
-            <a:ext cx="8229600" cy="731520"/>
-          </a:xfrm>
-          <a:prstGeom prst="roundRect">
-            <a:avLst>
-              <a:gd name="adj" fmla="val 10000"/>
-            </a:avLst>
-          </a:prstGeom>
-          <a:solidFill>
-            <a:srgbClr val="1B1F3B"/>
-          </a:solidFill>
-          <a:ln w="12700">
-            <a:solidFill>
-              <a:srgbClr val="1B1F3B"/>
-            </a:solidFill>
-            <a:prstDash val="solid"/>
-          </a:ln>
-        </p:spPr>
-      </p:sp>
-      <p:sp>
-        <p:nvSpPr>
-          <p:cNvPr id="22" name="Text 20"/>
-          <p:cNvSpPr txBox="1"/>
-          <p:nvPr/>
-        </p:nvSpPr>
-        <p:spPr>
-          <a:xfrm>
-            <a:off x="640080" y="3657600"/>
-            <a:ext cx="7863840" cy="731520"/>
-          </a:xfrm>
-          <a:prstGeom prst="rect">
-            <a:avLst/>
-          </a:prstGeom>
-          <a:noFill/>
-          <a:ln/>
-        </p:spPr>
-        <p:txBody>
-          <a:bodyPr wrap="square" lIns="0" tIns="0" rIns="0" bIns="0" rtlCol="0" anchor="ctr"/>
-          <a:lstStyle/>
-          <a:p>
-            <a:pPr indent="0" marL="0">
-              <a:buNone/>
-            </a:pPr>
-            <a:r>
-              <a:rPr lang="en-US" sz="1300" b="1" dirty="0">
-                <a:solidFill>
-                  <a:srgbClr val="FFFFFF"/>
-                </a:solidFill>
-              </a:rPr>
-              <a:t>U.S.: VSP Printing (California) provides local service and covers OEM headquarters; CLT already exhibits at PRINTING United.</a:t>
-            </a:r>
-            <a:endParaRPr lang="en-US" sz="1300" dirty="0"/>
+            <a:endParaRPr lang="en-US" sz="1000" dirty="0"/>
           </a:p>
         </p:txBody>
       </p:sp>
@@ -28582,13 +28171,15 @@
       <p:sp>
         <p:nvSpPr>
           <p:cNvPr id="2" name="Text 0"/>
-          <p:cNvSpPr txBox="1"/>
-          <p:nvPr/>
-        </p:nvSpPr>
-        <p:spPr>
-          <a:xfrm>
-            <a:off x="548640" y="1097280"/>
-            <a:ext cx="2743200" cy="914400"/>
+          <p:cNvSpPr/>
+          <p:nvPr>
+            <p:ph idx="100" type="title" hasCustomPrompt="1"/>
+          </p:nvPr>
+        </p:nvSpPr>
+        <p:spPr>
+          <a:xfrm>
+            <a:off x="457200" y="274320"/>
+            <a:ext cx="8229600" cy="640080"/>
           </a:xfrm>
           <a:prstGeom prst="rect">
             <a:avLst/>
@@ -28597,36 +28188,58 @@
           <a:ln/>
         </p:spPr>
         <p:txBody>
-          <a:bodyPr wrap="square" lIns="0" tIns="0" rIns="0" bIns="0" rtlCol="0" anchor="ctr"/>
+          <a:bodyPr wrap="square" rtlCol="0" anchor="ctr"/>
           <a:lstStyle/>
           <a:p>
             <a:pPr indent="0" marL="0">
               <a:buNone/>
             </a:pPr>
             <a:r>
-              <a:rPr lang="en-US" sz="6000" b="1" dirty="0">
+              <a:rPr lang="en-US" sz="2600" b="1" dirty="0">
                 <a:solidFill>
-                  <a:schemeClr val="accent3"/>
+                  <a:schemeClr val="tx1"/>
                 </a:solidFill>
               </a:rPr>
-              <a:t>08</a:t>
+              <a:t>LATAM map: printers and manufacturers</a:t>
             </a:r>
-            <a:endParaRPr lang="en-US" sz="6000" dirty="0"/>
-          </a:p>
-        </p:txBody>
-      </p:sp>
-      <p:sp>
-        <p:nvSpPr>
-          <p:cNvPr id="3" name="Text 0"/>
-          <p:cNvSpPr/>
-          <p:nvPr>
-            <p:ph idx="100" type="title" hasCustomPrompt="1"/>
-          </p:nvPr>
-        </p:nvSpPr>
-        <p:spPr>
-          <a:xfrm>
-            <a:off x="548640" y="2103120"/>
-            <a:ext cx="8046720" cy="914400"/>
+            <a:endParaRPr lang="en-US" sz="2600" dirty="0"/>
+          </a:p>
+        </p:txBody>
+      </p:sp>
+      <p:pic>
+        <p:nvPicPr>
+          <p:cNvPr id="3" name="Image 0" descr="LATAM map: printers and manufacturers">    </p:cNvPr>
+          <p:cNvPicPr>
+            <a:picLocks noChangeAspect="1"/>
+          </p:cNvPicPr>
+          <p:nvPr/>
+        </p:nvPicPr>
+        <p:blipFill>
+          <a:blip r:embed="rId1"/>
+          <a:stretch>
+            <a:fillRect/>
+          </a:stretch>
+        </p:blipFill>
+        <p:spPr>
+          <a:xfrm>
+            <a:off x="1252728" y="914400"/>
+            <a:ext cx="6638544" cy="3429000"/>
+          </a:xfrm>
+          <a:prstGeom prst="rect">
+            <a:avLst/>
+          </a:prstGeom>
+        </p:spPr>
+      </p:pic>
+      <p:sp>
+        <p:nvSpPr>
+          <p:cNvPr id="4" name="Text 1"/>
+          <p:cNvSpPr txBox="1"/>
+          <p:nvPr/>
+        </p:nvSpPr>
+        <p:spPr>
+          <a:xfrm>
+            <a:off x="457200" y="4480560"/>
+            <a:ext cx="8229600" cy="274320"/>
           </a:xfrm>
           <a:prstGeom prst="rect">
             <a:avLst/>
@@ -28635,123 +28248,68 @@
           <a:ln/>
         </p:spPr>
         <p:txBody>
-          <a:bodyPr wrap="square" rtlCol="0"/>
-          <a:lstStyle/>
-          <a:p>
-            <a:pPr algn="l" indent="0" marL="0">
+          <a:bodyPr wrap="square" lIns="0" tIns="0" rIns="0" bIns="0" rtlCol="0" anchor="ctr"/>
+          <a:lstStyle/>
+          <a:p>
+            <a:pPr indent="0" marL="0">
               <a:buNone/>
             </a:pPr>
             <a:r>
-              <a:rPr lang="en-US" sz="3600" b="1" dirty="0">
+              <a:rPr lang="en-US" sz="1000" i="1" dirty="0">
                 <a:solidFill>
-                  <a:schemeClr val="bg1"/>
+                  <a:schemeClr val="accent5"/>
                 </a:solidFill>
               </a:rPr>
-              <a:t>Conclusions</a:t>
+              <a:t>Gold star: 80/20 account in Mexico or priority A elsewhere in LATAM. Numbered account list in mapas/ and in the prospects workbook.</a:t>
             </a:r>
-            <a:endParaRPr lang="en-US" sz="3600" dirty="0"/>
-          </a:p>
-        </p:txBody>
-      </p:sp>
-      <p:sp>
-        <p:nvSpPr>
-          <p:cNvPr id="4" name="cmyk-dot"/>
-          <p:cNvSpPr/>
-          <p:nvPr/>
-        </p:nvSpPr>
-        <p:spPr>
-          <a:xfrm>
-            <a:off x="594360" y="3246120"/>
-            <a:ext cx="164592" cy="164592"/>
-          </a:xfrm>
-          <a:prstGeom prst="ellipse">
-            <a:avLst/>
-          </a:prstGeom>
-          <a:solidFill>
-            <a:srgbClr val="0089C2"/>
-          </a:solidFill>
-          <a:ln w="12700">
-            <a:solidFill>
-              <a:srgbClr val="0089C2"/>
-            </a:solidFill>
-            <a:prstDash val="solid"/>
-          </a:ln>
-        </p:spPr>
-      </p:sp>
-      <p:sp>
-        <p:nvSpPr>
-          <p:cNvPr id="5" name="cmyk-dot"/>
-          <p:cNvSpPr/>
-          <p:nvPr/>
-        </p:nvSpPr>
-        <p:spPr>
-          <a:xfrm>
-            <a:off x="832104" y="3246120"/>
-            <a:ext cx="164592" cy="164592"/>
-          </a:xfrm>
-          <a:prstGeom prst="ellipse">
-            <a:avLst/>
-          </a:prstGeom>
-          <a:solidFill>
-            <a:srgbClr val="C2185B"/>
-          </a:solidFill>
-          <a:ln w="12700">
-            <a:solidFill>
-              <a:srgbClr val="C2185B"/>
-            </a:solidFill>
-            <a:prstDash val="solid"/>
-          </a:ln>
-        </p:spPr>
-      </p:sp>
-      <p:sp>
-        <p:nvSpPr>
-          <p:cNvPr id="6" name="cmyk-dot"/>
-          <p:cNvSpPr/>
-          <p:nvPr/>
-        </p:nvSpPr>
-        <p:spPr>
-          <a:xfrm>
-            <a:off x="1069848" y="3246120"/>
-            <a:ext cx="164592" cy="164592"/>
-          </a:xfrm>
-          <a:prstGeom prst="ellipse">
-            <a:avLst/>
-          </a:prstGeom>
-          <a:solidFill>
-            <a:srgbClr val="F2B705"/>
-          </a:solidFill>
-          <a:ln w="12700">
-            <a:solidFill>
-              <a:srgbClr val="F2B705"/>
-            </a:solidFill>
-            <a:prstDash val="solid"/>
-          </a:ln>
-        </p:spPr>
-      </p:sp>
-      <p:sp>
-        <p:nvSpPr>
-          <p:cNvPr id="7" name="cmyk-dot"/>
-          <p:cNvSpPr/>
-          <p:nvPr/>
-        </p:nvSpPr>
-        <p:spPr>
-          <a:xfrm>
-            <a:off x="1307592" y="3246120"/>
-            <a:ext cx="164592" cy="164592"/>
-          </a:xfrm>
-          <a:prstGeom prst="ellipse">
-            <a:avLst/>
-          </a:prstGeom>
-          <a:solidFill>
-            <a:srgbClr val="FFFFFF"/>
-          </a:solidFill>
-          <a:ln w="12700">
-            <a:solidFill>
-              <a:srgbClr val="FFFFFF"/>
-            </a:solidFill>
-            <a:prstDash val="solid"/>
-          </a:ln>
-        </p:spPr>
+            <a:endParaRPr lang="en-US" sz="1000" dirty="0"/>
+          </a:p>
+        </p:txBody>
+      </p:sp>
+      <p:sp>
+        <p:nvSpPr>
+          <p:cNvPr id="25" name="Slide Number Placeholder 0"/>
+          <p:cNvSpPr>
+            <a:spLocks noGrp="1"/>
+          </p:cNvSpPr>
+          <p:nvPr>
+            <p:ph type="sldNum" sz="quarter" idx="4294967295"/>
+          </p:nvPr>
+        </p:nvSpPr>
+        <p:spPr>
+          <a:xfrm>
+            <a:off x="8229600" y="4800600"/>
+            <a:ext cx="457200" cy="228600"/>
+          </a:xfrm>
+          <a:prstGeom prst="rect">
+            <a:avLst/>
+          </a:prstGeom>
+          <a:extLst>
+            <a:ext uri="{C572A759-6A51-4108-AA02-DFA0A04FC94B}">
+              <ma14:wrappingTextBoxFlag xmlns:ma14="http://schemas.microsoft.com/office/mac/drawingml/2011/main" val="0"/>
+            </a:ext>
+          </a:extLst>
+        </p:spPr>
+        <p:txBody>
+          <a:bodyPr/>
+          <a:lstStyle>
+            <a:lvl1pPr>
+              <a:defRPr sz="900">
+                <a:solidFill>
+                  <a:srgbClr val="7A8299"/>
+                </a:solidFill>
+              </a:defRPr>
+            </a:lvl1pPr>
+          </a:lstStyle>
+          <a:p>
+            <a:pPr algn="r"/>
+            <a:fld id="{F7021451-1387-4CA6-816F-3879F97B5CBC}" type="slidenum">
+              <a:rPr b="0" lang="en-US"/>
+              <a:t>34</a:t>
+            </a:fld>
+            <a:endParaRPr lang="en-US"/>
+          </a:p>
+        </p:txBody>
       </p:sp>
     </p:spTree>
   </p:cSld>
@@ -28813,7 +28371,7 @@
                   <a:schemeClr val="tx1"/>
                 </a:solidFill>
               </a:rPr>
-              <a:t>Conclusions</a:t>
+              <a:t>Expansion path</a:t>
             </a:r>
             <a:endParaRPr lang="en-US" sz="2600" dirty="0"/>
           </a:p>
@@ -28827,8 +28385,35 @@
         </p:nvSpPr>
         <p:spPr>
           <a:xfrm>
-            <a:off x="457200" y="1069848"/>
-            <a:ext cx="411480" cy="411480"/>
+            <a:off x="457200" y="1097280"/>
+            <a:ext cx="2606040" cy="2377440"/>
+          </a:xfrm>
+          <a:prstGeom prst="roundRect">
+            <a:avLst>
+              <a:gd name="adj" fmla="val 3077"/>
+            </a:avLst>
+          </a:prstGeom>
+          <a:solidFill>
+            <a:srgbClr val="EEF2F7"/>
+          </a:solidFill>
+          <a:ln w="12700">
+            <a:solidFill>
+              <a:srgbClr val="EEF2F7"/>
+            </a:solidFill>
+            <a:prstDash val="solid"/>
+          </a:ln>
+        </p:spPr>
+      </p:sp>
+      <p:sp>
+        <p:nvSpPr>
+          <p:cNvPr id="4" name="Shape 2"/>
+          <p:cNvSpPr/>
+          <p:nvPr/>
+        </p:nvSpPr>
+        <p:spPr>
+          <a:xfrm>
+            <a:off x="640080" y="1261872"/>
+            <a:ext cx="384048" cy="384048"/>
           </a:xfrm>
           <a:prstGeom prst="ellipse">
             <a:avLst/>
@@ -28846,14 +28431,14 @@
       </p:sp>
       <p:sp>
         <p:nvSpPr>
-          <p:cNvPr id="4" name="Text 2"/>
+          <p:cNvPr id="5" name="Text 3"/>
           <p:cNvSpPr txBox="1"/>
           <p:nvPr/>
         </p:nvSpPr>
         <p:spPr>
           <a:xfrm>
-            <a:off x="457200" y="1069848"/>
-            <a:ext cx="411480" cy="411480"/>
+            <a:off x="640080" y="1261872"/>
+            <a:ext cx="384048" cy="384048"/>
           </a:xfrm>
           <a:prstGeom prst="rect">
             <a:avLst/>
@@ -28882,14 +28467,14 @@
       </p:sp>
       <p:sp>
         <p:nvSpPr>
-          <p:cNvPr id="5" name="Text 3"/>
+          <p:cNvPr id="6" name="Text 4"/>
           <p:cNvSpPr txBox="1"/>
           <p:nvPr/>
         </p:nvSpPr>
         <p:spPr>
           <a:xfrm>
-            <a:off x="1051560" y="1005840"/>
-            <a:ext cx="7589520" cy="548640"/>
+            <a:off x="1143000" y="1261872"/>
+            <a:ext cx="1828800" cy="384048"/>
           </a:xfrm>
           <a:prstGeom prst="rect">
             <a:avLst/>
@@ -28905,27 +28490,126 @@
               <a:buNone/>
             </a:pPr>
             <a:r>
-              <a:rPr lang="en-US" sz="1400" dirty="0">
+              <a:rPr lang="en-US" sz="1300" b="1" dirty="0">
+                <a:solidFill>
+                  <a:schemeClr val="accent1"/>
+                </a:solidFill>
+              </a:rPr>
+              <a:t>Wave 1 · years 2–3</a:t>
+            </a:r>
+            <a:endParaRPr lang="en-US" sz="1300" dirty="0"/>
+          </a:p>
+        </p:txBody>
+      </p:sp>
+      <p:sp>
+        <p:nvSpPr>
+          <p:cNvPr id="7" name="Text 5"/>
+          <p:cNvSpPr txBox="1"/>
+          <p:nvPr/>
+        </p:nvSpPr>
+        <p:spPr>
+          <a:xfrm>
+            <a:off x="640080" y="1783080"/>
+            <a:ext cx="2286000" cy="548640"/>
+          </a:xfrm>
+          <a:prstGeom prst="rect">
+            <a:avLst/>
+          </a:prstGeom>
+          <a:noFill/>
+          <a:ln/>
+        </p:spPr>
+        <p:txBody>
+          <a:bodyPr wrap="square" lIns="0" tIns="0" rIns="0" bIns="0" rtlCol="0" anchor="t"/>
+          <a:lstStyle/>
+          <a:p>
+            <a:pPr indent="0" marL="0">
+              <a:buNone/>
+            </a:pPr>
+            <a:r>
+              <a:rPr lang="en-US" sz="1500" b="1" dirty="0">
                 <a:solidFill>
                   <a:schemeClr val="tx1"/>
                 </a:solidFill>
               </a:rPr>
-              <a:t>Mexico’s industry must stand out against imports: hybrid printing answers that need.</a:t>
+              <a:t>El Salvador, Honduras, Guatemala</a:t>
             </a:r>
-            <a:endParaRPr lang="en-US" sz="1400" dirty="0"/>
-          </a:p>
-        </p:txBody>
-      </p:sp>
-      <p:sp>
-        <p:nvSpPr>
-          <p:cNvPr id="6" name="Shape 4"/>
+            <a:endParaRPr lang="en-US" sz="1500" dirty="0"/>
+          </a:p>
+        </p:txBody>
+      </p:sp>
+      <p:sp>
+        <p:nvSpPr>
+          <p:cNvPr id="8" name="Text 6"/>
+          <p:cNvSpPr txBox="1"/>
+          <p:nvPr/>
+        </p:nvSpPr>
+        <p:spPr>
+          <a:xfrm>
+            <a:off x="640080" y="2377440"/>
+            <a:ext cx="2286000" cy="1005840"/>
+          </a:xfrm>
+          <a:prstGeom prst="rect">
+            <a:avLst/>
+          </a:prstGeom>
+          <a:noFill/>
+          <a:ln/>
+        </p:spPr>
+        <p:txBody>
+          <a:bodyPr wrap="square" lIns="0" tIns="0" rIns="0" bIns="0" rtlCol="0" anchor="t"/>
+          <a:lstStyle/>
+          <a:p>
+            <a:pPr indent="0" marL="0">
+              <a:buNone/>
+            </a:pPr>
+            <a:r>
+              <a:rPr lang="en-US" sz="1200" dirty="0">
+                <a:solidFill>
+                  <a:schemeClr val="tx2"/>
+                </a:solidFill>
+              </a:rPr>
+              <a:t>Contractors printing for Hanes, Gildan, Tegra; sold from Mexico</a:t>
+            </a:r>
+            <a:endParaRPr lang="en-US" sz="1200" dirty="0"/>
+          </a:p>
+        </p:txBody>
+      </p:sp>
+      <p:sp>
+        <p:nvSpPr>
+          <p:cNvPr id="9" name="Shape 7"/>
           <p:cNvSpPr/>
           <p:nvPr/>
         </p:nvSpPr>
         <p:spPr>
           <a:xfrm>
-            <a:off x="457200" y="1755648"/>
-            <a:ext cx="411480" cy="411480"/>
+            <a:off x="3246120" y="1097280"/>
+            <a:ext cx="2606040" cy="2377440"/>
+          </a:xfrm>
+          <a:prstGeom prst="roundRect">
+            <a:avLst>
+              <a:gd name="adj" fmla="val 3077"/>
+            </a:avLst>
+          </a:prstGeom>
+          <a:solidFill>
+            <a:srgbClr val="EEF2F7"/>
+          </a:solidFill>
+          <a:ln w="12700">
+            <a:solidFill>
+              <a:srgbClr val="EEF2F7"/>
+            </a:solidFill>
+            <a:prstDash val="solid"/>
+          </a:ln>
+        </p:spPr>
+      </p:sp>
+      <p:sp>
+        <p:nvSpPr>
+          <p:cNvPr id="10" name="Shape 8"/>
+          <p:cNvSpPr/>
+          <p:nvPr/>
+        </p:nvSpPr>
+        <p:spPr>
+          <a:xfrm>
+            <a:off x="3429000" y="1261872"/>
+            <a:ext cx="384048" cy="384048"/>
           </a:xfrm>
           <a:prstGeom prst="ellipse">
             <a:avLst/>
@@ -28943,14 +28627,14 @@
       </p:sp>
       <p:sp>
         <p:nvSpPr>
-          <p:cNvPr id="7" name="Text 5"/>
+          <p:cNvPr id="11" name="Text 9"/>
           <p:cNvSpPr txBox="1"/>
           <p:nvPr/>
         </p:nvSpPr>
         <p:spPr>
           <a:xfrm>
-            <a:off x="457200" y="1755648"/>
-            <a:ext cx="411480" cy="411480"/>
+            <a:off x="3429000" y="1261872"/>
+            <a:ext cx="384048" cy="384048"/>
           </a:xfrm>
           <a:prstGeom prst="rect">
             <a:avLst/>
@@ -28979,14 +28663,14 @@
       </p:sp>
       <p:sp>
         <p:nvSpPr>
-          <p:cNvPr id="8" name="Text 6"/>
+          <p:cNvPr id="12" name="Text 10"/>
           <p:cNvSpPr txBox="1"/>
           <p:nvPr/>
         </p:nvSpPr>
         <p:spPr>
           <a:xfrm>
-            <a:off x="1051560" y="1691640"/>
-            <a:ext cx="7589520" cy="548640"/>
+            <a:off x="3931920" y="1261872"/>
+            <a:ext cx="1828800" cy="384048"/>
           </a:xfrm>
           <a:prstGeom prst="rect">
             <a:avLst/>
@@ -29002,27 +28686,126 @@
               <a:buNone/>
             </a:pPr>
             <a:r>
-              <a:rPr lang="en-US" sz="1400" dirty="0">
+              <a:rPr lang="en-US" sz="1300" b="1" dirty="0">
+                <a:solidFill>
+                  <a:schemeClr val="accent1"/>
+                </a:solidFill>
+              </a:rPr>
+              <a:t>Wave 2 · year 3</a:t>
+            </a:r>
+            <a:endParaRPr lang="en-US" sz="1300" dirty="0"/>
+          </a:p>
+        </p:txBody>
+      </p:sp>
+      <p:sp>
+        <p:nvSpPr>
+          <p:cNvPr id="13" name="Text 11"/>
+          <p:cNvSpPr txBox="1"/>
+          <p:nvPr/>
+        </p:nvSpPr>
+        <p:spPr>
+          <a:xfrm>
+            <a:off x="3429000" y="1783080"/>
+            <a:ext cx="2286000" cy="548640"/>
+          </a:xfrm>
+          <a:prstGeom prst="rect">
+            <a:avLst/>
+          </a:prstGeom>
+          <a:noFill/>
+          <a:ln/>
+        </p:spPr>
+        <p:txBody>
+          <a:bodyPr wrap="square" lIns="0" tIns="0" rIns="0" bIns="0" rtlCol="0" anchor="t"/>
+          <a:lstStyle/>
+          <a:p>
+            <a:pPr indent="0" marL="0">
+              <a:buNone/>
+            </a:pPr>
+            <a:r>
+              <a:rPr lang="en-US" sz="1500" b="1" dirty="0">
                 <a:solidFill>
                   <a:schemeClr val="tx1"/>
                 </a:solidFill>
               </a:rPr>
-              <a:t>The reachable market is concentrated (~1,900 firms): it is won with consultative selling to a few large accounts.</a:t>
+              <a:t>Peru and Colombia</a:t>
             </a:r>
-            <a:endParaRPr lang="en-US" sz="1400" dirty="0"/>
-          </a:p>
-        </p:txBody>
-      </p:sp>
-      <p:sp>
-        <p:nvSpPr>
-          <p:cNvPr id="9" name="Shape 7"/>
+            <a:endParaRPr lang="en-US" sz="1500" dirty="0"/>
+          </a:p>
+        </p:txBody>
+      </p:sp>
+      <p:sp>
+        <p:nvSpPr>
+          <p:cNvPr id="14" name="Text 12"/>
+          <p:cNvSpPr txBox="1"/>
+          <p:nvPr/>
+        </p:nvSpPr>
+        <p:spPr>
+          <a:xfrm>
+            <a:off x="3429000" y="2377440"/>
+            <a:ext cx="2286000" cy="1005840"/>
+          </a:xfrm>
+          <a:prstGeom prst="rect">
+            <a:avLst/>
+          </a:prstGeom>
+          <a:noFill/>
+          <a:ln/>
+        </p:spPr>
+        <p:txBody>
+          <a:bodyPr wrap="square" lIns="0" tIns="0" rIns="0" bIns="0" rtlCol="0" anchor="t"/>
+          <a:lstStyle/>
+          <a:p>
+            <a:pPr indent="0" marL="0">
+              <a:buNone/>
+            </a:pPr>
+            <a:r>
+              <a:rPr lang="en-US" sz="1200" dirty="0">
+                <a:solidFill>
+                  <a:schemeClr val="tx2"/>
+                </a:solidFill>
+              </a:rPr>
+              <a:t>Export cotton and knitwear; local agent with TID support</a:t>
+            </a:r>
+            <a:endParaRPr lang="en-US" sz="1200" dirty="0"/>
+          </a:p>
+        </p:txBody>
+      </p:sp>
+      <p:sp>
+        <p:nvSpPr>
+          <p:cNvPr id="15" name="Shape 13"/>
           <p:cNvSpPr/>
           <p:nvPr/>
         </p:nvSpPr>
         <p:spPr>
           <a:xfrm>
-            <a:off x="457200" y="2441448"/>
-            <a:ext cx="411480" cy="411480"/>
+            <a:off x="6035040" y="1097280"/>
+            <a:ext cx="2606040" cy="2377440"/>
+          </a:xfrm>
+          <a:prstGeom prst="roundRect">
+            <a:avLst>
+              <a:gd name="adj" fmla="val 3077"/>
+            </a:avLst>
+          </a:prstGeom>
+          <a:solidFill>
+            <a:srgbClr val="EEF2F7"/>
+          </a:solidFill>
+          <a:ln w="12700">
+            <a:solidFill>
+              <a:srgbClr val="EEF2F7"/>
+            </a:solidFill>
+            <a:prstDash val="solid"/>
+          </a:ln>
+        </p:spPr>
+      </p:sp>
+      <p:sp>
+        <p:nvSpPr>
+          <p:cNvPr id="16" name="Shape 14"/>
+          <p:cNvSpPr/>
+          <p:nvPr/>
+        </p:nvSpPr>
+        <p:spPr>
+          <a:xfrm>
+            <a:off x="6217920" y="1261872"/>
+            <a:ext cx="384048" cy="384048"/>
           </a:xfrm>
           <a:prstGeom prst="ellipse">
             <a:avLst/>
@@ -29040,14 +28823,14 @@
       </p:sp>
       <p:sp>
         <p:nvSpPr>
-          <p:cNvPr id="10" name="Text 8"/>
+          <p:cNvPr id="17" name="Text 15"/>
           <p:cNvSpPr txBox="1"/>
           <p:nvPr/>
         </p:nvSpPr>
         <p:spPr>
           <a:xfrm>
-            <a:off x="457200" y="2441448"/>
-            <a:ext cx="411480" cy="411480"/>
+            <a:off x="6217920" y="1261872"/>
+            <a:ext cx="384048" cy="384048"/>
           </a:xfrm>
           <a:prstGeom prst="rect">
             <a:avLst/>
@@ -29076,14 +28859,14 @@
       </p:sp>
       <p:sp>
         <p:nvSpPr>
-          <p:cNvPr id="11" name="Text 9"/>
+          <p:cNvPr id="18" name="Text 16"/>
           <p:cNvSpPr txBox="1"/>
           <p:nvPr/>
         </p:nvSpPr>
         <p:spPr>
           <a:xfrm>
-            <a:off x="1051560" y="2377440"/>
-            <a:ext cx="7589520" cy="548640"/>
+            <a:off x="6720840" y="1261872"/>
+            <a:ext cx="1828800" cy="384048"/>
           </a:xfrm>
           <a:prstGeom prst="rect">
             <a:avLst/>
@@ -29099,30 +28882,104 @@
               <a:buNone/>
             </a:pPr>
             <a:r>
-              <a:rPr lang="en-US" sz="1400" dirty="0">
+              <a:rPr lang="en-US" sz="1300" b="1" dirty="0">
+                <a:solidFill>
+                  <a:schemeClr val="accent1"/>
+                </a:solidFill>
+              </a:rPr>
+              <a:t>Wave 3 · years 3–4</a:t>
+            </a:r>
+            <a:endParaRPr lang="en-US" sz="1300" dirty="0"/>
+          </a:p>
+        </p:txBody>
+      </p:sp>
+      <p:sp>
+        <p:nvSpPr>
+          <p:cNvPr id="19" name="Text 17"/>
+          <p:cNvSpPr txBox="1"/>
+          <p:nvPr/>
+        </p:nvSpPr>
+        <p:spPr>
+          <a:xfrm>
+            <a:off x="6217920" y="1783080"/>
+            <a:ext cx="2286000" cy="548640"/>
+          </a:xfrm>
+          <a:prstGeom prst="rect">
+            <a:avLst/>
+          </a:prstGeom>
+          <a:noFill/>
+          <a:ln/>
+        </p:spPr>
+        <p:txBody>
+          <a:bodyPr wrap="square" lIns="0" tIns="0" rIns="0" bIns="0" rtlCol="0" anchor="t"/>
+          <a:lstStyle/>
+          <a:p>
+            <a:pPr indent="0" marL="0">
+              <a:buNone/>
+            </a:pPr>
+            <a:r>
+              <a:rPr lang="en-US" sz="1500" b="1" dirty="0">
                 <a:solidFill>
                   <a:schemeClr val="tx1"/>
                 </a:solidFill>
               </a:rPr>
-              <a:t>Nobody owns the category: no formal distributor of Chinese hybrids and no turnkey offer with local service.</a:t>
+              <a:t>Dominican Rep., Haiti and others</a:t>
             </a:r>
-            <a:endParaRPr lang="en-US" sz="1400" dirty="0"/>
-          </a:p>
-        </p:txBody>
-      </p:sp>
-      <p:sp>
-        <p:nvSpPr>
-          <p:cNvPr id="12" name="Shape 10"/>
+            <a:endParaRPr lang="en-US" sz="1500" dirty="0"/>
+          </a:p>
+        </p:txBody>
+      </p:sp>
+      <p:sp>
+        <p:nvSpPr>
+          <p:cNvPr id="20" name="Text 18"/>
+          <p:cNvSpPr txBox="1"/>
+          <p:nvPr/>
+        </p:nvSpPr>
+        <p:spPr>
+          <a:xfrm>
+            <a:off x="6217920" y="2377440"/>
+            <a:ext cx="2286000" cy="1005840"/>
+          </a:xfrm>
+          <a:prstGeom prst="rect">
+            <a:avLst/>
+          </a:prstGeom>
+          <a:noFill/>
+          <a:ln/>
+        </p:spPr>
+        <p:txBody>
+          <a:bodyPr wrap="square" lIns="0" tIns="0" rIns="0" bIns="0" rtlCol="0" anchor="t"/>
+          <a:lstStyle/>
+          <a:p>
+            <a:pPr indent="0" marL="0">
+              <a:buNone/>
+            </a:pPr>
+            <a:r>
+              <a:rPr lang="en-US" sz="1200" dirty="0">
+                <a:solidFill>
+                  <a:schemeClr val="tx2"/>
+                </a:solidFill>
+              </a:rPr>
+              <a:t>Free zones with screen printing (Gildan, Hansae)</a:t>
+            </a:r>
+            <a:endParaRPr lang="en-US" sz="1200" dirty="0"/>
+          </a:p>
+        </p:txBody>
+      </p:sp>
+      <p:sp>
+        <p:nvSpPr>
+          <p:cNvPr id="21" name="Shape 19"/>
           <p:cNvSpPr/>
           <p:nvPr/>
         </p:nvSpPr>
         <p:spPr>
           <a:xfrm>
-            <a:off x="457200" y="3127248"/>
-            <a:ext cx="411480" cy="411480"/>
-          </a:xfrm>
-          <a:prstGeom prst="ellipse">
-            <a:avLst/>
+            <a:off x="457200" y="3657600"/>
+            <a:ext cx="8229600" cy="731520"/>
+          </a:xfrm>
+          <a:prstGeom prst="roundRect">
+            <a:avLst>
+              <a:gd name="adj" fmla="val 10000"/>
+            </a:avLst>
           </a:prstGeom>
           <a:solidFill>
             <a:srgbClr val="1B1F3B"/>
@@ -29137,14 +28994,14 @@
       </p:sp>
       <p:sp>
         <p:nvSpPr>
-          <p:cNvPr id="13" name="Text 11"/>
+          <p:cNvPr id="22" name="Text 20"/>
           <p:cNvSpPr txBox="1"/>
           <p:nvPr/>
         </p:nvSpPr>
         <p:spPr>
           <a:xfrm>
-            <a:off x="457200" y="3127248"/>
-            <a:ext cx="411480" cy="411480"/>
+            <a:off x="640080" y="3657600"/>
+            <a:ext cx="7863840" cy="731520"/>
           </a:xfrm>
           <a:prstGeom prst="rect">
             <a:avLst/>
@@ -29156,7 +29013,7 @@
           <a:bodyPr wrap="square" lIns="0" tIns="0" rIns="0" bIns="0" rtlCol="0" anchor="ctr"/>
           <a:lstStyle/>
           <a:p>
-            <a:pPr algn="ctr" indent="0" marL="0">
+            <a:pPr indent="0" marL="0">
               <a:buNone/>
             </a:pPr>
             <a:r>
@@ -29165,142 +29022,9 @@
                   <a:srgbClr val="FFFFFF"/>
                 </a:solidFill>
               </a:rPr>
-              <a:t>4</a:t>
+              <a:t>U.S.: VSP Printing (California) provides local service and covers OEM headquarters; CLT already exhibits at PRINTING United.</a:t>
             </a:r>
             <a:endParaRPr lang="en-US" sz="1300" dirty="0"/>
-          </a:p>
-        </p:txBody>
-      </p:sp>
-      <p:sp>
-        <p:nvSpPr>
-          <p:cNvPr id="14" name="Text 12"/>
-          <p:cNvSpPr txBox="1"/>
-          <p:nvPr/>
-        </p:nvSpPr>
-        <p:spPr>
-          <a:xfrm>
-            <a:off x="1051560" y="3063240"/>
-            <a:ext cx="7589520" cy="548640"/>
-          </a:xfrm>
-          <a:prstGeom prst="rect">
-            <a:avLst/>
-          </a:prstGeom>
-          <a:noFill/>
-          <a:ln/>
-        </p:spPr>
-        <p:txBody>
-          <a:bodyPr wrap="square" lIns="0" tIns="0" rIns="0" bIns="0" rtlCol="0" anchor="ctr"/>
-          <a:lstStyle/>
-          <a:p>
-            <a:pPr indent="0" marL="0">
-              <a:buNone/>
-            </a:pPr>
-            <a:r>
-              <a:rPr lang="en-US" sz="1400" dirty="0">
-                <a:solidFill>
-                  <a:schemeClr val="tx1"/>
-                </a:solidFill>
-              </a:rPr>
-              <a:t>Ink competition is premium (Avient, Matsui) or cheap (ScreenTec, local brands): CLT competes with package and service.</a:t>
-            </a:r>
-            <a:endParaRPr lang="en-US" sz="1400" dirty="0"/>
-          </a:p>
-        </p:txBody>
-      </p:sp>
-      <p:sp>
-        <p:nvSpPr>
-          <p:cNvPr id="15" name="Shape 13"/>
-          <p:cNvSpPr/>
-          <p:nvPr/>
-        </p:nvSpPr>
-        <p:spPr>
-          <a:xfrm>
-            <a:off x="457200" y="3813048"/>
-            <a:ext cx="411480" cy="411480"/>
-          </a:xfrm>
-          <a:prstGeom prst="ellipse">
-            <a:avLst/>
-          </a:prstGeom>
-          <a:solidFill>
-            <a:srgbClr val="0089C2"/>
-          </a:solidFill>
-          <a:ln w="12700">
-            <a:solidFill>
-              <a:srgbClr val="0089C2"/>
-            </a:solidFill>
-            <a:prstDash val="solid"/>
-          </a:ln>
-        </p:spPr>
-      </p:sp>
-      <p:sp>
-        <p:nvSpPr>
-          <p:cNvPr id="16" name="Text 14"/>
-          <p:cNvSpPr txBox="1"/>
-          <p:nvPr/>
-        </p:nvSpPr>
-        <p:spPr>
-          <a:xfrm>
-            <a:off x="457200" y="3813048"/>
-            <a:ext cx="411480" cy="411480"/>
-          </a:xfrm>
-          <a:prstGeom prst="rect">
-            <a:avLst/>
-          </a:prstGeom>
-          <a:noFill/>
-          <a:ln/>
-        </p:spPr>
-        <p:txBody>
-          <a:bodyPr wrap="square" lIns="0" tIns="0" rIns="0" bIns="0" rtlCol="0" anchor="ctr"/>
-          <a:lstStyle/>
-          <a:p>
-            <a:pPr algn="ctr" indent="0" marL="0">
-              <a:buNone/>
-            </a:pPr>
-            <a:r>
-              <a:rPr lang="en-US" sz="1300" b="1" dirty="0">
-                <a:solidFill>
-                  <a:srgbClr val="FFFFFF"/>
-                </a:solidFill>
-              </a:rPr>
-              <a:t>5</a:t>
-            </a:r>
-            <a:endParaRPr lang="en-US" sz="1300" dirty="0"/>
-          </a:p>
-        </p:txBody>
-      </p:sp>
-      <p:sp>
-        <p:nvSpPr>
-          <p:cNvPr id="17" name="Text 15"/>
-          <p:cNvSpPr txBox="1"/>
-          <p:nvPr/>
-        </p:nvSpPr>
-        <p:spPr>
-          <a:xfrm>
-            <a:off x="1051560" y="3749040"/>
-            <a:ext cx="7589520" cy="548640"/>
-          </a:xfrm>
-          <a:prstGeom prst="rect">
-            <a:avLst/>
-          </a:prstGeom>
-          <a:noFill/>
-          <a:ln/>
-        </p:spPr>
-        <p:txBody>
-          <a:bodyPr wrap="square" lIns="0" tIns="0" rIns="0" bIns="0" rtlCol="0" anchor="ctr"/>
-          <a:lstStyle/>
-          <a:p>
-            <a:pPr indent="0" marL="0">
-              <a:buNone/>
-            </a:pPr>
-            <a:r>
-              <a:rPr lang="en-US" sz="1400" dirty="0">
-                <a:solidFill>
-                  <a:schemeClr val="tx1"/>
-                </a:solidFill>
-              </a:rPr>
-              <a:t>2026 tariffs and USMCA favor producing in Mexico; Central America and Peru are the next wave.</a:t>
-            </a:r>
-            <a:endParaRPr lang="en-US" sz="1400" dirty="0"/>
           </a:p>
         </p:txBody>
       </p:sp>
@@ -29380,6 +29104,42 @@
       <p:sp>
         <p:nvSpPr>
           <p:cNvPr id="2" name="Text 0"/>
+          <p:cNvSpPr txBox="1"/>
+          <p:nvPr/>
+        </p:nvSpPr>
+        <p:spPr>
+          <a:xfrm>
+            <a:off x="548640" y="1097280"/>
+            <a:ext cx="2743200" cy="914400"/>
+          </a:xfrm>
+          <a:prstGeom prst="rect">
+            <a:avLst/>
+          </a:prstGeom>
+          <a:noFill/>
+          <a:ln/>
+        </p:spPr>
+        <p:txBody>
+          <a:bodyPr wrap="square" lIns="0" tIns="0" rIns="0" bIns="0" rtlCol="0" anchor="ctr"/>
+          <a:lstStyle/>
+          <a:p>
+            <a:pPr indent="0" marL="0">
+              <a:buNone/>
+            </a:pPr>
+            <a:r>
+              <a:rPr lang="en-US" sz="6000" b="1" dirty="0">
+                <a:solidFill>
+                  <a:schemeClr val="accent3"/>
+                </a:solidFill>
+              </a:rPr>
+              <a:t>08</a:t>
+            </a:r>
+            <a:endParaRPr lang="en-US" sz="6000" dirty="0"/>
+          </a:p>
+        </p:txBody>
+      </p:sp>
+      <p:sp>
+        <p:nvSpPr>
+          <p:cNvPr id="3" name="Text 0"/>
           <p:cNvSpPr/>
           <p:nvPr>
             <p:ph idx="100" type="title" hasCustomPrompt="1"/>
@@ -29387,8 +29147,8 @@
         </p:nvSpPr>
         <p:spPr>
           <a:xfrm>
-            <a:off x="457200" y="274320"/>
-            <a:ext cx="8229600" cy="640080"/>
+            <a:off x="548640" y="2103120"/>
+            <a:ext cx="8046720" cy="914400"/>
           </a:xfrm>
           <a:prstGeom prst="rect">
             <a:avLst/>
@@ -29397,34 +29157,34 @@
           <a:ln/>
         </p:spPr>
         <p:txBody>
-          <a:bodyPr wrap="square" rtlCol="0" anchor="ctr"/>
-          <a:lstStyle/>
-          <a:p>
-            <a:pPr indent="0" marL="0">
+          <a:bodyPr wrap="square" rtlCol="0"/>
+          <a:lstStyle/>
+          <a:p>
+            <a:pPr algn="l" indent="0" marL="0">
               <a:buNone/>
             </a:pPr>
             <a:r>
-              <a:rPr lang="en-US" sz="2600" b="1" dirty="0">
+              <a:rPr lang="en-US" sz="3600" b="1" dirty="0">
                 <a:solidFill>
-                  <a:schemeClr val="tx1"/>
+                  <a:schemeClr val="bg1"/>
                 </a:solidFill>
               </a:rPr>
-              <a:t>Recommendations and next steps</a:t>
+              <a:t>Conclusions</a:t>
             </a:r>
-            <a:endParaRPr lang="en-US" sz="2600" dirty="0"/>
-          </a:p>
-        </p:txBody>
-      </p:sp>
-      <p:sp>
-        <p:nvSpPr>
-          <p:cNvPr id="3" name="Shape 1"/>
+            <a:endParaRPr lang="en-US" sz="3600" dirty="0"/>
+          </a:p>
+        </p:txBody>
+      </p:sp>
+      <p:sp>
+        <p:nvSpPr>
+          <p:cNvPr id="4" name="cmyk-dot"/>
           <p:cNvSpPr/>
           <p:nvPr/>
         </p:nvSpPr>
         <p:spPr>
           <a:xfrm>
-            <a:off x="457200" y="1097280"/>
-            <a:ext cx="411480" cy="411480"/>
+            <a:off x="594360" y="3246120"/>
+            <a:ext cx="164592" cy="164592"/>
           </a:xfrm>
           <a:prstGeom prst="ellipse">
             <a:avLst/>
@@ -29442,86 +29202,14 @@
       </p:sp>
       <p:sp>
         <p:nvSpPr>
-          <p:cNvPr id="4" name="Text 2"/>
-          <p:cNvSpPr txBox="1"/>
-          <p:nvPr/>
-        </p:nvSpPr>
-        <p:spPr>
-          <a:xfrm>
-            <a:off x="457200" y="1097280"/>
-            <a:ext cx="411480" cy="411480"/>
-          </a:xfrm>
-          <a:prstGeom prst="rect">
-            <a:avLst/>
-          </a:prstGeom>
-          <a:noFill/>
-          <a:ln/>
-        </p:spPr>
-        <p:txBody>
-          <a:bodyPr wrap="square" lIns="0" tIns="0" rIns="0" bIns="0" rtlCol="0" anchor="ctr"/>
-          <a:lstStyle/>
-          <a:p>
-            <a:pPr algn="ctr" indent="0" marL="0">
-              <a:buNone/>
-            </a:pPr>
-            <a:r>
-              <a:rPr lang="en-US" sz="1300" b="1" dirty="0">
-                <a:solidFill>
-                  <a:srgbClr val="FFFFFF"/>
-                </a:solidFill>
-              </a:rPr>
-              <a:t>1</a:t>
-            </a:r>
-            <a:endParaRPr lang="en-US" sz="1300" dirty="0"/>
-          </a:p>
-        </p:txBody>
-      </p:sp>
-      <p:sp>
-        <p:nvSpPr>
-          <p:cNvPr id="5" name="Text 3"/>
-          <p:cNvSpPr txBox="1"/>
-          <p:nvPr/>
-        </p:nvSpPr>
-        <p:spPr>
-          <a:xfrm>
-            <a:off x="1051560" y="1051560"/>
-            <a:ext cx="7589520" cy="502920"/>
-          </a:xfrm>
-          <a:prstGeom prst="rect">
-            <a:avLst/>
-          </a:prstGeom>
-          <a:noFill/>
-          <a:ln/>
-        </p:spPr>
-        <p:txBody>
-          <a:bodyPr wrap="square" lIns="0" tIns="0" rIns="0" bIns="0" rtlCol="0" anchor="ctr"/>
-          <a:lstStyle/>
-          <a:p>
-            <a:pPr indent="0" marL="0">
-              <a:buNone/>
-            </a:pPr>
-            <a:r>
-              <a:rPr lang="en-US" sz="1500" dirty="0">
-                <a:solidFill>
-                  <a:schemeClr val="tx1"/>
-                </a:solidFill>
-              </a:rPr>
-              <a:t>Formal CLT quotation to replace estimates</a:t>
-            </a:r>
-            <a:endParaRPr lang="en-US" sz="1500" dirty="0"/>
-          </a:p>
-        </p:txBody>
-      </p:sp>
-      <p:sp>
-        <p:nvSpPr>
-          <p:cNvPr id="6" name="Shape 4"/>
+          <p:cNvPr id="5" name="cmyk-dot"/>
           <p:cNvSpPr/>
           <p:nvPr/>
         </p:nvSpPr>
         <p:spPr>
           <a:xfrm>
-            <a:off x="457200" y="1737360"/>
-            <a:ext cx="411480" cy="411480"/>
+            <a:off x="832104" y="3246120"/>
+            <a:ext cx="164592" cy="164592"/>
           </a:xfrm>
           <a:prstGeom prst="ellipse">
             <a:avLst/>
@@ -29539,86 +29227,14 @@
       </p:sp>
       <p:sp>
         <p:nvSpPr>
-          <p:cNvPr id="7" name="Text 5"/>
-          <p:cNvSpPr txBox="1"/>
-          <p:nvPr/>
-        </p:nvSpPr>
-        <p:spPr>
-          <a:xfrm>
-            <a:off x="457200" y="1737360"/>
-            <a:ext cx="411480" cy="411480"/>
-          </a:xfrm>
-          <a:prstGeom prst="rect">
-            <a:avLst/>
-          </a:prstGeom>
-          <a:noFill/>
-          <a:ln/>
-        </p:spPr>
-        <p:txBody>
-          <a:bodyPr wrap="square" lIns="0" tIns="0" rIns="0" bIns="0" rtlCol="0" anchor="ctr"/>
-          <a:lstStyle/>
-          <a:p>
-            <a:pPr algn="ctr" indent="0" marL="0">
-              <a:buNone/>
-            </a:pPr>
-            <a:r>
-              <a:rPr lang="en-US" sz="1300" b="1" dirty="0">
-                <a:solidFill>
-                  <a:srgbClr val="FFFFFF"/>
-                </a:solidFill>
-              </a:rPr>
-              <a:t>2</a:t>
-            </a:r>
-            <a:endParaRPr lang="en-US" sz="1300" dirty="0"/>
-          </a:p>
-        </p:txBody>
-      </p:sp>
-      <p:sp>
-        <p:nvSpPr>
-          <p:cNvPr id="8" name="Text 6"/>
-          <p:cNvSpPr txBox="1"/>
-          <p:nvPr/>
-        </p:nvSpPr>
-        <p:spPr>
-          <a:xfrm>
-            <a:off x="1051560" y="1691640"/>
-            <a:ext cx="7589520" cy="502920"/>
-          </a:xfrm>
-          <a:prstGeom prst="rect">
-            <a:avLst/>
-          </a:prstGeom>
-          <a:noFill/>
-          <a:ln/>
-        </p:spPr>
-        <p:txBody>
-          <a:bodyPr wrap="square" lIns="0" tIns="0" rIns="0" bIns="0" rtlCol="0" anchor="ctr"/>
-          <a:lstStyle/>
-          <a:p>
-            <a:pPr indent="0" marL="0">
-              <a:buNone/>
-            </a:pPr>
-            <a:r>
-              <a:rPr lang="en-US" sz="1500" dirty="0">
-                <a:solidFill>
-                  <a:schemeClr val="tx1"/>
-                </a:solidFill>
-              </a:rPr>
-              <a:t>Validate consumption and prices with 10–15 shops</a:t>
-            </a:r>
-            <a:endParaRPr lang="en-US" sz="1500" dirty="0"/>
-          </a:p>
-        </p:txBody>
-      </p:sp>
-      <p:sp>
-        <p:nvSpPr>
-          <p:cNvPr id="9" name="Shape 7"/>
+          <p:cNvPr id="6" name="cmyk-dot"/>
           <p:cNvSpPr/>
           <p:nvPr/>
         </p:nvSpPr>
         <p:spPr>
           <a:xfrm>
-            <a:off x="457200" y="2377440"/>
-            <a:ext cx="411480" cy="411480"/>
+            <a:off x="1069848" y="3246120"/>
+            <a:ext cx="164592" cy="164592"/>
           </a:xfrm>
           <a:prstGeom prst="ellipse">
             <a:avLst/>
@@ -29636,314 +29252,28 @@
       </p:sp>
       <p:sp>
         <p:nvSpPr>
-          <p:cNvPr id="10" name="Text 8"/>
-          <p:cNvSpPr txBox="1"/>
-          <p:nvPr/>
-        </p:nvSpPr>
-        <p:spPr>
-          <a:xfrm>
-            <a:off x="457200" y="2377440"/>
-            <a:ext cx="411480" cy="411480"/>
-          </a:xfrm>
-          <a:prstGeom prst="rect">
-            <a:avLst/>
-          </a:prstGeom>
-          <a:noFill/>
-          <a:ln/>
-        </p:spPr>
-        <p:txBody>
-          <a:bodyPr wrap="square" lIns="0" tIns="0" rIns="0" bIns="0" rtlCol="0" anchor="ctr"/>
-          <a:lstStyle/>
-          <a:p>
-            <a:pPr algn="ctr" indent="0" marL="0">
-              <a:buNone/>
-            </a:pPr>
-            <a:r>
-              <a:rPr lang="en-US" sz="1300" b="1" dirty="0">
-                <a:solidFill>
-                  <a:srgbClr val="1B1F3B"/>
-                </a:solidFill>
-              </a:rPr>
-              <a:t>3</a:t>
-            </a:r>
-            <a:endParaRPr lang="en-US" sz="1300" dirty="0"/>
-          </a:p>
-        </p:txBody>
-      </p:sp>
-      <p:sp>
-        <p:nvSpPr>
-          <p:cNvPr id="11" name="Text 9"/>
-          <p:cNvSpPr txBox="1"/>
-          <p:nvPr/>
-        </p:nvSpPr>
-        <p:spPr>
-          <a:xfrm>
-            <a:off x="1051560" y="2331720"/>
-            <a:ext cx="7589520" cy="502920"/>
-          </a:xfrm>
-          <a:prstGeom prst="rect">
-            <a:avLst/>
-          </a:prstGeom>
-          <a:noFill/>
-          <a:ln/>
-        </p:spPr>
-        <p:txBody>
-          <a:bodyPr wrap="square" lIns="0" tIns="0" rIns="0" bIns="0" rtlCol="0" anchor="ctr"/>
-          <a:lstStyle/>
-          <a:p>
-            <a:pPr indent="0" marL="0">
-              <a:buNone/>
-            </a:pPr>
-            <a:r>
-              <a:rPr lang="en-US" sz="1500" dirty="0">
-                <a:solidFill>
-                  <a:schemeClr val="tx1"/>
-                </a:solidFill>
-              </a:rPr>
-              <a:t>Open the demo room and work the 17 80/20 accounts</a:t>
-            </a:r>
-            <a:endParaRPr lang="en-US" sz="1500" dirty="0"/>
-          </a:p>
-        </p:txBody>
-      </p:sp>
-      <p:sp>
-        <p:nvSpPr>
-          <p:cNvPr id="12" name="Shape 10"/>
+          <p:cNvPr id="7" name="cmyk-dot"/>
           <p:cNvSpPr/>
           <p:nvPr/>
         </p:nvSpPr>
         <p:spPr>
           <a:xfrm>
-            <a:off x="457200" y="3017520"/>
-            <a:ext cx="411480" cy="411480"/>
+            <a:off x="1307592" y="3246120"/>
+            <a:ext cx="164592" cy="164592"/>
           </a:xfrm>
           <a:prstGeom prst="ellipse">
             <a:avLst/>
           </a:prstGeom>
           <a:solidFill>
-            <a:srgbClr val="1B1F3B"/>
+            <a:srgbClr val="FFFFFF"/>
           </a:solidFill>
           <a:ln w="12700">
             <a:solidFill>
-              <a:srgbClr val="1B1F3B"/>
+              <a:srgbClr val="FFFFFF"/>
             </a:solidFill>
             <a:prstDash val="solid"/>
           </a:ln>
         </p:spPr>
-      </p:sp>
-      <p:sp>
-        <p:nvSpPr>
-          <p:cNvPr id="13" name="Text 11"/>
-          <p:cNvSpPr txBox="1"/>
-          <p:nvPr/>
-        </p:nvSpPr>
-        <p:spPr>
-          <a:xfrm>
-            <a:off x="457200" y="3017520"/>
-            <a:ext cx="411480" cy="411480"/>
-          </a:xfrm>
-          <a:prstGeom prst="rect">
-            <a:avLst/>
-          </a:prstGeom>
-          <a:noFill/>
-          <a:ln/>
-        </p:spPr>
-        <p:txBody>
-          <a:bodyPr wrap="square" lIns="0" tIns="0" rIns="0" bIns="0" rtlCol="0" anchor="ctr"/>
-          <a:lstStyle/>
-          <a:p>
-            <a:pPr algn="ctr" indent="0" marL="0">
-              <a:buNone/>
-            </a:pPr>
-            <a:r>
-              <a:rPr lang="en-US" sz="1300" b="1" dirty="0">
-                <a:solidFill>
-                  <a:srgbClr val="FFFFFF"/>
-                </a:solidFill>
-              </a:rPr>
-              <a:t>4</a:t>
-            </a:r>
-            <a:endParaRPr lang="en-US" sz="1300" dirty="0"/>
-          </a:p>
-        </p:txBody>
-      </p:sp>
-      <p:sp>
-        <p:nvSpPr>
-          <p:cNvPr id="14" name="Text 12"/>
-          <p:cNvSpPr txBox="1"/>
-          <p:nvPr/>
-        </p:nvSpPr>
-        <p:spPr>
-          <a:xfrm>
-            <a:off x="1051560" y="2971800"/>
-            <a:ext cx="7589520" cy="502920"/>
-          </a:xfrm>
-          <a:prstGeom prst="rect">
-            <a:avLst/>
-          </a:prstGeom>
-          <a:noFill/>
-          <a:ln/>
-        </p:spPr>
-        <p:txBody>
-          <a:bodyPr wrap="square" lIns="0" tIns="0" rIns="0" bIns="0" rtlCol="0" anchor="ctr"/>
-          <a:lstStyle/>
-          <a:p>
-            <a:pPr indent="0" marL="0">
-              <a:buNone/>
-            </a:pPr>
-            <a:r>
-              <a:rPr lang="en-US" sz="1500" dirty="0">
-                <a:solidFill>
-                  <a:schemeClr val="tx1"/>
-                </a:solidFill>
-              </a:rPr>
-              <a:t>Confirm tariffs and HS codes with a customs broker</a:t>
-            </a:r>
-            <a:endParaRPr lang="en-US" sz="1500" dirty="0"/>
-          </a:p>
-        </p:txBody>
-      </p:sp>
-      <p:sp>
-        <p:nvSpPr>
-          <p:cNvPr id="15" name="Shape 13"/>
-          <p:cNvSpPr/>
-          <p:nvPr/>
-        </p:nvSpPr>
-        <p:spPr>
-          <a:xfrm>
-            <a:off x="457200" y="3657600"/>
-            <a:ext cx="411480" cy="411480"/>
-          </a:xfrm>
-          <a:prstGeom prst="ellipse">
-            <a:avLst/>
-          </a:prstGeom>
-          <a:solidFill>
-            <a:srgbClr val="0089C2"/>
-          </a:solidFill>
-          <a:ln w="12700">
-            <a:solidFill>
-              <a:srgbClr val="0089C2"/>
-            </a:solidFill>
-            <a:prstDash val="solid"/>
-          </a:ln>
-        </p:spPr>
-      </p:sp>
-      <p:sp>
-        <p:nvSpPr>
-          <p:cNvPr id="16" name="Text 14"/>
-          <p:cNvSpPr txBox="1"/>
-          <p:nvPr/>
-        </p:nvSpPr>
-        <p:spPr>
-          <a:xfrm>
-            <a:off x="457200" y="3657600"/>
-            <a:ext cx="411480" cy="411480"/>
-          </a:xfrm>
-          <a:prstGeom prst="rect">
-            <a:avLst/>
-          </a:prstGeom>
-          <a:noFill/>
-          <a:ln/>
-        </p:spPr>
-        <p:txBody>
-          <a:bodyPr wrap="square" lIns="0" tIns="0" rIns="0" bIns="0" rtlCol="0" anchor="ctr"/>
-          <a:lstStyle/>
-          <a:p>
-            <a:pPr algn="ctr" indent="0" marL="0">
-              <a:buNone/>
-            </a:pPr>
-            <a:r>
-              <a:rPr lang="en-US" sz="1300" b="1" dirty="0">
-                <a:solidFill>
-                  <a:srgbClr val="FFFFFF"/>
-                </a:solidFill>
-              </a:rPr>
-              <a:t>5</a:t>
-            </a:r>
-            <a:endParaRPr lang="en-US" sz="1300" dirty="0"/>
-          </a:p>
-        </p:txBody>
-      </p:sp>
-      <p:sp>
-        <p:nvSpPr>
-          <p:cNvPr id="17" name="Text 15"/>
-          <p:cNvSpPr txBox="1"/>
-          <p:nvPr/>
-        </p:nvSpPr>
-        <p:spPr>
-          <a:xfrm>
-            <a:off x="1051560" y="3611880"/>
-            <a:ext cx="7589520" cy="502920"/>
-          </a:xfrm>
-          <a:prstGeom prst="rect">
-            <a:avLst/>
-          </a:prstGeom>
-          <a:noFill/>
-          <a:ln/>
-        </p:spPr>
-        <p:txBody>
-          <a:bodyPr wrap="square" lIns="0" tIns="0" rIns="0" bIns="0" rtlCol="0" anchor="ctr"/>
-          <a:lstStyle/>
-          <a:p>
-            <a:pPr indent="0" marL="0">
-              <a:buNone/>
-            </a:pPr>
-            <a:r>
-              <a:rPr lang="en-US" sz="1500" dirty="0">
-                <a:solidFill>
-                  <a:schemeClr val="tx1"/>
-                </a:solidFill>
-              </a:rPr>
-              <a:t>Prepare the Central America entry (year 2)</a:t>
-            </a:r>
-            <a:endParaRPr lang="en-US" sz="1500" dirty="0"/>
-          </a:p>
-        </p:txBody>
-      </p:sp>
-      <p:sp>
-        <p:nvSpPr>
-          <p:cNvPr id="25" name="Slide Number Placeholder 0"/>
-          <p:cNvSpPr>
-            <a:spLocks noGrp="1"/>
-          </p:cNvSpPr>
-          <p:nvPr>
-            <p:ph type="sldNum" sz="quarter" idx="4294967295"/>
-          </p:nvPr>
-        </p:nvSpPr>
-        <p:spPr>
-          <a:xfrm>
-            <a:off x="8229600" y="4800600"/>
-            <a:ext cx="457200" cy="228600"/>
-          </a:xfrm>
-          <a:prstGeom prst="rect">
-            <a:avLst/>
-          </a:prstGeom>
-          <a:extLst>
-            <a:ext uri="{C572A759-6A51-4108-AA02-DFA0A04FC94B}">
-              <ma14:wrappingTextBoxFlag xmlns:ma14="http://schemas.microsoft.com/office/mac/drawingml/2011/main" val="0"/>
-            </a:ext>
-          </a:extLst>
-        </p:spPr>
-        <p:txBody>
-          <a:bodyPr/>
-          <a:lstStyle>
-            <a:lvl1pPr>
-              <a:defRPr sz="900">
-                <a:solidFill>
-                  <a:srgbClr val="7A8299"/>
-                </a:solidFill>
-              </a:defRPr>
-            </a:lvl1pPr>
-          </a:lstStyle>
-          <a:p>
-            <a:pPr algn="r"/>
-            <a:fld id="{F7021451-1387-4CA6-816F-3879F97B5CBC}" type="slidenum">
-              <a:rPr b="0" lang="en-US"/>
-              <a:t>36</a:t>
-            </a:fld>
-            <a:endParaRPr lang="en-US"/>
-          </a:p>
-        </p:txBody>
       </p:sp>
     </p:spTree>
   </p:cSld>
@@ -29959,6 +29289,1198 @@
 <file path=ppt/slides/slide37.xml><?xml version="1.0" encoding="utf-8"?>
 <p:sld xmlns:a="http://schemas.openxmlformats.org/drawingml/2006/main" xmlns:r="http://schemas.openxmlformats.org/officeDocument/2006/relationships" xmlns:p="http://schemas.openxmlformats.org/presentationml/2006/main">
   <p:cSld name="Slide 37">
+    <p:spTree>
+      <p:nvGrpSpPr>
+        <p:cNvPr id="1" name=""/>
+        <p:cNvGrpSpPr/>
+        <p:nvPr/>
+      </p:nvGrpSpPr>
+      <p:grpSpPr>
+        <a:xfrm>
+          <a:off x="0" y="0"/>
+          <a:ext cx="0" cy="0"/>
+          <a:chOff x="0" y="0"/>
+          <a:chExt cx="0" cy="0"/>
+        </a:xfrm>
+      </p:grpSpPr>
+      <p:sp>
+        <p:nvSpPr>
+          <p:cNvPr id="2" name="Text 0"/>
+          <p:cNvSpPr/>
+          <p:nvPr>
+            <p:ph idx="100" type="title" hasCustomPrompt="1"/>
+          </p:nvPr>
+        </p:nvSpPr>
+        <p:spPr>
+          <a:xfrm>
+            <a:off x="457200" y="274320"/>
+            <a:ext cx="8229600" cy="640080"/>
+          </a:xfrm>
+          <a:prstGeom prst="rect">
+            <a:avLst/>
+          </a:prstGeom>
+          <a:noFill/>
+          <a:ln/>
+        </p:spPr>
+        <p:txBody>
+          <a:bodyPr wrap="square" rtlCol="0" anchor="ctr"/>
+          <a:lstStyle/>
+          <a:p>
+            <a:pPr indent="0" marL="0">
+              <a:buNone/>
+            </a:pPr>
+            <a:r>
+              <a:rPr lang="en-US" sz="2600" b="1" dirty="0">
+                <a:solidFill>
+                  <a:schemeClr val="tx1"/>
+                </a:solidFill>
+              </a:rPr>
+              <a:t>Conclusions</a:t>
+            </a:r>
+            <a:endParaRPr lang="en-US" sz="2600" dirty="0"/>
+          </a:p>
+        </p:txBody>
+      </p:sp>
+      <p:sp>
+        <p:nvSpPr>
+          <p:cNvPr id="3" name="Shape 1"/>
+          <p:cNvSpPr/>
+          <p:nvPr/>
+        </p:nvSpPr>
+        <p:spPr>
+          <a:xfrm>
+            <a:off x="457200" y="1069848"/>
+            <a:ext cx="411480" cy="411480"/>
+          </a:xfrm>
+          <a:prstGeom prst="ellipse">
+            <a:avLst/>
+          </a:prstGeom>
+          <a:solidFill>
+            <a:srgbClr val="0089C2"/>
+          </a:solidFill>
+          <a:ln w="12700">
+            <a:solidFill>
+              <a:srgbClr val="0089C2"/>
+            </a:solidFill>
+            <a:prstDash val="solid"/>
+          </a:ln>
+        </p:spPr>
+      </p:sp>
+      <p:sp>
+        <p:nvSpPr>
+          <p:cNvPr id="4" name="Text 2"/>
+          <p:cNvSpPr txBox="1"/>
+          <p:nvPr/>
+        </p:nvSpPr>
+        <p:spPr>
+          <a:xfrm>
+            <a:off x="457200" y="1069848"/>
+            <a:ext cx="411480" cy="411480"/>
+          </a:xfrm>
+          <a:prstGeom prst="rect">
+            <a:avLst/>
+          </a:prstGeom>
+          <a:noFill/>
+          <a:ln/>
+        </p:spPr>
+        <p:txBody>
+          <a:bodyPr wrap="square" lIns="0" tIns="0" rIns="0" bIns="0" rtlCol="0" anchor="ctr"/>
+          <a:lstStyle/>
+          <a:p>
+            <a:pPr algn="ctr" indent="0" marL="0">
+              <a:buNone/>
+            </a:pPr>
+            <a:r>
+              <a:rPr lang="en-US" sz="1300" b="1" dirty="0">
+                <a:solidFill>
+                  <a:srgbClr val="FFFFFF"/>
+                </a:solidFill>
+              </a:rPr>
+              <a:t>1</a:t>
+            </a:r>
+            <a:endParaRPr lang="en-US" sz="1300" dirty="0"/>
+          </a:p>
+        </p:txBody>
+      </p:sp>
+      <p:sp>
+        <p:nvSpPr>
+          <p:cNvPr id="5" name="Text 3"/>
+          <p:cNvSpPr txBox="1"/>
+          <p:nvPr/>
+        </p:nvSpPr>
+        <p:spPr>
+          <a:xfrm>
+            <a:off x="1051560" y="1005840"/>
+            <a:ext cx="7589520" cy="548640"/>
+          </a:xfrm>
+          <a:prstGeom prst="rect">
+            <a:avLst/>
+          </a:prstGeom>
+          <a:noFill/>
+          <a:ln/>
+        </p:spPr>
+        <p:txBody>
+          <a:bodyPr wrap="square" lIns="0" tIns="0" rIns="0" bIns="0" rtlCol="0" anchor="ctr"/>
+          <a:lstStyle/>
+          <a:p>
+            <a:pPr indent="0" marL="0">
+              <a:buNone/>
+            </a:pPr>
+            <a:r>
+              <a:rPr lang="en-US" sz="1400" dirty="0">
+                <a:solidFill>
+                  <a:schemeClr val="tx1"/>
+                </a:solidFill>
+              </a:rPr>
+              <a:t>Mexico’s industry must stand out against imports: hybrid printing answers that need.</a:t>
+            </a:r>
+            <a:endParaRPr lang="en-US" sz="1400" dirty="0"/>
+          </a:p>
+        </p:txBody>
+      </p:sp>
+      <p:sp>
+        <p:nvSpPr>
+          <p:cNvPr id="6" name="Shape 4"/>
+          <p:cNvSpPr/>
+          <p:nvPr/>
+        </p:nvSpPr>
+        <p:spPr>
+          <a:xfrm>
+            <a:off x="457200" y="1755648"/>
+            <a:ext cx="411480" cy="411480"/>
+          </a:xfrm>
+          <a:prstGeom prst="ellipse">
+            <a:avLst/>
+          </a:prstGeom>
+          <a:solidFill>
+            <a:srgbClr val="C2185B"/>
+          </a:solidFill>
+          <a:ln w="12700">
+            <a:solidFill>
+              <a:srgbClr val="C2185B"/>
+            </a:solidFill>
+            <a:prstDash val="solid"/>
+          </a:ln>
+        </p:spPr>
+      </p:sp>
+      <p:sp>
+        <p:nvSpPr>
+          <p:cNvPr id="7" name="Text 5"/>
+          <p:cNvSpPr txBox="1"/>
+          <p:nvPr/>
+        </p:nvSpPr>
+        <p:spPr>
+          <a:xfrm>
+            <a:off x="457200" y="1755648"/>
+            <a:ext cx="411480" cy="411480"/>
+          </a:xfrm>
+          <a:prstGeom prst="rect">
+            <a:avLst/>
+          </a:prstGeom>
+          <a:noFill/>
+          <a:ln/>
+        </p:spPr>
+        <p:txBody>
+          <a:bodyPr wrap="square" lIns="0" tIns="0" rIns="0" bIns="0" rtlCol="0" anchor="ctr"/>
+          <a:lstStyle/>
+          <a:p>
+            <a:pPr algn="ctr" indent="0" marL="0">
+              <a:buNone/>
+            </a:pPr>
+            <a:r>
+              <a:rPr lang="en-US" sz="1300" b="1" dirty="0">
+                <a:solidFill>
+                  <a:srgbClr val="FFFFFF"/>
+                </a:solidFill>
+              </a:rPr>
+              <a:t>2</a:t>
+            </a:r>
+            <a:endParaRPr lang="en-US" sz="1300" dirty="0"/>
+          </a:p>
+        </p:txBody>
+      </p:sp>
+      <p:sp>
+        <p:nvSpPr>
+          <p:cNvPr id="8" name="Text 6"/>
+          <p:cNvSpPr txBox="1"/>
+          <p:nvPr/>
+        </p:nvSpPr>
+        <p:spPr>
+          <a:xfrm>
+            <a:off x="1051560" y="1691640"/>
+            <a:ext cx="7589520" cy="548640"/>
+          </a:xfrm>
+          <a:prstGeom prst="rect">
+            <a:avLst/>
+          </a:prstGeom>
+          <a:noFill/>
+          <a:ln/>
+        </p:spPr>
+        <p:txBody>
+          <a:bodyPr wrap="square" lIns="0" tIns="0" rIns="0" bIns="0" rtlCol="0" anchor="ctr"/>
+          <a:lstStyle/>
+          <a:p>
+            <a:pPr indent="0" marL="0">
+              <a:buNone/>
+            </a:pPr>
+            <a:r>
+              <a:rPr lang="en-US" sz="1400" dirty="0">
+                <a:solidFill>
+                  <a:schemeClr val="tx1"/>
+                </a:solidFill>
+              </a:rPr>
+              <a:t>The reachable market is concentrated (~1,900 firms): it is won with consultative selling to a few large accounts.</a:t>
+            </a:r>
+            <a:endParaRPr lang="en-US" sz="1400" dirty="0"/>
+          </a:p>
+        </p:txBody>
+      </p:sp>
+      <p:sp>
+        <p:nvSpPr>
+          <p:cNvPr id="9" name="Shape 7"/>
+          <p:cNvSpPr/>
+          <p:nvPr/>
+        </p:nvSpPr>
+        <p:spPr>
+          <a:xfrm>
+            <a:off x="457200" y="2441448"/>
+            <a:ext cx="411480" cy="411480"/>
+          </a:xfrm>
+          <a:prstGeom prst="ellipse">
+            <a:avLst/>
+          </a:prstGeom>
+          <a:solidFill>
+            <a:srgbClr val="F2B705"/>
+          </a:solidFill>
+          <a:ln w="12700">
+            <a:solidFill>
+              <a:srgbClr val="F2B705"/>
+            </a:solidFill>
+            <a:prstDash val="solid"/>
+          </a:ln>
+        </p:spPr>
+      </p:sp>
+      <p:sp>
+        <p:nvSpPr>
+          <p:cNvPr id="10" name="Text 8"/>
+          <p:cNvSpPr txBox="1"/>
+          <p:nvPr/>
+        </p:nvSpPr>
+        <p:spPr>
+          <a:xfrm>
+            <a:off x="457200" y="2441448"/>
+            <a:ext cx="411480" cy="411480"/>
+          </a:xfrm>
+          <a:prstGeom prst="rect">
+            <a:avLst/>
+          </a:prstGeom>
+          <a:noFill/>
+          <a:ln/>
+        </p:spPr>
+        <p:txBody>
+          <a:bodyPr wrap="square" lIns="0" tIns="0" rIns="0" bIns="0" rtlCol="0" anchor="ctr"/>
+          <a:lstStyle/>
+          <a:p>
+            <a:pPr algn="ctr" indent="0" marL="0">
+              <a:buNone/>
+            </a:pPr>
+            <a:r>
+              <a:rPr lang="en-US" sz="1300" b="1" dirty="0">
+                <a:solidFill>
+                  <a:srgbClr val="1B1F3B"/>
+                </a:solidFill>
+              </a:rPr>
+              <a:t>3</a:t>
+            </a:r>
+            <a:endParaRPr lang="en-US" sz="1300" dirty="0"/>
+          </a:p>
+        </p:txBody>
+      </p:sp>
+      <p:sp>
+        <p:nvSpPr>
+          <p:cNvPr id="11" name="Text 9"/>
+          <p:cNvSpPr txBox="1"/>
+          <p:nvPr/>
+        </p:nvSpPr>
+        <p:spPr>
+          <a:xfrm>
+            <a:off x="1051560" y="2377440"/>
+            <a:ext cx="7589520" cy="548640"/>
+          </a:xfrm>
+          <a:prstGeom prst="rect">
+            <a:avLst/>
+          </a:prstGeom>
+          <a:noFill/>
+          <a:ln/>
+        </p:spPr>
+        <p:txBody>
+          <a:bodyPr wrap="square" lIns="0" tIns="0" rIns="0" bIns="0" rtlCol="0" anchor="ctr"/>
+          <a:lstStyle/>
+          <a:p>
+            <a:pPr indent="0" marL="0">
+              <a:buNone/>
+            </a:pPr>
+            <a:r>
+              <a:rPr lang="en-US" sz="1400" dirty="0">
+                <a:solidFill>
+                  <a:schemeClr val="tx1"/>
+                </a:solidFill>
+              </a:rPr>
+              <a:t>Nobody owns the category: no formal distributor of Chinese hybrids and no turnkey offer with local service.</a:t>
+            </a:r>
+            <a:endParaRPr lang="en-US" sz="1400" dirty="0"/>
+          </a:p>
+        </p:txBody>
+      </p:sp>
+      <p:sp>
+        <p:nvSpPr>
+          <p:cNvPr id="12" name="Shape 10"/>
+          <p:cNvSpPr/>
+          <p:nvPr/>
+        </p:nvSpPr>
+        <p:spPr>
+          <a:xfrm>
+            <a:off x="457200" y="3127248"/>
+            <a:ext cx="411480" cy="411480"/>
+          </a:xfrm>
+          <a:prstGeom prst="ellipse">
+            <a:avLst/>
+          </a:prstGeom>
+          <a:solidFill>
+            <a:srgbClr val="1B1F3B"/>
+          </a:solidFill>
+          <a:ln w="12700">
+            <a:solidFill>
+              <a:srgbClr val="1B1F3B"/>
+            </a:solidFill>
+            <a:prstDash val="solid"/>
+          </a:ln>
+        </p:spPr>
+      </p:sp>
+      <p:sp>
+        <p:nvSpPr>
+          <p:cNvPr id="13" name="Text 11"/>
+          <p:cNvSpPr txBox="1"/>
+          <p:nvPr/>
+        </p:nvSpPr>
+        <p:spPr>
+          <a:xfrm>
+            <a:off x="457200" y="3127248"/>
+            <a:ext cx="411480" cy="411480"/>
+          </a:xfrm>
+          <a:prstGeom prst="rect">
+            <a:avLst/>
+          </a:prstGeom>
+          <a:noFill/>
+          <a:ln/>
+        </p:spPr>
+        <p:txBody>
+          <a:bodyPr wrap="square" lIns="0" tIns="0" rIns="0" bIns="0" rtlCol="0" anchor="ctr"/>
+          <a:lstStyle/>
+          <a:p>
+            <a:pPr algn="ctr" indent="0" marL="0">
+              <a:buNone/>
+            </a:pPr>
+            <a:r>
+              <a:rPr lang="en-US" sz="1300" b="1" dirty="0">
+                <a:solidFill>
+                  <a:srgbClr val="FFFFFF"/>
+                </a:solidFill>
+              </a:rPr>
+              <a:t>4</a:t>
+            </a:r>
+            <a:endParaRPr lang="en-US" sz="1300" dirty="0"/>
+          </a:p>
+        </p:txBody>
+      </p:sp>
+      <p:sp>
+        <p:nvSpPr>
+          <p:cNvPr id="14" name="Text 12"/>
+          <p:cNvSpPr txBox="1"/>
+          <p:nvPr/>
+        </p:nvSpPr>
+        <p:spPr>
+          <a:xfrm>
+            <a:off x="1051560" y="3063240"/>
+            <a:ext cx="7589520" cy="548640"/>
+          </a:xfrm>
+          <a:prstGeom prst="rect">
+            <a:avLst/>
+          </a:prstGeom>
+          <a:noFill/>
+          <a:ln/>
+        </p:spPr>
+        <p:txBody>
+          <a:bodyPr wrap="square" lIns="0" tIns="0" rIns="0" bIns="0" rtlCol="0" anchor="ctr"/>
+          <a:lstStyle/>
+          <a:p>
+            <a:pPr indent="0" marL="0">
+              <a:buNone/>
+            </a:pPr>
+            <a:r>
+              <a:rPr lang="en-US" sz="1400" dirty="0">
+                <a:solidFill>
+                  <a:schemeClr val="tx1"/>
+                </a:solidFill>
+              </a:rPr>
+              <a:t>Ink competition is premium (Avient, Matsui) or cheap (ScreenTec, local brands): CLT competes with package and service.</a:t>
+            </a:r>
+            <a:endParaRPr lang="en-US" sz="1400" dirty="0"/>
+          </a:p>
+        </p:txBody>
+      </p:sp>
+      <p:sp>
+        <p:nvSpPr>
+          <p:cNvPr id="15" name="Shape 13"/>
+          <p:cNvSpPr/>
+          <p:nvPr/>
+        </p:nvSpPr>
+        <p:spPr>
+          <a:xfrm>
+            <a:off x="457200" y="3813048"/>
+            <a:ext cx="411480" cy="411480"/>
+          </a:xfrm>
+          <a:prstGeom prst="ellipse">
+            <a:avLst/>
+          </a:prstGeom>
+          <a:solidFill>
+            <a:srgbClr val="0089C2"/>
+          </a:solidFill>
+          <a:ln w="12700">
+            <a:solidFill>
+              <a:srgbClr val="0089C2"/>
+            </a:solidFill>
+            <a:prstDash val="solid"/>
+          </a:ln>
+        </p:spPr>
+      </p:sp>
+      <p:sp>
+        <p:nvSpPr>
+          <p:cNvPr id="16" name="Text 14"/>
+          <p:cNvSpPr txBox="1"/>
+          <p:nvPr/>
+        </p:nvSpPr>
+        <p:spPr>
+          <a:xfrm>
+            <a:off x="457200" y="3813048"/>
+            <a:ext cx="411480" cy="411480"/>
+          </a:xfrm>
+          <a:prstGeom prst="rect">
+            <a:avLst/>
+          </a:prstGeom>
+          <a:noFill/>
+          <a:ln/>
+        </p:spPr>
+        <p:txBody>
+          <a:bodyPr wrap="square" lIns="0" tIns="0" rIns="0" bIns="0" rtlCol="0" anchor="ctr"/>
+          <a:lstStyle/>
+          <a:p>
+            <a:pPr algn="ctr" indent="0" marL="0">
+              <a:buNone/>
+            </a:pPr>
+            <a:r>
+              <a:rPr lang="en-US" sz="1300" b="1" dirty="0">
+                <a:solidFill>
+                  <a:srgbClr val="FFFFFF"/>
+                </a:solidFill>
+              </a:rPr>
+              <a:t>5</a:t>
+            </a:r>
+            <a:endParaRPr lang="en-US" sz="1300" dirty="0"/>
+          </a:p>
+        </p:txBody>
+      </p:sp>
+      <p:sp>
+        <p:nvSpPr>
+          <p:cNvPr id="17" name="Text 15"/>
+          <p:cNvSpPr txBox="1"/>
+          <p:nvPr/>
+        </p:nvSpPr>
+        <p:spPr>
+          <a:xfrm>
+            <a:off x="1051560" y="3749040"/>
+            <a:ext cx="7589520" cy="548640"/>
+          </a:xfrm>
+          <a:prstGeom prst="rect">
+            <a:avLst/>
+          </a:prstGeom>
+          <a:noFill/>
+          <a:ln/>
+        </p:spPr>
+        <p:txBody>
+          <a:bodyPr wrap="square" lIns="0" tIns="0" rIns="0" bIns="0" rtlCol="0" anchor="ctr"/>
+          <a:lstStyle/>
+          <a:p>
+            <a:pPr indent="0" marL="0">
+              <a:buNone/>
+            </a:pPr>
+            <a:r>
+              <a:rPr lang="en-US" sz="1400" dirty="0">
+                <a:solidFill>
+                  <a:schemeClr val="tx1"/>
+                </a:solidFill>
+              </a:rPr>
+              <a:t>2026 tariffs and USMCA favor producing in Mexico; Central America and Peru are the next wave.</a:t>
+            </a:r>
+            <a:endParaRPr lang="en-US" sz="1400" dirty="0"/>
+          </a:p>
+        </p:txBody>
+      </p:sp>
+      <p:sp>
+        <p:nvSpPr>
+          <p:cNvPr id="25" name="Slide Number Placeholder 0"/>
+          <p:cNvSpPr>
+            <a:spLocks noGrp="1"/>
+          </p:cNvSpPr>
+          <p:nvPr>
+            <p:ph type="sldNum" sz="quarter" idx="4294967295"/>
+          </p:nvPr>
+        </p:nvSpPr>
+        <p:spPr>
+          <a:xfrm>
+            <a:off x="8229600" y="4800600"/>
+            <a:ext cx="457200" cy="228600"/>
+          </a:xfrm>
+          <a:prstGeom prst="rect">
+            <a:avLst/>
+          </a:prstGeom>
+          <a:extLst>
+            <a:ext uri="{C572A759-6A51-4108-AA02-DFA0A04FC94B}">
+              <ma14:wrappingTextBoxFlag xmlns:ma14="http://schemas.microsoft.com/office/mac/drawingml/2011/main" val="0"/>
+            </a:ext>
+          </a:extLst>
+        </p:spPr>
+        <p:txBody>
+          <a:bodyPr/>
+          <a:lstStyle>
+            <a:lvl1pPr>
+              <a:defRPr sz="900">
+                <a:solidFill>
+                  <a:srgbClr val="7A8299"/>
+                </a:solidFill>
+              </a:defRPr>
+            </a:lvl1pPr>
+          </a:lstStyle>
+          <a:p>
+            <a:pPr algn="r"/>
+            <a:fld id="{F7021451-1387-4CA6-816F-3879F97B5CBC}" type="slidenum">
+              <a:rPr b="0" lang="en-US"/>
+              <a:t>37</a:t>
+            </a:fld>
+            <a:endParaRPr lang="en-US"/>
+          </a:p>
+        </p:txBody>
+      </p:sp>
+    </p:spTree>
+  </p:cSld>
+  <p:clrMapOvr>
+    <a:masterClrMapping/>
+  </p:clrMapOvr>
+  <p:transition spd="med">
+    <p:fade/>
+  </p:transition>
+</p:sld>
+</file>
+
+<file path=ppt/slides/slide38.xml><?xml version="1.0" encoding="utf-8"?>
+<p:sld xmlns:a="http://schemas.openxmlformats.org/drawingml/2006/main" xmlns:r="http://schemas.openxmlformats.org/officeDocument/2006/relationships" xmlns:p="http://schemas.openxmlformats.org/presentationml/2006/main">
+  <p:cSld name="Slide 38">
+    <p:spTree>
+      <p:nvGrpSpPr>
+        <p:cNvPr id="1" name=""/>
+        <p:cNvGrpSpPr/>
+        <p:nvPr/>
+      </p:nvGrpSpPr>
+      <p:grpSpPr>
+        <a:xfrm>
+          <a:off x="0" y="0"/>
+          <a:ext cx="0" cy="0"/>
+          <a:chOff x="0" y="0"/>
+          <a:chExt cx="0" cy="0"/>
+        </a:xfrm>
+      </p:grpSpPr>
+      <p:sp>
+        <p:nvSpPr>
+          <p:cNvPr id="2" name="Text 0"/>
+          <p:cNvSpPr/>
+          <p:nvPr>
+            <p:ph idx="100" type="title" hasCustomPrompt="1"/>
+          </p:nvPr>
+        </p:nvSpPr>
+        <p:spPr>
+          <a:xfrm>
+            <a:off x="457200" y="274320"/>
+            <a:ext cx="8229600" cy="640080"/>
+          </a:xfrm>
+          <a:prstGeom prst="rect">
+            <a:avLst/>
+          </a:prstGeom>
+          <a:noFill/>
+          <a:ln/>
+        </p:spPr>
+        <p:txBody>
+          <a:bodyPr wrap="square" rtlCol="0" anchor="ctr"/>
+          <a:lstStyle/>
+          <a:p>
+            <a:pPr indent="0" marL="0">
+              <a:buNone/>
+            </a:pPr>
+            <a:r>
+              <a:rPr lang="en-US" sz="2600" b="1" dirty="0">
+                <a:solidFill>
+                  <a:schemeClr val="tx1"/>
+                </a:solidFill>
+              </a:rPr>
+              <a:t>Recommendations and next steps</a:t>
+            </a:r>
+            <a:endParaRPr lang="en-US" sz="2600" dirty="0"/>
+          </a:p>
+        </p:txBody>
+      </p:sp>
+      <p:sp>
+        <p:nvSpPr>
+          <p:cNvPr id="3" name="Shape 1"/>
+          <p:cNvSpPr/>
+          <p:nvPr/>
+        </p:nvSpPr>
+        <p:spPr>
+          <a:xfrm>
+            <a:off x="457200" y="1097280"/>
+            <a:ext cx="411480" cy="411480"/>
+          </a:xfrm>
+          <a:prstGeom prst="ellipse">
+            <a:avLst/>
+          </a:prstGeom>
+          <a:solidFill>
+            <a:srgbClr val="0089C2"/>
+          </a:solidFill>
+          <a:ln w="12700">
+            <a:solidFill>
+              <a:srgbClr val="0089C2"/>
+            </a:solidFill>
+            <a:prstDash val="solid"/>
+          </a:ln>
+        </p:spPr>
+      </p:sp>
+      <p:sp>
+        <p:nvSpPr>
+          <p:cNvPr id="4" name="Text 2"/>
+          <p:cNvSpPr txBox="1"/>
+          <p:nvPr/>
+        </p:nvSpPr>
+        <p:spPr>
+          <a:xfrm>
+            <a:off x="457200" y="1097280"/>
+            <a:ext cx="411480" cy="411480"/>
+          </a:xfrm>
+          <a:prstGeom prst="rect">
+            <a:avLst/>
+          </a:prstGeom>
+          <a:noFill/>
+          <a:ln/>
+        </p:spPr>
+        <p:txBody>
+          <a:bodyPr wrap="square" lIns="0" tIns="0" rIns="0" bIns="0" rtlCol="0" anchor="ctr"/>
+          <a:lstStyle/>
+          <a:p>
+            <a:pPr algn="ctr" indent="0" marL="0">
+              <a:buNone/>
+            </a:pPr>
+            <a:r>
+              <a:rPr lang="en-US" sz="1300" b="1" dirty="0">
+                <a:solidFill>
+                  <a:srgbClr val="FFFFFF"/>
+                </a:solidFill>
+              </a:rPr>
+              <a:t>1</a:t>
+            </a:r>
+            <a:endParaRPr lang="en-US" sz="1300" dirty="0"/>
+          </a:p>
+        </p:txBody>
+      </p:sp>
+      <p:sp>
+        <p:nvSpPr>
+          <p:cNvPr id="5" name="Text 3"/>
+          <p:cNvSpPr txBox="1"/>
+          <p:nvPr/>
+        </p:nvSpPr>
+        <p:spPr>
+          <a:xfrm>
+            <a:off x="1051560" y="1051560"/>
+            <a:ext cx="7589520" cy="502920"/>
+          </a:xfrm>
+          <a:prstGeom prst="rect">
+            <a:avLst/>
+          </a:prstGeom>
+          <a:noFill/>
+          <a:ln/>
+        </p:spPr>
+        <p:txBody>
+          <a:bodyPr wrap="square" lIns="0" tIns="0" rIns="0" bIns="0" rtlCol="0" anchor="ctr"/>
+          <a:lstStyle/>
+          <a:p>
+            <a:pPr indent="0" marL="0">
+              <a:buNone/>
+            </a:pPr>
+            <a:r>
+              <a:rPr lang="en-US" sz="1500" dirty="0">
+                <a:solidFill>
+                  <a:schemeClr val="tx1"/>
+                </a:solidFill>
+              </a:rPr>
+              <a:t>Formal CLT quotation to replace estimates</a:t>
+            </a:r>
+            <a:endParaRPr lang="en-US" sz="1500" dirty="0"/>
+          </a:p>
+        </p:txBody>
+      </p:sp>
+      <p:sp>
+        <p:nvSpPr>
+          <p:cNvPr id="6" name="Shape 4"/>
+          <p:cNvSpPr/>
+          <p:nvPr/>
+        </p:nvSpPr>
+        <p:spPr>
+          <a:xfrm>
+            <a:off x="457200" y="1737360"/>
+            <a:ext cx="411480" cy="411480"/>
+          </a:xfrm>
+          <a:prstGeom prst="ellipse">
+            <a:avLst/>
+          </a:prstGeom>
+          <a:solidFill>
+            <a:srgbClr val="C2185B"/>
+          </a:solidFill>
+          <a:ln w="12700">
+            <a:solidFill>
+              <a:srgbClr val="C2185B"/>
+            </a:solidFill>
+            <a:prstDash val="solid"/>
+          </a:ln>
+        </p:spPr>
+      </p:sp>
+      <p:sp>
+        <p:nvSpPr>
+          <p:cNvPr id="7" name="Text 5"/>
+          <p:cNvSpPr txBox="1"/>
+          <p:nvPr/>
+        </p:nvSpPr>
+        <p:spPr>
+          <a:xfrm>
+            <a:off x="457200" y="1737360"/>
+            <a:ext cx="411480" cy="411480"/>
+          </a:xfrm>
+          <a:prstGeom prst="rect">
+            <a:avLst/>
+          </a:prstGeom>
+          <a:noFill/>
+          <a:ln/>
+        </p:spPr>
+        <p:txBody>
+          <a:bodyPr wrap="square" lIns="0" tIns="0" rIns="0" bIns="0" rtlCol="0" anchor="ctr"/>
+          <a:lstStyle/>
+          <a:p>
+            <a:pPr algn="ctr" indent="0" marL="0">
+              <a:buNone/>
+            </a:pPr>
+            <a:r>
+              <a:rPr lang="en-US" sz="1300" b="1" dirty="0">
+                <a:solidFill>
+                  <a:srgbClr val="FFFFFF"/>
+                </a:solidFill>
+              </a:rPr>
+              <a:t>2</a:t>
+            </a:r>
+            <a:endParaRPr lang="en-US" sz="1300" dirty="0"/>
+          </a:p>
+        </p:txBody>
+      </p:sp>
+      <p:sp>
+        <p:nvSpPr>
+          <p:cNvPr id="8" name="Text 6"/>
+          <p:cNvSpPr txBox="1"/>
+          <p:nvPr/>
+        </p:nvSpPr>
+        <p:spPr>
+          <a:xfrm>
+            <a:off x="1051560" y="1691640"/>
+            <a:ext cx="7589520" cy="502920"/>
+          </a:xfrm>
+          <a:prstGeom prst="rect">
+            <a:avLst/>
+          </a:prstGeom>
+          <a:noFill/>
+          <a:ln/>
+        </p:spPr>
+        <p:txBody>
+          <a:bodyPr wrap="square" lIns="0" tIns="0" rIns="0" bIns="0" rtlCol="0" anchor="ctr"/>
+          <a:lstStyle/>
+          <a:p>
+            <a:pPr indent="0" marL="0">
+              <a:buNone/>
+            </a:pPr>
+            <a:r>
+              <a:rPr lang="en-US" sz="1500" dirty="0">
+                <a:solidFill>
+                  <a:schemeClr val="tx1"/>
+                </a:solidFill>
+              </a:rPr>
+              <a:t>Validate consumption and prices with 10–15 shops</a:t>
+            </a:r>
+            <a:endParaRPr lang="en-US" sz="1500" dirty="0"/>
+          </a:p>
+        </p:txBody>
+      </p:sp>
+      <p:sp>
+        <p:nvSpPr>
+          <p:cNvPr id="9" name="Shape 7"/>
+          <p:cNvSpPr/>
+          <p:nvPr/>
+        </p:nvSpPr>
+        <p:spPr>
+          <a:xfrm>
+            <a:off x="457200" y="2377440"/>
+            <a:ext cx="411480" cy="411480"/>
+          </a:xfrm>
+          <a:prstGeom prst="ellipse">
+            <a:avLst/>
+          </a:prstGeom>
+          <a:solidFill>
+            <a:srgbClr val="F2B705"/>
+          </a:solidFill>
+          <a:ln w="12700">
+            <a:solidFill>
+              <a:srgbClr val="F2B705"/>
+            </a:solidFill>
+            <a:prstDash val="solid"/>
+          </a:ln>
+        </p:spPr>
+      </p:sp>
+      <p:sp>
+        <p:nvSpPr>
+          <p:cNvPr id="10" name="Text 8"/>
+          <p:cNvSpPr txBox="1"/>
+          <p:nvPr/>
+        </p:nvSpPr>
+        <p:spPr>
+          <a:xfrm>
+            <a:off x="457200" y="2377440"/>
+            <a:ext cx="411480" cy="411480"/>
+          </a:xfrm>
+          <a:prstGeom prst="rect">
+            <a:avLst/>
+          </a:prstGeom>
+          <a:noFill/>
+          <a:ln/>
+        </p:spPr>
+        <p:txBody>
+          <a:bodyPr wrap="square" lIns="0" tIns="0" rIns="0" bIns="0" rtlCol="0" anchor="ctr"/>
+          <a:lstStyle/>
+          <a:p>
+            <a:pPr algn="ctr" indent="0" marL="0">
+              <a:buNone/>
+            </a:pPr>
+            <a:r>
+              <a:rPr lang="en-US" sz="1300" b="1" dirty="0">
+                <a:solidFill>
+                  <a:srgbClr val="1B1F3B"/>
+                </a:solidFill>
+              </a:rPr>
+              <a:t>3</a:t>
+            </a:r>
+            <a:endParaRPr lang="en-US" sz="1300" dirty="0"/>
+          </a:p>
+        </p:txBody>
+      </p:sp>
+      <p:sp>
+        <p:nvSpPr>
+          <p:cNvPr id="11" name="Text 9"/>
+          <p:cNvSpPr txBox="1"/>
+          <p:nvPr/>
+        </p:nvSpPr>
+        <p:spPr>
+          <a:xfrm>
+            <a:off x="1051560" y="2331720"/>
+            <a:ext cx="7589520" cy="502920"/>
+          </a:xfrm>
+          <a:prstGeom prst="rect">
+            <a:avLst/>
+          </a:prstGeom>
+          <a:noFill/>
+          <a:ln/>
+        </p:spPr>
+        <p:txBody>
+          <a:bodyPr wrap="square" lIns="0" tIns="0" rIns="0" bIns="0" rtlCol="0" anchor="ctr"/>
+          <a:lstStyle/>
+          <a:p>
+            <a:pPr indent="0" marL="0">
+              <a:buNone/>
+            </a:pPr>
+            <a:r>
+              <a:rPr lang="en-US" sz="1500" dirty="0">
+                <a:solidFill>
+                  <a:schemeClr val="tx1"/>
+                </a:solidFill>
+              </a:rPr>
+              <a:t>Open the demo room and work the 17 80/20 accounts</a:t>
+            </a:r>
+            <a:endParaRPr lang="en-US" sz="1500" dirty="0"/>
+          </a:p>
+        </p:txBody>
+      </p:sp>
+      <p:sp>
+        <p:nvSpPr>
+          <p:cNvPr id="12" name="Shape 10"/>
+          <p:cNvSpPr/>
+          <p:nvPr/>
+        </p:nvSpPr>
+        <p:spPr>
+          <a:xfrm>
+            <a:off x="457200" y="3017520"/>
+            <a:ext cx="411480" cy="411480"/>
+          </a:xfrm>
+          <a:prstGeom prst="ellipse">
+            <a:avLst/>
+          </a:prstGeom>
+          <a:solidFill>
+            <a:srgbClr val="1B1F3B"/>
+          </a:solidFill>
+          <a:ln w="12700">
+            <a:solidFill>
+              <a:srgbClr val="1B1F3B"/>
+            </a:solidFill>
+            <a:prstDash val="solid"/>
+          </a:ln>
+        </p:spPr>
+      </p:sp>
+      <p:sp>
+        <p:nvSpPr>
+          <p:cNvPr id="13" name="Text 11"/>
+          <p:cNvSpPr txBox="1"/>
+          <p:nvPr/>
+        </p:nvSpPr>
+        <p:spPr>
+          <a:xfrm>
+            <a:off x="457200" y="3017520"/>
+            <a:ext cx="411480" cy="411480"/>
+          </a:xfrm>
+          <a:prstGeom prst="rect">
+            <a:avLst/>
+          </a:prstGeom>
+          <a:noFill/>
+          <a:ln/>
+        </p:spPr>
+        <p:txBody>
+          <a:bodyPr wrap="square" lIns="0" tIns="0" rIns="0" bIns="0" rtlCol="0" anchor="ctr"/>
+          <a:lstStyle/>
+          <a:p>
+            <a:pPr algn="ctr" indent="0" marL="0">
+              <a:buNone/>
+            </a:pPr>
+            <a:r>
+              <a:rPr lang="en-US" sz="1300" b="1" dirty="0">
+                <a:solidFill>
+                  <a:srgbClr val="FFFFFF"/>
+                </a:solidFill>
+              </a:rPr>
+              <a:t>4</a:t>
+            </a:r>
+            <a:endParaRPr lang="en-US" sz="1300" dirty="0"/>
+          </a:p>
+        </p:txBody>
+      </p:sp>
+      <p:sp>
+        <p:nvSpPr>
+          <p:cNvPr id="14" name="Text 12"/>
+          <p:cNvSpPr txBox="1"/>
+          <p:nvPr/>
+        </p:nvSpPr>
+        <p:spPr>
+          <a:xfrm>
+            <a:off x="1051560" y="2971800"/>
+            <a:ext cx="7589520" cy="502920"/>
+          </a:xfrm>
+          <a:prstGeom prst="rect">
+            <a:avLst/>
+          </a:prstGeom>
+          <a:noFill/>
+          <a:ln/>
+        </p:spPr>
+        <p:txBody>
+          <a:bodyPr wrap="square" lIns="0" tIns="0" rIns="0" bIns="0" rtlCol="0" anchor="ctr"/>
+          <a:lstStyle/>
+          <a:p>
+            <a:pPr indent="0" marL="0">
+              <a:buNone/>
+            </a:pPr>
+            <a:r>
+              <a:rPr lang="en-US" sz="1500" dirty="0">
+                <a:solidFill>
+                  <a:schemeClr val="tx1"/>
+                </a:solidFill>
+              </a:rPr>
+              <a:t>Confirm tariffs and HS codes with a customs broker</a:t>
+            </a:r>
+            <a:endParaRPr lang="en-US" sz="1500" dirty="0"/>
+          </a:p>
+        </p:txBody>
+      </p:sp>
+      <p:sp>
+        <p:nvSpPr>
+          <p:cNvPr id="15" name="Shape 13"/>
+          <p:cNvSpPr/>
+          <p:nvPr/>
+        </p:nvSpPr>
+        <p:spPr>
+          <a:xfrm>
+            <a:off x="457200" y="3657600"/>
+            <a:ext cx="411480" cy="411480"/>
+          </a:xfrm>
+          <a:prstGeom prst="ellipse">
+            <a:avLst/>
+          </a:prstGeom>
+          <a:solidFill>
+            <a:srgbClr val="0089C2"/>
+          </a:solidFill>
+          <a:ln w="12700">
+            <a:solidFill>
+              <a:srgbClr val="0089C2"/>
+            </a:solidFill>
+            <a:prstDash val="solid"/>
+          </a:ln>
+        </p:spPr>
+      </p:sp>
+      <p:sp>
+        <p:nvSpPr>
+          <p:cNvPr id="16" name="Text 14"/>
+          <p:cNvSpPr txBox="1"/>
+          <p:nvPr/>
+        </p:nvSpPr>
+        <p:spPr>
+          <a:xfrm>
+            <a:off x="457200" y="3657600"/>
+            <a:ext cx="411480" cy="411480"/>
+          </a:xfrm>
+          <a:prstGeom prst="rect">
+            <a:avLst/>
+          </a:prstGeom>
+          <a:noFill/>
+          <a:ln/>
+        </p:spPr>
+        <p:txBody>
+          <a:bodyPr wrap="square" lIns="0" tIns="0" rIns="0" bIns="0" rtlCol="0" anchor="ctr"/>
+          <a:lstStyle/>
+          <a:p>
+            <a:pPr algn="ctr" indent="0" marL="0">
+              <a:buNone/>
+            </a:pPr>
+            <a:r>
+              <a:rPr lang="en-US" sz="1300" b="1" dirty="0">
+                <a:solidFill>
+                  <a:srgbClr val="FFFFFF"/>
+                </a:solidFill>
+              </a:rPr>
+              <a:t>5</a:t>
+            </a:r>
+            <a:endParaRPr lang="en-US" sz="1300" dirty="0"/>
+          </a:p>
+        </p:txBody>
+      </p:sp>
+      <p:sp>
+        <p:nvSpPr>
+          <p:cNvPr id="17" name="Text 15"/>
+          <p:cNvSpPr txBox="1"/>
+          <p:nvPr/>
+        </p:nvSpPr>
+        <p:spPr>
+          <a:xfrm>
+            <a:off x="1051560" y="3611880"/>
+            <a:ext cx="7589520" cy="502920"/>
+          </a:xfrm>
+          <a:prstGeom prst="rect">
+            <a:avLst/>
+          </a:prstGeom>
+          <a:noFill/>
+          <a:ln/>
+        </p:spPr>
+        <p:txBody>
+          <a:bodyPr wrap="square" lIns="0" tIns="0" rIns="0" bIns="0" rtlCol="0" anchor="ctr"/>
+          <a:lstStyle/>
+          <a:p>
+            <a:pPr indent="0" marL="0">
+              <a:buNone/>
+            </a:pPr>
+            <a:r>
+              <a:rPr lang="en-US" sz="1500" dirty="0">
+                <a:solidFill>
+                  <a:schemeClr val="tx1"/>
+                </a:solidFill>
+              </a:rPr>
+              <a:t>Prepare the Central America entry (year 2)</a:t>
+            </a:r>
+            <a:endParaRPr lang="en-US" sz="1500" dirty="0"/>
+          </a:p>
+        </p:txBody>
+      </p:sp>
+      <p:sp>
+        <p:nvSpPr>
+          <p:cNvPr id="25" name="Slide Number Placeholder 0"/>
+          <p:cNvSpPr>
+            <a:spLocks noGrp="1"/>
+          </p:cNvSpPr>
+          <p:nvPr>
+            <p:ph type="sldNum" sz="quarter" idx="4294967295"/>
+          </p:nvPr>
+        </p:nvSpPr>
+        <p:spPr>
+          <a:xfrm>
+            <a:off x="8229600" y="4800600"/>
+            <a:ext cx="457200" cy="228600"/>
+          </a:xfrm>
+          <a:prstGeom prst="rect">
+            <a:avLst/>
+          </a:prstGeom>
+          <a:extLst>
+            <a:ext uri="{C572A759-6A51-4108-AA02-DFA0A04FC94B}">
+              <ma14:wrappingTextBoxFlag xmlns:ma14="http://schemas.microsoft.com/office/mac/drawingml/2011/main" val="0"/>
+            </a:ext>
+          </a:extLst>
+        </p:spPr>
+        <p:txBody>
+          <a:bodyPr/>
+          <a:lstStyle>
+            <a:lvl1pPr>
+              <a:defRPr sz="900">
+                <a:solidFill>
+                  <a:srgbClr val="7A8299"/>
+                </a:solidFill>
+              </a:defRPr>
+            </a:lvl1pPr>
+          </a:lstStyle>
+          <a:p>
+            <a:pPr algn="r"/>
+            <a:fld id="{F7021451-1387-4CA6-816F-3879F97B5CBC}" type="slidenum">
+              <a:rPr b="0" lang="en-US"/>
+              <a:t>38</a:t>
+            </a:fld>
+            <a:endParaRPr lang="en-US"/>
+          </a:p>
+        </p:txBody>
+      </p:sp>
+    </p:spTree>
+  </p:cSld>
+  <p:clrMapOvr>
+    <a:masterClrMapping/>
+  </p:clrMapOvr>
+  <p:transition spd="med">
+    <p:fade/>
+  </p:transition>
+</p:sld>
+</file>
+
+<file path=ppt/slides/slide39.xml><?xml version="1.0" encoding="utf-8"?>
+<p:sld xmlns:a="http://schemas.openxmlformats.org/drawingml/2006/main" xmlns:r="http://schemas.openxmlformats.org/officeDocument/2006/relationships" xmlns:p="http://schemas.openxmlformats.org/presentationml/2006/main">
+  <p:cSld name="Slide 39">
     <p:spTree>
       <p:nvGrpSpPr>
         <p:cNvPr id="1" name=""/>

</xml_diff>

<commit_message>
Regenera el estudio de mercado con la nota de mapas corregida
Co-Authored-By: Claude Opus 5.5 <noreply@anthropic.com>
Claude-Session: https://claude.ai/code/session_012axCVDM5kAgj1VFnxhpsuM
</commit_message>
<xml_diff>
--- a/propuesta-clt/CLT_Market_Study_Mexico_Latam_EN.pptx
+++ b/propuesta-clt/CLT_Market_Study_Mexico_Latam_EN.pptx
@@ -145,20 +145,20 @@
   <p:extLst>
     <p:ext uri="{521415D9-36F7-43E2-AB2F-B90AF26B5E84}">
       <p14:sectionLst xmlns:p14="http://schemas.microsoft.com/office/powerpoint/2010/main">
-        <p14:section name="Opening" id="{d491546d-b0fa-babb-47ef-a81b1d32190d}">
+        <p14:section name="Opening" id="{68df490d-cd89-bf93-77c1-eaec21dd1146}">
           <p14:sldIdLst>
             <p14:sldId id="256"/>
             <p14:sldId id="257"/>
             <p14:sldId id="258"/>
           </p14:sldIdLst>
         </p14:section>
-        <p14:section name="Scope and methodology" id="{1aeac795-6aaa-1a36-0f61-81bcca3744dd}">
+        <p14:section name="Scope and methodology" id="{cd251756-5cf2-5260-c530-f5bc6779a643}">
           <p14:sldIdLst>
             <p14:sldId id="259"/>
             <p14:sldId id="260"/>
           </p14:sldIdLst>
         </p14:section>
-        <p14:section name="The manufacturer: CLT" id="{2f725a22-de04-c718-efcd-02103b0c3e1b}">
+        <p14:section name="The manufacturer: CLT" id="{965f8dfc-eeaf-8ded-0912-dfaa80c9d34c}">
           <p14:sldIdLst>
             <p14:sldId id="261"/>
             <p14:sldId id="262"/>
@@ -170,7 +170,7 @@
             <p14:sldId id="268"/>
           </p14:sldIdLst>
         </p14:section>
-        <p14:section name="Mexican market" id="{a590c268-d971-b815-cb77-aa4507ff8c7c}">
+        <p14:section name="Mexican market" id="{57b01f0e-cecc-2640-dcd3-870177a9e8c2}">
           <p14:sldIdLst>
             <p14:sldId id="269"/>
             <p14:sldId id="270"/>
@@ -180,14 +180,14 @@
             <p14:sldId id="274"/>
           </p14:sldIdLst>
         </p14:section>
-        <p14:section name="Priority accounts" id="{d8ea4643-2865-00be-c411-e423f78623b2}">
+        <p14:section name="Priority accounts" id="{929fbffc-4283-3519-2e12-40b28b8fa38d}">
           <p14:sldIdLst>
             <p14:sldId id="275"/>
             <p14:sldId id="276"/>
             <p14:sldId id="277"/>
           </p14:sldIdLst>
         </p14:section>
-        <p14:section name="Competition" id="{eb9d7040-1373-fb08-15f7-9129769f8cd7}">
+        <p14:section name="Competition" id="{2cb86a0d-430d-0340-1fe4-296a191864eb}">
           <p14:sldIdLst>
             <p14:sldId id="278"/>
             <p14:sldId id="279"/>
@@ -196,13 +196,13 @@
             <p14:sldId id="282"/>
           </p14:sldIdLst>
         </p14:section>
-        <p14:section name="Trade" id="{1ddbb390-05ff-dd3b-9e77-76a2be24c2ae}">
+        <p14:section name="Trade" id="{b590f099-b12c-5eb1-9cd0-4174504c030e}">
           <p14:sldIdLst>
             <p14:sldId id="283"/>
             <p14:sldId id="284"/>
           </p14:sldIdLst>
         </p14:section>
-        <p14:section name="Latin America and the U.S." id="{0f54ed07-18ad-7089-23eb-ee40c8147dd0}">
+        <p14:section name="Latin America and the U.S." id="{1f737d14-0bb8-c9ec-9ccf-94a47b0aa39c}">
           <p14:sldIdLst>
             <p14:sldId id="285"/>
             <p14:sldId id="286"/>
@@ -212,7 +212,7 @@
             <p14:sldId id="290"/>
           </p14:sldIdLst>
         </p14:section>
-        <p14:section name="Conclusions" id="{c14d7c04-a31f-8866-c1bf-a32f98382a1f}">
+        <p14:section name="Conclusions" id="{aae3af2e-b892-f2eb-8c27-ac3a6be02a9f}">
           <p14:sldIdLst>
             <p14:sldId id="291"/>
             <p14:sldId id="292"/>
@@ -28089,7 +28089,7 @@
                   <a:schemeClr val="accent5"/>
                 </a:solidFill>
               </a:rPr>
-              <a:t>Gold star: 80/20 account in Mexico or priority A elsewhere in LATAM. Numbered account list in mapas/ and in the prospects workbook.</a:t>
+              <a:t>Gold star: 80/20 account in Mexico or priority A elsewhere in LATAM. Numbered account list in the Mapas sheet of the marketing plan workbook.</a:t>
             </a:r>
             <a:endParaRPr lang="en-US" sz="1000" dirty="0"/>
           </a:p>
@@ -28260,7 +28260,7 @@
                   <a:schemeClr val="accent5"/>
                 </a:solidFill>
               </a:rPr>
-              <a:t>Gold star: 80/20 account in Mexico or priority A elsewhere in LATAM. Numbered account list in mapas/ and in the prospects workbook.</a:t>
+              <a:t>Gold star: 80/20 account in Mexico or priority A elsewhere in LATAM. Numbered account list in the Mapas sheet of the marketing plan workbook.</a:t>
             </a:r>
             <a:endParaRPr lang="en-US" sz="1000" dirty="0"/>
           </a:p>

</xml_diff>

<commit_message>
Quita el pie de página de texto en todas las presentaciones
Co-Authored-By: Claude Opus 5.5 <noreply@anthropic.com>
Claude-Session: https://claude.ai/code/session_012axCVDM5kAgj1VFnxhpsuM
</commit_message>
<xml_diff>
--- a/propuesta-clt/CLT_Market_Study_Mexico_Latam_EN.pptx
+++ b/propuesta-clt/CLT_Market_Study_Mexico_Latam_EN.pptx
@@ -145,20 +145,20 @@
   <p:extLst>
     <p:ext uri="{521415D9-36F7-43E2-AB2F-B90AF26B5E84}">
       <p14:sectionLst xmlns:p14="http://schemas.microsoft.com/office/powerpoint/2010/main">
-        <p14:section name="Opening" id="{68df490d-cd89-bf93-77c1-eaec21dd1146}">
+        <p14:section name="Opening" id="{8d316bc7-9e7c-a116-97d6-d280c3a9d2c3}">
           <p14:sldIdLst>
             <p14:sldId id="256"/>
             <p14:sldId id="257"/>
             <p14:sldId id="258"/>
           </p14:sldIdLst>
         </p14:section>
-        <p14:section name="Scope and methodology" id="{cd251756-5cf2-5260-c530-f5bc6779a643}">
+        <p14:section name="Scope and methodology" id="{7a59154c-cfeb-b909-ef18-7375eedee4c9}">
           <p14:sldIdLst>
             <p14:sldId id="259"/>
             <p14:sldId id="260"/>
           </p14:sldIdLst>
         </p14:section>
-        <p14:section name="The manufacturer: CLT" id="{965f8dfc-eeaf-8ded-0912-dfaa80c9d34c}">
+        <p14:section name="The manufacturer: CLT" id="{ef0364dc-662e-148f-bbbf-a208ec03a6d9}">
           <p14:sldIdLst>
             <p14:sldId id="261"/>
             <p14:sldId id="262"/>
@@ -170,7 +170,7 @@
             <p14:sldId id="268"/>
           </p14:sldIdLst>
         </p14:section>
-        <p14:section name="Mexican market" id="{57b01f0e-cecc-2640-dcd3-870177a9e8c2}">
+        <p14:section name="Mexican market" id="{902ff84e-66fb-c065-2ad4-e2dcc8b8f465}">
           <p14:sldIdLst>
             <p14:sldId id="269"/>
             <p14:sldId id="270"/>
@@ -180,14 +180,14 @@
             <p14:sldId id="274"/>
           </p14:sldIdLst>
         </p14:section>
-        <p14:section name="Priority accounts" id="{929fbffc-4283-3519-2e12-40b28b8fa38d}">
+        <p14:section name="Priority accounts" id="{beed4a04-004b-9022-af96-109c928693e9}">
           <p14:sldIdLst>
             <p14:sldId id="275"/>
             <p14:sldId id="276"/>
             <p14:sldId id="277"/>
           </p14:sldIdLst>
         </p14:section>
-        <p14:section name="Competition" id="{2cb86a0d-430d-0340-1fe4-296a191864eb}">
+        <p14:section name="Competition" id="{412cb622-6fe0-ff2b-30c5-7499b6eae8e0}">
           <p14:sldIdLst>
             <p14:sldId id="278"/>
             <p14:sldId id="279"/>
@@ -196,13 +196,13 @@
             <p14:sldId id="282"/>
           </p14:sldIdLst>
         </p14:section>
-        <p14:section name="Trade" id="{b590f099-b12c-5eb1-9cd0-4174504c030e}">
+        <p14:section name="Trade" id="{378c0206-92f9-187e-f5db-81a41e6930b5}">
           <p14:sldIdLst>
             <p14:sldId id="283"/>
             <p14:sldId id="284"/>
           </p14:sldIdLst>
         </p14:section>
-        <p14:section name="Latin America and the U.S." id="{1f737d14-0bb8-c9ec-9ccf-94a47b0aa39c}">
+        <p14:section name="Latin America and the U.S." id="{e080f654-cc52-3578-b8e7-d2f22e18b3d6}">
           <p14:sldIdLst>
             <p14:sldId id="285"/>
             <p14:sldId id="286"/>
@@ -212,7 +212,7 @@
             <p14:sldId id="290"/>
           </p14:sldIdLst>
         </p14:section>
-        <p14:section name="Conclusions" id="{aae3af2e-b892-f2eb-8c27-ac3a6be02a9f}">
+        <p14:section name="Conclusions" id="{97bb4791-4a1c-a54d-30bc-f453248c7ea1}">
           <p14:sldIdLst>
             <p14:sldId id="291"/>
             <p14:sldId id="292"/>
@@ -5847,42 +5847,6 @@
       </p:sp>
       <p:sp>
         <p:nvSpPr>
-          <p:cNvPr id="3" name="Text 0"/>
-          <p:cNvSpPr/>
-          <p:nvPr/>
-        </p:nvSpPr>
-        <p:spPr>
-          <a:xfrm>
-            <a:off x="457200" y="4800600"/>
-            <a:ext cx="6858000" cy="228600"/>
-          </a:xfrm>
-          <a:prstGeom prst="rect">
-            <a:avLst/>
-          </a:prstGeom>
-          <a:noFill/>
-          <a:ln/>
-        </p:spPr>
-        <p:txBody>
-          <a:bodyPr wrap="square" rtlCol="0" anchor="ctr"/>
-          <a:lstStyle/>
-          <a:p>
-            <a:pPr indent="0" marL="0">
-              <a:buNone/>
-            </a:pPr>
-            <a:r>
-              <a:rPr lang="en-US" sz="900" dirty="0">
-                <a:solidFill>
-                  <a:srgbClr val="7A8299"/>
-                </a:solidFill>
-              </a:rPr>
-              <a:t>CLT market study — TID · VSP · CEB — Confidential</a:t>
-            </a:r>
-            <a:endParaRPr lang="en-US" sz="900" dirty="0"/>
-          </a:p>
-        </p:txBody>
-      </p:sp>
-      <p:sp>
-        <p:nvSpPr>
           <p:cNvPr id="25" name="Slide Number Placeholder 0"/>
           <p:cNvSpPr>
             <a:spLocks noGrp="1"/>

</xml_diff>

<commit_message>
Agrega 16 prospectos de Brasil (Nordeste, RJ, SP, MG, PR, GO) y regenera Excel, estudio, mapas y plan
Co-Authored-By: Claude Opus 5.5 <noreply@anthropic.com>
Claude-Session: https://claude.ai/code/session_012axCVDM5kAgj1VFnxhpsuM
</commit_message>
<xml_diff>
--- a/propuesta-clt/CLT_Market_Study_Mexico_Latam_EN.pptx
+++ b/propuesta-clt/CLT_Market_Study_Mexico_Latam_EN.pptx
@@ -145,20 +145,20 @@
   <p:extLst>
     <p:ext uri="{521415D9-36F7-43E2-AB2F-B90AF26B5E84}">
       <p14:sectionLst xmlns:p14="http://schemas.microsoft.com/office/powerpoint/2010/main">
-        <p14:section name="Opening" id="{8d316bc7-9e7c-a116-97d6-d280c3a9d2c3}">
+        <p14:section name="Opening" id="{a7bd01de-fc71-5069-4dcf-2d5992e60a1e}">
           <p14:sldIdLst>
             <p14:sldId id="256"/>
             <p14:sldId id="257"/>
             <p14:sldId id="258"/>
           </p14:sldIdLst>
         </p14:section>
-        <p14:section name="Scope and methodology" id="{7a59154c-cfeb-b909-ef18-7375eedee4c9}">
+        <p14:section name="Scope and methodology" id="{a55c7a6f-aa36-55d1-9afa-7cc3da58a64f}">
           <p14:sldIdLst>
             <p14:sldId id="259"/>
             <p14:sldId id="260"/>
           </p14:sldIdLst>
         </p14:section>
-        <p14:section name="The manufacturer: CLT" id="{ef0364dc-662e-148f-bbbf-a208ec03a6d9}">
+        <p14:section name="The manufacturer: CLT" id="{c2659e38-bbac-47ea-334f-61edd938e99f}">
           <p14:sldIdLst>
             <p14:sldId id="261"/>
             <p14:sldId id="262"/>
@@ -170,7 +170,7 @@
             <p14:sldId id="268"/>
           </p14:sldIdLst>
         </p14:section>
-        <p14:section name="Mexican market" id="{902ff84e-66fb-c065-2ad4-e2dcc8b8f465}">
+        <p14:section name="Mexican market" id="{01e133db-fa7d-0b7f-3d9f-ff38cf8a7711}">
           <p14:sldIdLst>
             <p14:sldId id="269"/>
             <p14:sldId id="270"/>
@@ -180,14 +180,14 @@
             <p14:sldId id="274"/>
           </p14:sldIdLst>
         </p14:section>
-        <p14:section name="Priority accounts" id="{beed4a04-004b-9022-af96-109c928693e9}">
+        <p14:section name="Priority accounts" id="{ac5b4f2f-adce-0a50-9590-72a0af4f60fd}">
           <p14:sldIdLst>
             <p14:sldId id="275"/>
             <p14:sldId id="276"/>
             <p14:sldId id="277"/>
           </p14:sldIdLst>
         </p14:section>
-        <p14:section name="Competition" id="{412cb622-6fe0-ff2b-30c5-7499b6eae8e0}">
+        <p14:section name="Competition" id="{0682d4cd-e044-6bf9-9d9f-8a62c9b1b791}">
           <p14:sldIdLst>
             <p14:sldId id="278"/>
             <p14:sldId id="279"/>
@@ -196,13 +196,13 @@
             <p14:sldId id="282"/>
           </p14:sldIdLst>
         </p14:section>
-        <p14:section name="Trade" id="{378c0206-92f9-187e-f5db-81a41e6930b5}">
+        <p14:section name="Trade" id="{6140a33d-9c69-0bf7-8915-5e8c47763544}">
           <p14:sldIdLst>
             <p14:sldId id="283"/>
             <p14:sldId id="284"/>
           </p14:sldIdLst>
         </p14:section>
-        <p14:section name="Latin America and the U.S." id="{e080f654-cc52-3578-b8e7-d2f22e18b3d6}">
+        <p14:section name="Latin America and the U.S." id="{84f90905-28f3-5c6c-d2f3-6dd3fc59f746}">
           <p14:sldIdLst>
             <p14:sldId id="285"/>
             <p14:sldId id="286"/>
@@ -212,7 +212,7 @@
             <p14:sldId id="290"/>
           </p14:sldIdLst>
         </p14:section>
-        <p14:section name="Conclusions" id="{97bb4791-4a1c-a54d-30bc-f453248c7ea1}">
+        <p14:section name="Conclusions" id="{f4b3607c-aaf9-b25d-da2b-71682020ad6e}">
           <p14:sldIdLst>
             <p14:sldId id="291"/>
             <p14:sldId id="292"/>
@@ -1456,7 +1456,7 @@
                   <c:v>6</c:v>
                 </c:pt>
                 <c:pt idx="2">
-                  <c:v>25</c:v>
+                  <c:v>30</c:v>
                 </c:pt>
               </c:numCache>
             </c:numRef>
@@ -1539,7 +1539,7 @@
                   <c:v>16</c:v>
                 </c:pt>
                 <c:pt idx="2">
-                  <c:v>40</c:v>
+                  <c:v>55</c:v>
                 </c:pt>
               </c:numCache>
             </c:numRef>
@@ -1622,7 +1622,7 @@
                   <c:v>11</c:v>
                 </c:pt>
                 <c:pt idx="2">
-                  <c:v>38</c:v>
+                  <c:v>55</c:v>
                 </c:pt>
               </c:numCache>
             </c:numRef>
@@ -12194,7 +12194,7 @@
                   <a:srgbClr val="B38600"/>
                 </a:solidFill>
               </a:rPr>
-              <a:t>180</a:t>
+              <a:t>217</a:t>
             </a:r>
             <a:endParaRPr lang="en-US" sz="3000" dirty="0"/>
           </a:p>
@@ -25067,7 +25067,7 @@
                   <a:schemeClr val="tx1"/>
                 </a:solidFill>
               </a:rPr>
-              <a:t>Latin America: 180 prospects in 16 countries</a:t>
+              <a:t>Latin America: 217 prospects in 16 countries</a:t>
             </a:r>
             <a:endParaRPr lang="en-US" sz="2600" dirty="0"/>
           </a:p>
@@ -25119,7 +25119,7 @@
                   <a:schemeClr val="accent1"/>
                 </a:solidFill>
               </a:rPr>
-              <a:t>42</a:t>
+              <a:t>47</a:t>
             </a:r>
             <a:endParaRPr lang="en-US" sz="3000" dirty="0"/>
           </a:p>
@@ -25263,7 +25263,7 @@
                   <a:schemeClr val="accent1"/>
                 </a:solidFill>
               </a:rPr>
-              <a:t>41 + 35</a:t>
+              <a:t>62 + 51</a:t>
             </a:r>
             <a:endParaRPr lang="en-US" sz="3000" dirty="0"/>
           </a:p>

</xml_diff>